<commit_message>
docs: perfect PPT typography, layout alignment, and slide previews
</commit_message>
<xml_diff>
--- a/DeploySafe_Final_Presentation_V2.pptx
+++ b/DeploySafe_Final_Presentation_V2.pptx
@@ -3195,8 +3195,8 @@
         </p:nvSpPr>
         <p:spPr>
           <a:xfrm>
-            <a:off x="1097280" y="1097280"/>
-            <a:ext cx="9966960" cy="3108960"/>
+            <a:off x="1097280" y="1051560"/>
+            <a:ext cx="9966960" cy="3200400"/>
           </a:xfrm>
           <a:prstGeom prst="rect">
             <a:avLst/>
@@ -3204,14 +3204,14 @@
           <a:noFill/>
         </p:spPr>
         <p:txBody>
-          <a:bodyPr wrap="square">
+          <a:bodyPr wrap="square" lIns="0" rIns="0" tIns="0" bIns="0">
             <a:spAutoFit/>
           </a:bodyPr>
           <a:lstStyle/>
           <a:p>
             <a:pPr algn="l">
               <a:spcAft>
-                <a:spcPts val="1200"/>
+                <a:spcPts val="1000"/>
               </a:spcAft>
             </a:pPr>
             <a:r>
@@ -3227,11 +3227,11 @@
           <a:p>
             <a:pPr algn="l">
               <a:spcAft>
-                <a:spcPts val="1000"/>
-              </a:spcAft>
-            </a:pPr>
-            <a:r>
-              <a:rPr sz="3000" b="1">
+                <a:spcPts val="800"/>
+              </a:spcAft>
+            </a:pPr>
+            <a:r>
+              <a:rPr sz="2800" b="1">
                 <a:solidFill>
                   <a:srgbClr val="0F172A"/>
                 </a:solidFill>
@@ -3243,11 +3243,11 @@
           <a:p>
             <a:pPr algn="l">
               <a:spcAft>
-                <a:spcPts val="2200"/>
-              </a:spcAft>
-            </a:pPr>
-            <a:r>
-              <a:rPr sz="1500" b="0">
+                <a:spcPts val="1800"/>
+              </a:spcAft>
+            </a:pPr>
+            <a:r>
+              <a:rPr sz="1400" b="0">
                 <a:solidFill>
                   <a:srgbClr val="475569"/>
                 </a:solidFill>
@@ -3327,8 +3327,8 @@
         </p:nvSpPr>
         <p:spPr>
           <a:xfrm>
-            <a:off x="914400" y="4983480"/>
-            <a:ext cx="3063240" cy="1097280"/>
+            <a:off x="960120" y="4983480"/>
+            <a:ext cx="2971800" cy="1097280"/>
           </a:xfrm>
           <a:prstGeom prst="rect">
             <a:avLst/>
@@ -3336,7 +3336,7 @@
           <a:noFill/>
         </p:spPr>
         <p:txBody>
-          <a:bodyPr wrap="none">
+          <a:bodyPr wrap="square" lIns="0" rIns="0" tIns="0" bIns="0">
             <a:spAutoFit/>
           </a:bodyPr>
           <a:lstStyle/>
@@ -3443,8 +3443,8 @@
         </p:nvSpPr>
         <p:spPr>
           <a:xfrm>
-            <a:off x="4562856" y="4983480"/>
-            <a:ext cx="3063240" cy="1097280"/>
+            <a:off x="4608576" y="4983480"/>
+            <a:ext cx="2971800" cy="1097280"/>
           </a:xfrm>
           <a:prstGeom prst="rect">
             <a:avLst/>
@@ -3452,7 +3452,7 @@
           <a:noFill/>
         </p:spPr>
         <p:txBody>
-          <a:bodyPr wrap="none">
+          <a:bodyPr wrap="square" lIns="0" rIns="0" tIns="0" bIns="0">
             <a:spAutoFit/>
           </a:bodyPr>
           <a:lstStyle/>
@@ -3501,7 +3501,7 @@
                 </a:solidFill>
                 <a:latin typeface="Segoe UI"/>
               </a:rPr>
-              <a:t>FastAPI Backend + React/Vite UI</a:t>
+              <a:t>FastAPI Backend + React 18 UI</a:t>
             </a:r>
           </a:p>
         </p:txBody>
@@ -3559,8 +3559,8 @@
         </p:nvSpPr>
         <p:spPr>
           <a:xfrm>
-            <a:off x="8211312" y="4983480"/>
-            <a:ext cx="3063240" cy="1097280"/>
+            <a:off x="8257032" y="4983480"/>
+            <a:ext cx="2971800" cy="1097280"/>
           </a:xfrm>
           <a:prstGeom prst="rect">
             <a:avLst/>
@@ -3568,7 +3568,7 @@
           <a:noFill/>
         </p:spPr>
         <p:txBody>
-          <a:bodyPr wrap="none">
+          <a:bodyPr wrap="square" lIns="0" rIns="0" tIns="0" bIns="0">
             <a:spAutoFit/>
           </a:bodyPr>
           <a:lstStyle/>
@@ -3752,7 +3752,7 @@
           <a:noFill/>
         </p:spPr>
         <p:txBody>
-          <a:bodyPr wrap="none">
+          <a:bodyPr wrap="square" lIns="0" rIns="0" tIns="0" bIns="0">
             <a:spAutoFit/>
           </a:bodyPr>
           <a:lstStyle/>
@@ -3779,7 +3779,7 @@
         <p:spPr>
           <a:xfrm>
             <a:off x="731520" y="777240"/>
-            <a:ext cx="10698480" cy="640080"/>
+            <a:ext cx="10698480" cy="731520"/>
           </a:xfrm>
           <a:prstGeom prst="rect">
             <a:avLst/>
@@ -3787,14 +3787,14 @@
           <a:noFill/>
         </p:spPr>
         <p:txBody>
-          <a:bodyPr wrap="square" lIns="0" tIns="0" rIns="0" bIns="0">
+          <a:bodyPr wrap="square" lIns="0" rIns="0" tIns="0" bIns="0">
             <a:spAutoFit/>
           </a:bodyPr>
           <a:lstStyle/>
           <a:p>
             <a:pPr algn="l">
               <a:spcAft>
-                <a:spcPts val="200"/>
+                <a:spcPts val="300"/>
               </a:spcAft>
             </a:pPr>
             <a:r>
@@ -3834,7 +3834,7 @@
         <p:spPr>
           <a:xfrm>
             <a:off x="731520" y="1783080"/>
-            <a:ext cx="2523744" cy="1463040"/>
+            <a:ext cx="2523744" cy="1371600"/>
           </a:xfrm>
           <a:prstGeom prst="roundRect">
             <a:avLst/>
@@ -3878,8 +3878,8 @@
         </p:nvSpPr>
         <p:spPr>
           <a:xfrm>
-            <a:off x="914400" y="1965960"/>
-            <a:ext cx="2157984" cy="1097280"/>
+            <a:off x="868680" y="1920240"/>
+            <a:ext cx="2249424" cy="1097280"/>
           </a:xfrm>
           <a:prstGeom prst="rect">
             <a:avLst/>
@@ -3887,7 +3887,7 @@
           <a:noFill/>
         </p:spPr>
         <p:txBody>
-          <a:bodyPr wrap="none">
+          <a:bodyPr wrap="square" lIns="0" rIns="0" tIns="0" bIns="0">
             <a:spAutoFit/>
           </a:bodyPr>
           <a:lstStyle/>
@@ -3914,7 +3914,7 @@
               </a:spcAft>
             </a:pPr>
             <a:r>
-              <a:rPr sz="2600" b="1">
+              <a:rPr sz="2400" b="1">
                 <a:solidFill>
                   <a:srgbClr val="16A34A"/>
                 </a:solidFill>
@@ -3930,7 +3930,7 @@
               </a:spcAft>
             </a:pPr>
             <a:r>
-              <a:rPr sz="1100" b="0">
+              <a:rPr sz="1000" b="0">
                 <a:solidFill>
                   <a:srgbClr val="475569"/>
                 </a:solidFill>
@@ -3950,7 +3950,7 @@
         <p:spPr>
           <a:xfrm>
             <a:off x="3465575" y="1783080"/>
-            <a:ext cx="2523744" cy="1463040"/>
+            <a:ext cx="2523744" cy="1371600"/>
           </a:xfrm>
           <a:prstGeom prst="roundRect">
             <a:avLst/>
@@ -3994,8 +3994,8 @@
         </p:nvSpPr>
         <p:spPr>
           <a:xfrm>
-            <a:off x="3648456" y="1965960"/>
-            <a:ext cx="2157984" cy="1097280"/>
+            <a:off x="3602735" y="1920240"/>
+            <a:ext cx="2249424" cy="1097280"/>
           </a:xfrm>
           <a:prstGeom prst="rect">
             <a:avLst/>
@@ -4003,7 +4003,7 @@
           <a:noFill/>
         </p:spPr>
         <p:txBody>
-          <a:bodyPr wrap="none">
+          <a:bodyPr wrap="square" lIns="0" rIns="0" tIns="0" bIns="0">
             <a:spAutoFit/>
           </a:bodyPr>
           <a:lstStyle/>
@@ -4030,7 +4030,7 @@
               </a:spcAft>
             </a:pPr>
             <a:r>
-              <a:rPr sz="2600" b="1">
+              <a:rPr sz="2400" b="1">
                 <a:solidFill>
                   <a:srgbClr val="16A34A"/>
                 </a:solidFill>
@@ -4046,7 +4046,7 @@
               </a:spcAft>
             </a:pPr>
             <a:r>
-              <a:rPr sz="1100" b="0">
+              <a:rPr sz="1000" b="0">
                 <a:solidFill>
                   <a:srgbClr val="475569"/>
                 </a:solidFill>
@@ -4066,7 +4066,7 @@
         <p:spPr>
           <a:xfrm>
             <a:off x="6199631" y="1783080"/>
-            <a:ext cx="2523744" cy="1463040"/>
+            <a:ext cx="2523744" cy="1371600"/>
           </a:xfrm>
           <a:prstGeom prst="roundRect">
             <a:avLst/>
@@ -4110,8 +4110,8 @@
         </p:nvSpPr>
         <p:spPr>
           <a:xfrm>
-            <a:off x="6382512" y="1965960"/>
-            <a:ext cx="2157984" cy="1097280"/>
+            <a:off x="6336792" y="1920240"/>
+            <a:ext cx="2249424" cy="1097280"/>
           </a:xfrm>
           <a:prstGeom prst="rect">
             <a:avLst/>
@@ -4119,7 +4119,7 @@
           <a:noFill/>
         </p:spPr>
         <p:txBody>
-          <a:bodyPr wrap="none">
+          <a:bodyPr wrap="square" lIns="0" rIns="0" tIns="0" bIns="0">
             <a:spAutoFit/>
           </a:bodyPr>
           <a:lstStyle/>
@@ -4146,7 +4146,7 @@
               </a:spcAft>
             </a:pPr>
             <a:r>
-              <a:rPr sz="2600" b="1">
+              <a:rPr sz="2400" b="1">
                 <a:solidFill>
                   <a:srgbClr val="2563EB"/>
                 </a:solidFill>
@@ -4162,7 +4162,7 @@
               </a:spcAft>
             </a:pPr>
             <a:r>
-              <a:rPr sz="1100" b="0">
+              <a:rPr sz="1000" b="0">
                 <a:solidFill>
                   <a:srgbClr val="475569"/>
                 </a:solidFill>
@@ -4182,7 +4182,7 @@
         <p:spPr>
           <a:xfrm>
             <a:off x="8933688" y="1783080"/>
-            <a:ext cx="2523744" cy="1463040"/>
+            <a:ext cx="2523744" cy="1371600"/>
           </a:xfrm>
           <a:prstGeom prst="roundRect">
             <a:avLst/>
@@ -4226,8 +4226,8 @@
         </p:nvSpPr>
         <p:spPr>
           <a:xfrm>
-            <a:off x="9116567" y="1965960"/>
-            <a:ext cx="2157984" cy="1097280"/>
+            <a:off x="9070848" y="1920240"/>
+            <a:ext cx="2249424" cy="1097280"/>
           </a:xfrm>
           <a:prstGeom prst="rect">
             <a:avLst/>
@@ -4235,7 +4235,7 @@
           <a:noFill/>
         </p:spPr>
         <p:txBody>
-          <a:bodyPr wrap="none">
+          <a:bodyPr wrap="square" lIns="0" rIns="0" tIns="0" bIns="0">
             <a:spAutoFit/>
           </a:bodyPr>
           <a:lstStyle/>
@@ -4262,7 +4262,7 @@
               </a:spcAft>
             </a:pPr>
             <a:r>
-              <a:rPr sz="2600" b="1">
+              <a:rPr sz="2400" b="1">
                 <a:solidFill>
                   <a:srgbClr val="16A34A"/>
                 </a:solidFill>
@@ -4278,7 +4278,7 @@
               </a:spcAft>
             </a:pPr>
             <a:r>
-              <a:rPr sz="1100" b="0">
+              <a:rPr sz="1000" b="0">
                 <a:solidFill>
                   <a:srgbClr val="475569"/>
                 </a:solidFill>
@@ -4297,8 +4297,8 @@
         </p:nvSpPr>
         <p:spPr>
           <a:xfrm>
-            <a:off x="731520" y="3474720"/>
-            <a:ext cx="10728655" cy="2743200"/>
+            <a:off x="731520" y="3337560"/>
+            <a:ext cx="10728655" cy="2926080"/>
           </a:xfrm>
           <a:prstGeom prst="roundRect">
             <a:avLst/>
@@ -4342,8 +4342,8 @@
         </p:nvSpPr>
         <p:spPr>
           <a:xfrm>
-            <a:off x="1005840" y="3657600"/>
-            <a:ext cx="10149840" cy="2377440"/>
+            <a:off x="960120" y="3474720"/>
+            <a:ext cx="10241280" cy="365760"/>
           </a:xfrm>
           <a:prstGeom prst="rect">
             <a:avLst/>
@@ -4351,18 +4351,18 @@
           <a:noFill/>
         </p:spPr>
         <p:txBody>
-          <a:bodyPr wrap="none">
+          <a:bodyPr wrap="square" lIns="0" rIns="0" tIns="0" bIns="0">
             <a:spAutoFit/>
           </a:bodyPr>
           <a:lstStyle/>
           <a:p>
             <a:pPr algn="l">
               <a:spcAft>
-                <a:spcPts val="800"/>
-              </a:spcAft>
-            </a:pPr>
-            <a:r>
-              <a:rPr sz="1400" b="1">
+                <a:spcPts val="0"/>
+              </a:spcAft>
+            </a:pPr>
+            <a:r>
+              <a:rPr sz="1300" b="1">
                 <a:solidFill>
                   <a:srgbClr val="0F172A"/>
                 </a:solidFill>
@@ -4371,84 +4371,1009 @@
               <a:t>Evaluation Benchmark Breakdown Across Physical Test Repositories</a:t>
             </a:r>
           </a:p>
-          <a:p>
-            <a:pPr algn="l">
-              <a:spcAft>
-                <a:spcPts val="400"/>
-              </a:spcAft>
-            </a:pPr>
-            <a:r>
-              <a:rPr sz="1100" b="0">
+        </p:txBody>
+      </p:sp>
+      <p:sp>
+        <p:nvSpPr>
+          <p:cNvPr id="16" name="Rounded Rectangle 15"/>
+          <p:cNvSpPr/>
+          <p:nvPr/>
+        </p:nvSpPr>
+        <p:spPr>
+          <a:xfrm>
+            <a:off x="960120" y="3886200"/>
+            <a:ext cx="10271455" cy="384048"/>
+          </a:xfrm>
+          <a:prstGeom prst="roundRect">
+            <a:avLst/>
+          </a:prstGeom>
+          <a:solidFill>
+            <a:srgbClr val="FFFFFF"/>
+          </a:solidFill>
+          <a:ln w="12700">
+            <a:solidFill>
+              <a:srgbClr val="E2E8F0"/>
+            </a:solidFill>
+          </a:ln>
+        </p:spPr>
+        <p:style>
+          <a:lnRef idx="1">
+            <a:schemeClr val="accent1"/>
+          </a:lnRef>
+          <a:fillRef idx="3">
+            <a:schemeClr val="accent1"/>
+          </a:fillRef>
+          <a:effectRef idx="2">
+            <a:schemeClr val="accent1"/>
+          </a:effectRef>
+          <a:fontRef idx="minor">
+            <a:schemeClr val="lt1"/>
+          </a:fontRef>
+        </p:style>
+        <p:txBody>
+          <a:bodyPr rtlCol="0" anchor="ctr"/>
+          <a:lstStyle/>
+          <a:p>
+            <a:pPr algn="ctr"/>
+          </a:p>
+        </p:txBody>
+      </p:sp>
+      <p:sp>
+        <p:nvSpPr>
+          <p:cNvPr id="17" name="TextBox 16"/>
+          <p:cNvSpPr txBox="1"/>
+          <p:nvPr/>
+        </p:nvSpPr>
+        <p:spPr>
+          <a:xfrm>
+            <a:off x="1097280" y="3959352"/>
+            <a:ext cx="2926080" cy="274320"/>
+          </a:xfrm>
+          <a:prstGeom prst="rect">
+            <a:avLst/>
+          </a:prstGeom>
+          <a:noFill/>
+        </p:spPr>
+        <p:txBody>
+          <a:bodyPr wrap="square" lIns="0" rIns="0" tIns="0" bIns="0">
+            <a:spAutoFit/>
+          </a:bodyPr>
+          <a:lstStyle/>
+          <a:p>
+            <a:pPr algn="l">
+              <a:spcAft>
+                <a:spcPts val="0"/>
+              </a:spcAft>
+            </a:pPr>
+            <a:r>
+              <a:rPr sz="1000" b="1">
+                <a:solidFill>
+                  <a:srgbClr val="0F172A"/>
+                </a:solidFill>
+                <a:latin typeface="Segoe UI"/>
+              </a:rPr>
+              <a:t>EVAL-01: Config Hazard</a:t>
+            </a:r>
+          </a:p>
+        </p:txBody>
+      </p:sp>
+      <p:sp>
+        <p:nvSpPr>
+          <p:cNvPr id="18" name="TextBox 17"/>
+          <p:cNvSpPr txBox="1"/>
+          <p:nvPr/>
+        </p:nvSpPr>
+        <p:spPr>
+          <a:xfrm>
+            <a:off x="4023360" y="3959352"/>
+            <a:ext cx="3474720" cy="274320"/>
+          </a:xfrm>
+          <a:prstGeom prst="rect">
+            <a:avLst/>
+          </a:prstGeom>
+          <a:noFill/>
+        </p:spPr>
+        <p:txBody>
+          <a:bodyPr wrap="square" lIns="0" rIns="0" tIns="0" bIns="0">
+            <a:spAutoFit/>
+          </a:bodyPr>
+          <a:lstStyle/>
+          <a:p>
+            <a:pPr algn="l">
+              <a:spcAft>
+                <a:spcPts val="0"/>
+              </a:spcAft>
+            </a:pPr>
+            <a:r>
+              <a:rPr sz="1000" b="0">
                 <a:solidFill>
                   <a:srgbClr val="475569"/>
                 </a:solidFill>
                 <a:latin typeface="Segoe UI"/>
               </a:rPr>
-              <a:t>• EVAL-01: Config Risk: Unpinned container tag &amp; production debug flag -&gt; Expected: CRITICAL / HIGH -&gt; Status: PASS (Detected immediately)</a:t>
-            </a:r>
-          </a:p>
-          <a:p>
-            <a:pPr algn="l">
-              <a:spcAft>
-                <a:spcPts val="400"/>
-              </a:spcAft>
-            </a:pPr>
-            <a:r>
-              <a:rPr sz="1100" b="0">
+              <a:t>Unpinned Docker tag &amp; debug mode</a:t>
+            </a:r>
+          </a:p>
+        </p:txBody>
+      </p:sp>
+      <p:sp>
+        <p:nvSpPr>
+          <p:cNvPr id="19" name="TextBox 18"/>
+          <p:cNvSpPr txBox="1"/>
+          <p:nvPr/>
+        </p:nvSpPr>
+        <p:spPr>
+          <a:xfrm>
+            <a:off x="7498079" y="3959352"/>
+            <a:ext cx="1645920" cy="274320"/>
+          </a:xfrm>
+          <a:prstGeom prst="rect">
+            <a:avLst/>
+          </a:prstGeom>
+          <a:noFill/>
+        </p:spPr>
+        <p:txBody>
+          <a:bodyPr wrap="square" lIns="0" rIns="0" tIns="0" bIns="0">
+            <a:spAutoFit/>
+          </a:bodyPr>
+          <a:lstStyle/>
+          <a:p>
+            <a:pPr algn="l">
+              <a:spcAft>
+                <a:spcPts val="0"/>
+              </a:spcAft>
+            </a:pPr>
+            <a:r>
+              <a:rPr sz="900" b="1">
+                <a:solidFill>
+                  <a:srgbClr val="2563EB"/>
+                </a:solidFill>
+                <a:latin typeface="Segoe UI"/>
+              </a:rPr>
+              <a:t>CRITICAL / HIGH</a:t>
+            </a:r>
+          </a:p>
+        </p:txBody>
+      </p:sp>
+      <p:sp>
+        <p:nvSpPr>
+          <p:cNvPr id="20" name="TextBox 19"/>
+          <p:cNvSpPr txBox="1"/>
+          <p:nvPr/>
+        </p:nvSpPr>
+        <p:spPr>
+          <a:xfrm>
+            <a:off x="9144000" y="3959352"/>
+            <a:ext cx="2011680" cy="274320"/>
+          </a:xfrm>
+          <a:prstGeom prst="rect">
+            <a:avLst/>
+          </a:prstGeom>
+          <a:noFill/>
+        </p:spPr>
+        <p:txBody>
+          <a:bodyPr wrap="square" lIns="0" rIns="0" tIns="0" bIns="0">
+            <a:spAutoFit/>
+          </a:bodyPr>
+          <a:lstStyle/>
+          <a:p>
+            <a:pPr algn="l">
+              <a:spcAft>
+                <a:spcPts val="0"/>
+              </a:spcAft>
+            </a:pPr>
+            <a:r>
+              <a:rPr sz="900" b="1">
+                <a:solidFill>
+                  <a:srgbClr val="16A34A"/>
+                </a:solidFill>
+                <a:latin typeface="Segoe UI"/>
+              </a:rPr>
+              <a:t>PASS (100% Detected)</a:t>
+            </a:r>
+          </a:p>
+        </p:txBody>
+      </p:sp>
+      <p:sp>
+        <p:nvSpPr>
+          <p:cNvPr id="21" name="Rounded Rectangle 20"/>
+          <p:cNvSpPr/>
+          <p:nvPr/>
+        </p:nvSpPr>
+        <p:spPr>
+          <a:xfrm>
+            <a:off x="960120" y="4325112"/>
+            <a:ext cx="10271455" cy="384048"/>
+          </a:xfrm>
+          <a:prstGeom prst="roundRect">
+            <a:avLst/>
+          </a:prstGeom>
+          <a:solidFill>
+            <a:srgbClr val="F1F5F9"/>
+          </a:solidFill>
+          <a:ln w="12700">
+            <a:solidFill>
+              <a:srgbClr val="E2E8F0"/>
+            </a:solidFill>
+          </a:ln>
+        </p:spPr>
+        <p:style>
+          <a:lnRef idx="1">
+            <a:schemeClr val="accent1"/>
+          </a:lnRef>
+          <a:fillRef idx="3">
+            <a:schemeClr val="accent1"/>
+          </a:fillRef>
+          <a:effectRef idx="2">
+            <a:schemeClr val="accent1"/>
+          </a:effectRef>
+          <a:fontRef idx="minor">
+            <a:schemeClr val="lt1"/>
+          </a:fontRef>
+        </p:style>
+        <p:txBody>
+          <a:bodyPr rtlCol="0" anchor="ctr"/>
+          <a:lstStyle/>
+          <a:p>
+            <a:pPr algn="ctr"/>
+          </a:p>
+        </p:txBody>
+      </p:sp>
+      <p:sp>
+        <p:nvSpPr>
+          <p:cNvPr id="22" name="TextBox 21"/>
+          <p:cNvSpPr txBox="1"/>
+          <p:nvPr/>
+        </p:nvSpPr>
+        <p:spPr>
+          <a:xfrm>
+            <a:off x="1097280" y="4398264"/>
+            <a:ext cx="2926080" cy="274320"/>
+          </a:xfrm>
+          <a:prstGeom prst="rect">
+            <a:avLst/>
+          </a:prstGeom>
+          <a:noFill/>
+        </p:spPr>
+        <p:txBody>
+          <a:bodyPr wrap="square" lIns="0" rIns="0" tIns="0" bIns="0">
+            <a:spAutoFit/>
+          </a:bodyPr>
+          <a:lstStyle/>
+          <a:p>
+            <a:pPr algn="l">
+              <a:spcAft>
+                <a:spcPts val="0"/>
+              </a:spcAft>
+            </a:pPr>
+            <a:r>
+              <a:rPr sz="1000" b="1">
+                <a:solidFill>
+                  <a:srgbClr val="0F172A"/>
+                </a:solidFill>
+                <a:latin typeface="Segoe UI"/>
+              </a:rPr>
+              <a:t>EVAL-02: Secret Exposure</a:t>
+            </a:r>
+          </a:p>
+        </p:txBody>
+      </p:sp>
+      <p:sp>
+        <p:nvSpPr>
+          <p:cNvPr id="23" name="TextBox 22"/>
+          <p:cNvSpPr txBox="1"/>
+          <p:nvPr/>
+        </p:nvSpPr>
+        <p:spPr>
+          <a:xfrm>
+            <a:off x="4023360" y="4398264"/>
+            <a:ext cx="3474720" cy="274320"/>
+          </a:xfrm>
+          <a:prstGeom prst="rect">
+            <a:avLst/>
+          </a:prstGeom>
+          <a:noFill/>
+        </p:spPr>
+        <p:txBody>
+          <a:bodyPr wrap="square" lIns="0" rIns="0" tIns="0" bIns="0">
+            <a:spAutoFit/>
+          </a:bodyPr>
+          <a:lstStyle/>
+          <a:p>
+            <a:pPr algn="l">
+              <a:spcAft>
+                <a:spcPts val="0"/>
+              </a:spcAft>
+            </a:pPr>
+            <a:r>
+              <a:rPr sz="1000" b="0">
                 <a:solidFill>
                   <a:srgbClr val="475569"/>
                 </a:solidFill>
                 <a:latin typeface="Segoe UI"/>
               </a:rPr>
-              <a:t>• EVAL-02: Secret Leak: Plaintext AWS &amp; PostgreSQL credentials exposed -&gt; Expected: CRITICAL -&gt; Status: PASS (Pre-scrubbed &amp; flagged)</a:t>
-            </a:r>
-          </a:p>
-          <a:p>
-            <a:pPr algn="l">
-              <a:spcAft>
-                <a:spcPts val="400"/>
-              </a:spcAft>
-            </a:pPr>
-            <a:r>
-              <a:rPr sz="1100" b="0">
+              <a:t>AWS credentials &amp; database password leak</a:t>
+            </a:r>
+          </a:p>
+        </p:txBody>
+      </p:sp>
+      <p:sp>
+        <p:nvSpPr>
+          <p:cNvPr id="24" name="TextBox 23"/>
+          <p:cNvSpPr txBox="1"/>
+          <p:nvPr/>
+        </p:nvSpPr>
+        <p:spPr>
+          <a:xfrm>
+            <a:off x="7498079" y="4398264"/>
+            <a:ext cx="1645920" cy="274320"/>
+          </a:xfrm>
+          <a:prstGeom prst="rect">
+            <a:avLst/>
+          </a:prstGeom>
+          <a:noFill/>
+        </p:spPr>
+        <p:txBody>
+          <a:bodyPr wrap="square" lIns="0" rIns="0" tIns="0" bIns="0">
+            <a:spAutoFit/>
+          </a:bodyPr>
+          <a:lstStyle/>
+          <a:p>
+            <a:pPr algn="l">
+              <a:spcAft>
+                <a:spcPts val="0"/>
+              </a:spcAft>
+            </a:pPr>
+            <a:r>
+              <a:rPr sz="900" b="1">
+                <a:solidFill>
+                  <a:srgbClr val="2563EB"/>
+                </a:solidFill>
+                <a:latin typeface="Segoe UI"/>
+              </a:rPr>
+              <a:t>CRITICAL</a:t>
+            </a:r>
+          </a:p>
+        </p:txBody>
+      </p:sp>
+      <p:sp>
+        <p:nvSpPr>
+          <p:cNvPr id="25" name="TextBox 24"/>
+          <p:cNvSpPr txBox="1"/>
+          <p:nvPr/>
+        </p:nvSpPr>
+        <p:spPr>
+          <a:xfrm>
+            <a:off x="9144000" y="4398264"/>
+            <a:ext cx="2011680" cy="274320"/>
+          </a:xfrm>
+          <a:prstGeom prst="rect">
+            <a:avLst/>
+          </a:prstGeom>
+          <a:noFill/>
+        </p:spPr>
+        <p:txBody>
+          <a:bodyPr wrap="square" lIns="0" rIns="0" tIns="0" bIns="0">
+            <a:spAutoFit/>
+          </a:bodyPr>
+          <a:lstStyle/>
+          <a:p>
+            <a:pPr algn="l">
+              <a:spcAft>
+                <a:spcPts val="0"/>
+              </a:spcAft>
+            </a:pPr>
+            <a:r>
+              <a:rPr sz="900" b="1">
+                <a:solidFill>
+                  <a:srgbClr val="16A34A"/>
+                </a:solidFill>
+                <a:latin typeface="Segoe UI"/>
+              </a:rPr>
+              <a:t>PASS (Scrubbed &amp; Flagged)</a:t>
+            </a:r>
+          </a:p>
+        </p:txBody>
+      </p:sp>
+      <p:sp>
+        <p:nvSpPr>
+          <p:cNvPr id="26" name="Rounded Rectangle 25"/>
+          <p:cNvSpPr/>
+          <p:nvPr/>
+        </p:nvSpPr>
+        <p:spPr>
+          <a:xfrm>
+            <a:off x="960120" y="4764024"/>
+            <a:ext cx="10271455" cy="384048"/>
+          </a:xfrm>
+          <a:prstGeom prst="roundRect">
+            <a:avLst/>
+          </a:prstGeom>
+          <a:solidFill>
+            <a:srgbClr val="FFFFFF"/>
+          </a:solidFill>
+          <a:ln w="12700">
+            <a:solidFill>
+              <a:srgbClr val="E2E8F0"/>
+            </a:solidFill>
+          </a:ln>
+        </p:spPr>
+        <p:style>
+          <a:lnRef idx="1">
+            <a:schemeClr val="accent1"/>
+          </a:lnRef>
+          <a:fillRef idx="3">
+            <a:schemeClr val="accent1"/>
+          </a:fillRef>
+          <a:effectRef idx="2">
+            <a:schemeClr val="accent1"/>
+          </a:effectRef>
+          <a:fontRef idx="minor">
+            <a:schemeClr val="lt1"/>
+          </a:fontRef>
+        </p:style>
+        <p:txBody>
+          <a:bodyPr rtlCol="0" anchor="ctr"/>
+          <a:lstStyle/>
+          <a:p>
+            <a:pPr algn="ctr"/>
+          </a:p>
+        </p:txBody>
+      </p:sp>
+      <p:sp>
+        <p:nvSpPr>
+          <p:cNvPr id="27" name="TextBox 26"/>
+          <p:cNvSpPr txBox="1"/>
+          <p:nvPr/>
+        </p:nvSpPr>
+        <p:spPr>
+          <a:xfrm>
+            <a:off x="1097280" y="4837176"/>
+            <a:ext cx="2926080" cy="274320"/>
+          </a:xfrm>
+          <a:prstGeom prst="rect">
+            <a:avLst/>
+          </a:prstGeom>
+          <a:noFill/>
+        </p:spPr>
+        <p:txBody>
+          <a:bodyPr wrap="square" lIns="0" rIns="0" tIns="0" bIns="0">
+            <a:spAutoFit/>
+          </a:bodyPr>
+          <a:lstStyle/>
+          <a:p>
+            <a:pPr algn="l">
+              <a:spcAft>
+                <a:spcPts val="0"/>
+              </a:spcAft>
+            </a:pPr>
+            <a:r>
+              <a:rPr sz="1000" b="1">
+                <a:solidFill>
+                  <a:srgbClr val="0F172A"/>
+                </a:solidFill>
+                <a:latin typeface="Segoe UI"/>
+              </a:rPr>
+              <a:t>EVAL-03: Dependency CVE</a:t>
+            </a:r>
+          </a:p>
+        </p:txBody>
+      </p:sp>
+      <p:sp>
+        <p:nvSpPr>
+          <p:cNvPr id="28" name="TextBox 27"/>
+          <p:cNvSpPr txBox="1"/>
+          <p:nvPr/>
+        </p:nvSpPr>
+        <p:spPr>
+          <a:xfrm>
+            <a:off x="4023360" y="4837176"/>
+            <a:ext cx="3474720" cy="274320"/>
+          </a:xfrm>
+          <a:prstGeom prst="rect">
+            <a:avLst/>
+          </a:prstGeom>
+          <a:noFill/>
+        </p:spPr>
+        <p:txBody>
+          <a:bodyPr wrap="square" lIns="0" rIns="0" tIns="0" bIns="0">
+            <a:spAutoFit/>
+          </a:bodyPr>
+          <a:lstStyle/>
+          <a:p>
+            <a:pPr algn="l">
+              <a:spcAft>
+                <a:spcPts val="0"/>
+              </a:spcAft>
+            </a:pPr>
+            <a:r>
+              <a:rPr sz="1000" b="0">
                 <a:solidFill>
                   <a:srgbClr val="475569"/>
                 </a:solidFill>
                 <a:latin typeface="Segoe UI"/>
               </a:rPr>
-              <a:t>• EVAL-03: Dependency CVE: Vulnerable PyYAML &amp; requests with known CVEs -&gt; Expected: HIGH -&gt; Status: PASS (Advisory matched)</a:t>
-            </a:r>
-          </a:p>
-          <a:p>
-            <a:pPr algn="l">
-              <a:spcAft>
-                <a:spcPts val="400"/>
-              </a:spcAft>
-            </a:pPr>
-            <a:r>
-              <a:rPr sz="1100" b="0">
+              <a:t>Outdated PyYAML with published CVEs</a:t>
+            </a:r>
+          </a:p>
+        </p:txBody>
+      </p:sp>
+      <p:sp>
+        <p:nvSpPr>
+          <p:cNvPr id="29" name="TextBox 28"/>
+          <p:cNvSpPr txBox="1"/>
+          <p:nvPr/>
+        </p:nvSpPr>
+        <p:spPr>
+          <a:xfrm>
+            <a:off x="7498079" y="4837176"/>
+            <a:ext cx="1645920" cy="274320"/>
+          </a:xfrm>
+          <a:prstGeom prst="rect">
+            <a:avLst/>
+          </a:prstGeom>
+          <a:noFill/>
+        </p:spPr>
+        <p:txBody>
+          <a:bodyPr wrap="square" lIns="0" rIns="0" tIns="0" bIns="0">
+            <a:spAutoFit/>
+          </a:bodyPr>
+          <a:lstStyle/>
+          <a:p>
+            <a:pPr algn="l">
+              <a:spcAft>
+                <a:spcPts val="0"/>
+              </a:spcAft>
+            </a:pPr>
+            <a:r>
+              <a:rPr sz="900" b="1">
+                <a:solidFill>
+                  <a:srgbClr val="2563EB"/>
+                </a:solidFill>
+                <a:latin typeface="Segoe UI"/>
+              </a:rPr>
+              <a:t>HIGH</a:t>
+            </a:r>
+          </a:p>
+        </p:txBody>
+      </p:sp>
+      <p:sp>
+        <p:nvSpPr>
+          <p:cNvPr id="30" name="TextBox 29"/>
+          <p:cNvSpPr txBox="1"/>
+          <p:nvPr/>
+        </p:nvSpPr>
+        <p:spPr>
+          <a:xfrm>
+            <a:off x="9144000" y="4837176"/>
+            <a:ext cx="2011680" cy="274320"/>
+          </a:xfrm>
+          <a:prstGeom prst="rect">
+            <a:avLst/>
+          </a:prstGeom>
+          <a:noFill/>
+        </p:spPr>
+        <p:txBody>
+          <a:bodyPr wrap="square" lIns="0" rIns="0" tIns="0" bIns="0">
+            <a:spAutoFit/>
+          </a:bodyPr>
+          <a:lstStyle/>
+          <a:p>
+            <a:pPr algn="l">
+              <a:spcAft>
+                <a:spcPts val="0"/>
+              </a:spcAft>
+            </a:pPr>
+            <a:r>
+              <a:rPr sz="900" b="1">
+                <a:solidFill>
+                  <a:srgbClr val="16A34A"/>
+                </a:solidFill>
+                <a:latin typeface="Segoe UI"/>
+              </a:rPr>
+              <a:t>PASS (Advisory Matched)</a:t>
+            </a:r>
+          </a:p>
+        </p:txBody>
+      </p:sp>
+      <p:sp>
+        <p:nvSpPr>
+          <p:cNvPr id="31" name="Rounded Rectangle 30"/>
+          <p:cNvSpPr/>
+          <p:nvPr/>
+        </p:nvSpPr>
+        <p:spPr>
+          <a:xfrm>
+            <a:off x="960120" y="5202936"/>
+            <a:ext cx="10271455" cy="384048"/>
+          </a:xfrm>
+          <a:prstGeom prst="roundRect">
+            <a:avLst/>
+          </a:prstGeom>
+          <a:solidFill>
+            <a:srgbClr val="F1F5F9"/>
+          </a:solidFill>
+          <a:ln w="12700">
+            <a:solidFill>
+              <a:srgbClr val="E2E8F0"/>
+            </a:solidFill>
+          </a:ln>
+        </p:spPr>
+        <p:style>
+          <a:lnRef idx="1">
+            <a:schemeClr val="accent1"/>
+          </a:lnRef>
+          <a:fillRef idx="3">
+            <a:schemeClr val="accent1"/>
+          </a:fillRef>
+          <a:effectRef idx="2">
+            <a:schemeClr val="accent1"/>
+          </a:effectRef>
+          <a:fontRef idx="minor">
+            <a:schemeClr val="lt1"/>
+          </a:fontRef>
+        </p:style>
+        <p:txBody>
+          <a:bodyPr rtlCol="0" anchor="ctr"/>
+          <a:lstStyle/>
+          <a:p>
+            <a:pPr algn="ctr"/>
+          </a:p>
+        </p:txBody>
+      </p:sp>
+      <p:sp>
+        <p:nvSpPr>
+          <p:cNvPr id="32" name="TextBox 31"/>
+          <p:cNvSpPr txBox="1"/>
+          <p:nvPr/>
+        </p:nvSpPr>
+        <p:spPr>
+          <a:xfrm>
+            <a:off x="1097280" y="5276088"/>
+            <a:ext cx="2926080" cy="274320"/>
+          </a:xfrm>
+          <a:prstGeom prst="rect">
+            <a:avLst/>
+          </a:prstGeom>
+          <a:noFill/>
+        </p:spPr>
+        <p:txBody>
+          <a:bodyPr wrap="square" lIns="0" rIns="0" tIns="0" bIns="0">
+            <a:spAutoFit/>
+          </a:bodyPr>
+          <a:lstStyle/>
+          <a:p>
+            <a:pPr algn="l">
+              <a:spcAft>
+                <a:spcPts val="0"/>
+              </a:spcAft>
+            </a:pPr>
+            <a:r>
+              <a:rPr sz="1000" b="1">
+                <a:solidFill>
+                  <a:srgbClr val="0F172A"/>
+                </a:solidFill>
+                <a:latin typeface="Segoe UI"/>
+              </a:rPr>
+              <a:t>EVAL-04: Test Coverage Deficit</a:t>
+            </a:r>
+          </a:p>
+        </p:txBody>
+      </p:sp>
+      <p:sp>
+        <p:nvSpPr>
+          <p:cNvPr id="33" name="TextBox 32"/>
+          <p:cNvSpPr txBox="1"/>
+          <p:nvPr/>
+        </p:nvSpPr>
+        <p:spPr>
+          <a:xfrm>
+            <a:off x="4023360" y="5276088"/>
+            <a:ext cx="3474720" cy="274320"/>
+          </a:xfrm>
+          <a:prstGeom prst="rect">
+            <a:avLst/>
+          </a:prstGeom>
+          <a:noFill/>
+        </p:spPr>
+        <p:txBody>
+          <a:bodyPr wrap="square" lIns="0" rIns="0" tIns="0" bIns="0">
+            <a:spAutoFit/>
+          </a:bodyPr>
+          <a:lstStyle/>
+          <a:p>
+            <a:pPr algn="l">
+              <a:spcAft>
+                <a:spcPts val="0"/>
+              </a:spcAft>
+            </a:pPr>
+            <a:r>
+              <a:rPr sz="1000" b="0">
                 <a:solidFill>
                   <a:srgbClr val="475569"/>
                 </a:solidFill>
                 <a:latin typeface="Segoe UI"/>
               </a:rPr>
-              <a:t>• EVAL-04: Test Deficit: Untested payment / auth sensitive transaction logic -&gt; Expected: MEDIUM -&gt; Status: PASS (Missing test alert)</a:t>
-            </a:r>
-          </a:p>
-          <a:p>
-            <a:pPr algn="l">
-              <a:spcAft>
-                <a:spcPts val="400"/>
-              </a:spcAft>
-            </a:pPr>
-            <a:r>
-              <a:rPr sz="1100" b="0">
+              <a:t>Untested financial / auth payment logic</a:t>
+            </a:r>
+          </a:p>
+        </p:txBody>
+      </p:sp>
+      <p:sp>
+        <p:nvSpPr>
+          <p:cNvPr id="34" name="TextBox 33"/>
+          <p:cNvSpPr txBox="1"/>
+          <p:nvPr/>
+        </p:nvSpPr>
+        <p:spPr>
+          <a:xfrm>
+            <a:off x="7498079" y="5276088"/>
+            <a:ext cx="1645920" cy="274320"/>
+          </a:xfrm>
+          <a:prstGeom prst="rect">
+            <a:avLst/>
+          </a:prstGeom>
+          <a:noFill/>
+        </p:spPr>
+        <p:txBody>
+          <a:bodyPr wrap="square" lIns="0" rIns="0" tIns="0" bIns="0">
+            <a:spAutoFit/>
+          </a:bodyPr>
+          <a:lstStyle/>
+          <a:p>
+            <a:pPr algn="l">
+              <a:spcAft>
+                <a:spcPts val="0"/>
+              </a:spcAft>
+            </a:pPr>
+            <a:r>
+              <a:rPr sz="900" b="1">
+                <a:solidFill>
+                  <a:srgbClr val="2563EB"/>
+                </a:solidFill>
+                <a:latin typeface="Segoe UI"/>
+              </a:rPr>
+              <a:t>MEDIUM</a:t>
+            </a:r>
+          </a:p>
+        </p:txBody>
+      </p:sp>
+      <p:sp>
+        <p:nvSpPr>
+          <p:cNvPr id="35" name="TextBox 34"/>
+          <p:cNvSpPr txBox="1"/>
+          <p:nvPr/>
+        </p:nvSpPr>
+        <p:spPr>
+          <a:xfrm>
+            <a:off x="9144000" y="5276088"/>
+            <a:ext cx="2011680" cy="274320"/>
+          </a:xfrm>
+          <a:prstGeom prst="rect">
+            <a:avLst/>
+          </a:prstGeom>
+          <a:noFill/>
+        </p:spPr>
+        <p:txBody>
+          <a:bodyPr wrap="square" lIns="0" rIns="0" tIns="0" bIns="0">
+            <a:spAutoFit/>
+          </a:bodyPr>
+          <a:lstStyle/>
+          <a:p>
+            <a:pPr algn="l">
+              <a:spcAft>
+                <a:spcPts val="0"/>
+              </a:spcAft>
+            </a:pPr>
+            <a:r>
+              <a:rPr sz="900" b="1">
+                <a:solidFill>
+                  <a:srgbClr val="16A34A"/>
+                </a:solidFill>
+                <a:latin typeface="Segoe UI"/>
+              </a:rPr>
+              <a:t>PASS (Missing Test Flagged)</a:t>
+            </a:r>
+          </a:p>
+        </p:txBody>
+      </p:sp>
+      <p:sp>
+        <p:nvSpPr>
+          <p:cNvPr id="36" name="Rounded Rectangle 35"/>
+          <p:cNvSpPr/>
+          <p:nvPr/>
+        </p:nvSpPr>
+        <p:spPr>
+          <a:xfrm>
+            <a:off x="960120" y="5641848"/>
+            <a:ext cx="10271455" cy="384048"/>
+          </a:xfrm>
+          <a:prstGeom prst="roundRect">
+            <a:avLst/>
+          </a:prstGeom>
+          <a:solidFill>
+            <a:srgbClr val="FFFFFF"/>
+          </a:solidFill>
+          <a:ln w="12700">
+            <a:solidFill>
+              <a:srgbClr val="E2E8F0"/>
+            </a:solidFill>
+          </a:ln>
+        </p:spPr>
+        <p:style>
+          <a:lnRef idx="1">
+            <a:schemeClr val="accent1"/>
+          </a:lnRef>
+          <a:fillRef idx="3">
+            <a:schemeClr val="accent1"/>
+          </a:fillRef>
+          <a:effectRef idx="2">
+            <a:schemeClr val="accent1"/>
+          </a:effectRef>
+          <a:fontRef idx="minor">
+            <a:schemeClr val="lt1"/>
+          </a:fontRef>
+        </p:style>
+        <p:txBody>
+          <a:bodyPr rtlCol="0" anchor="ctr"/>
+          <a:lstStyle/>
+          <a:p>
+            <a:pPr algn="ctr"/>
+          </a:p>
+        </p:txBody>
+      </p:sp>
+      <p:sp>
+        <p:nvSpPr>
+          <p:cNvPr id="37" name="TextBox 36"/>
+          <p:cNvSpPr txBox="1"/>
+          <p:nvPr/>
+        </p:nvSpPr>
+        <p:spPr>
+          <a:xfrm>
+            <a:off x="1097280" y="5715000"/>
+            <a:ext cx="2926080" cy="274320"/>
+          </a:xfrm>
+          <a:prstGeom prst="rect">
+            <a:avLst/>
+          </a:prstGeom>
+          <a:noFill/>
+        </p:spPr>
+        <p:txBody>
+          <a:bodyPr wrap="square" lIns="0" rIns="0" tIns="0" bIns="0">
+            <a:spAutoFit/>
+          </a:bodyPr>
+          <a:lstStyle/>
+          <a:p>
+            <a:pPr algn="l">
+              <a:spcAft>
+                <a:spcPts val="0"/>
+              </a:spcAft>
+            </a:pPr>
+            <a:r>
+              <a:rPr sz="1000" b="1">
+                <a:solidFill>
+                  <a:srgbClr val="0F172A"/>
+                </a:solidFill>
+                <a:latin typeface="Segoe UI"/>
+              </a:rPr>
+              <a:t>EVAL-05: Clean Baseline</a:t>
+            </a:r>
+          </a:p>
+        </p:txBody>
+      </p:sp>
+      <p:sp>
+        <p:nvSpPr>
+          <p:cNvPr id="38" name="TextBox 37"/>
+          <p:cNvSpPr txBox="1"/>
+          <p:nvPr/>
+        </p:nvSpPr>
+        <p:spPr>
+          <a:xfrm>
+            <a:off x="4023360" y="5715000"/>
+            <a:ext cx="3474720" cy="274320"/>
+          </a:xfrm>
+          <a:prstGeom prst="rect">
+            <a:avLst/>
+          </a:prstGeom>
+          <a:noFill/>
+        </p:spPr>
+        <p:txBody>
+          <a:bodyPr wrap="square" lIns="0" rIns="0" tIns="0" bIns="0">
+            <a:spAutoFit/>
+          </a:bodyPr>
+          <a:lstStyle/>
+          <a:p>
+            <a:pPr algn="l">
+              <a:spcAft>
+                <a:spcPts val="0"/>
+              </a:spcAft>
+            </a:pPr>
+            <a:r>
+              <a:rPr sz="1000" b="0">
                 <a:solidFill>
                   <a:srgbClr val="475569"/>
                 </a:solidFill>
                 <a:latin typeface="Segoe UI"/>
               </a:rPr>
-              <a:t>• EVAL-05: Clean Baseline: Production-hardened repository with zero hazards -&gt; Expected: NONE (Clean) -&gt; Status: PASS (0 false positives (Clean))</a:t>
+              <a:t>Production-hardened clean repository</a:t>
+            </a:r>
+          </a:p>
+        </p:txBody>
+      </p:sp>
+      <p:sp>
+        <p:nvSpPr>
+          <p:cNvPr id="39" name="TextBox 38"/>
+          <p:cNvSpPr txBox="1"/>
+          <p:nvPr/>
+        </p:nvSpPr>
+        <p:spPr>
+          <a:xfrm>
+            <a:off x="7498079" y="5715000"/>
+            <a:ext cx="1645920" cy="274320"/>
+          </a:xfrm>
+          <a:prstGeom prst="rect">
+            <a:avLst/>
+          </a:prstGeom>
+          <a:noFill/>
+        </p:spPr>
+        <p:txBody>
+          <a:bodyPr wrap="square" lIns="0" rIns="0" tIns="0" bIns="0">
+            <a:spAutoFit/>
+          </a:bodyPr>
+          <a:lstStyle/>
+          <a:p>
+            <a:pPr algn="l">
+              <a:spcAft>
+                <a:spcPts val="0"/>
+              </a:spcAft>
+            </a:pPr>
+            <a:r>
+              <a:rPr sz="900" b="1">
+                <a:solidFill>
+                  <a:srgbClr val="2563EB"/>
+                </a:solidFill>
+                <a:latin typeface="Segoe UI"/>
+              </a:rPr>
+              <a:t>NONE (Clean)</a:t>
+            </a:r>
+          </a:p>
+        </p:txBody>
+      </p:sp>
+      <p:sp>
+        <p:nvSpPr>
+          <p:cNvPr id="40" name="TextBox 39"/>
+          <p:cNvSpPr txBox="1"/>
+          <p:nvPr/>
+        </p:nvSpPr>
+        <p:spPr>
+          <a:xfrm>
+            <a:off x="9144000" y="5715000"/>
+            <a:ext cx="2011680" cy="274320"/>
+          </a:xfrm>
+          <a:prstGeom prst="rect">
+            <a:avLst/>
+          </a:prstGeom>
+          <a:noFill/>
+        </p:spPr>
+        <p:txBody>
+          <a:bodyPr wrap="square" lIns="0" rIns="0" tIns="0" bIns="0">
+            <a:spAutoFit/>
+          </a:bodyPr>
+          <a:lstStyle/>
+          <a:p>
+            <a:pPr algn="l">
+              <a:spcAft>
+                <a:spcPts val="0"/>
+              </a:spcAft>
+            </a:pPr>
+            <a:r>
+              <a:rPr sz="900" b="1">
+                <a:solidFill>
+                  <a:srgbClr val="16A34A"/>
+                </a:solidFill>
+                <a:latin typeface="Segoe UI"/>
+              </a:rPr>
+              <a:t>PASS (0.0% False Positives)</a:t>
             </a:r>
           </a:p>
         </p:txBody>
@@ -4583,7 +5508,7 @@
           <a:noFill/>
         </p:spPr>
         <p:txBody>
-          <a:bodyPr wrap="none">
+          <a:bodyPr wrap="square" lIns="0" rIns="0" tIns="0" bIns="0">
             <a:spAutoFit/>
           </a:bodyPr>
           <a:lstStyle/>
@@ -4610,7 +5535,7 @@
         <p:spPr>
           <a:xfrm>
             <a:off x="731520" y="777240"/>
-            <a:ext cx="10698480" cy="640080"/>
+            <a:ext cx="10698480" cy="731520"/>
           </a:xfrm>
           <a:prstGeom prst="rect">
             <a:avLst/>
@@ -4618,14 +5543,14 @@
           <a:noFill/>
         </p:spPr>
         <p:txBody>
-          <a:bodyPr wrap="square" lIns="0" tIns="0" rIns="0" bIns="0">
+          <a:bodyPr wrap="square" lIns="0" rIns="0" tIns="0" bIns="0">
             <a:spAutoFit/>
           </a:bodyPr>
           <a:lstStyle/>
           <a:p>
             <a:pPr algn="l">
               <a:spcAft>
-                <a:spcPts val="200"/>
+                <a:spcPts val="300"/>
               </a:spcAft>
             </a:pPr>
             <a:r>
@@ -4665,7 +5590,7 @@
         <p:spPr>
           <a:xfrm>
             <a:off x="731520" y="1783080"/>
-            <a:ext cx="3429000" cy="4389120"/>
+            <a:ext cx="3429000" cy="4480560"/>
           </a:xfrm>
           <a:prstGeom prst="roundRect">
             <a:avLst/>
@@ -4709,7 +5634,7 @@
         </p:nvSpPr>
         <p:spPr>
           <a:xfrm>
-            <a:off x="914400" y="2011680"/>
+            <a:off x="960120" y="2011680"/>
             <a:ext cx="1645920" cy="256032"/>
           </a:xfrm>
           <a:prstGeom prst="roundRect">
@@ -4742,7 +5667,7 @@
           <a:p>
             <a:pPr algn="ctr"/>
             <a:r>
-              <a:rPr sz="1000" b="1">
+              <a:rPr sz="900" b="1">
                 <a:solidFill>
                   <a:srgbClr val="2563EB"/>
                 </a:solidFill>
@@ -4761,8 +5686,8 @@
         </p:nvSpPr>
         <p:spPr>
           <a:xfrm>
-            <a:off x="914400" y="2377440"/>
-            <a:ext cx="3063240" cy="3840480"/>
+            <a:off x="960120" y="2377440"/>
+            <a:ext cx="2971800" cy="3703320"/>
           </a:xfrm>
           <a:prstGeom prst="rect">
             <a:avLst/>
@@ -4770,7 +5695,7 @@
           <a:noFill/>
         </p:spPr>
         <p:txBody>
-          <a:bodyPr wrap="none">
+          <a:bodyPr wrap="square" lIns="0" rIns="0" tIns="0" bIns="0">
             <a:spAutoFit/>
           </a:bodyPr>
           <a:lstStyle/>
@@ -4881,7 +5806,7 @@
         <p:spPr>
           <a:xfrm>
             <a:off x="4379976" y="1783080"/>
-            <a:ext cx="3429000" cy="4389120"/>
+            <a:ext cx="3429000" cy="4480560"/>
           </a:xfrm>
           <a:prstGeom prst="roundRect">
             <a:avLst/>
@@ -4925,7 +5850,7 @@
         </p:nvSpPr>
         <p:spPr>
           <a:xfrm>
-            <a:off x="4562856" y="2011680"/>
+            <a:off x="4608576" y="2011680"/>
             <a:ext cx="1645920" cy="256032"/>
           </a:xfrm>
           <a:prstGeom prst="roundRect">
@@ -4958,7 +5883,7 @@
           <a:p>
             <a:pPr algn="ctr"/>
             <a:r>
-              <a:rPr sz="1000" b="1">
+              <a:rPr sz="900" b="1">
                 <a:solidFill>
                   <a:srgbClr val="2563EB"/>
                 </a:solidFill>
@@ -4977,8 +5902,8 @@
         </p:nvSpPr>
         <p:spPr>
           <a:xfrm>
-            <a:off x="4562856" y="2377440"/>
-            <a:ext cx="3063240" cy="3840480"/>
+            <a:off x="4608576" y="2377440"/>
+            <a:ext cx="2971800" cy="3703320"/>
           </a:xfrm>
           <a:prstGeom prst="rect">
             <a:avLst/>
@@ -4986,7 +5911,7 @@
           <a:noFill/>
         </p:spPr>
         <p:txBody>
-          <a:bodyPr wrap="none">
+          <a:bodyPr wrap="square" lIns="0" rIns="0" tIns="0" bIns="0">
             <a:spAutoFit/>
           </a:bodyPr>
           <a:lstStyle/>
@@ -5081,7 +6006,7 @@
         <p:spPr>
           <a:xfrm>
             <a:off x="8028431" y="1783080"/>
-            <a:ext cx="3429000" cy="4389120"/>
+            <a:ext cx="3429000" cy="4480560"/>
           </a:xfrm>
           <a:prstGeom prst="roundRect">
             <a:avLst/>
@@ -5125,7 +6050,7 @@
         </p:nvSpPr>
         <p:spPr>
           <a:xfrm>
-            <a:off x="8211311" y="2011680"/>
+            <a:off x="8257031" y="2011680"/>
             <a:ext cx="1645920" cy="256032"/>
           </a:xfrm>
           <a:prstGeom prst="roundRect">
@@ -5158,7 +6083,7 @@
           <a:p>
             <a:pPr algn="ctr"/>
             <a:r>
-              <a:rPr sz="1000" b="1">
+              <a:rPr sz="900" b="1">
                 <a:solidFill>
                   <a:srgbClr val="2563EB"/>
                 </a:solidFill>
@@ -5177,8 +6102,8 @@
         </p:nvSpPr>
         <p:spPr>
           <a:xfrm>
-            <a:off x="8211311" y="2377440"/>
-            <a:ext cx="3063240" cy="3840480"/>
+            <a:off x="8257031" y="2377440"/>
+            <a:ext cx="2971800" cy="3703320"/>
           </a:xfrm>
           <a:prstGeom prst="rect">
             <a:avLst/>
@@ -5186,7 +6111,7 @@
           <a:noFill/>
         </p:spPr>
         <p:txBody>
-          <a:bodyPr wrap="none">
+          <a:bodyPr wrap="square" lIns="0" rIns="0" tIns="0" bIns="0">
             <a:spAutoFit/>
           </a:bodyPr>
           <a:lstStyle/>
@@ -5219,7 +6144,7 @@
                 </a:solidFill>
                 <a:latin typeface="Segoe UI"/>
               </a:rPr>
-              <a:t>• `deploysafe` CLI command-line tool.</a:t>
+              <a:t>• deploysafe CLI command-line tool.</a:t>
             </a:r>
           </a:p>
           <a:p>
@@ -5235,7 +6160,7 @@
                 </a:solidFill>
                 <a:latin typeface="Segoe UI"/>
               </a:rPr>
-              <a:t>• Emits ANSI colored summaries and exit codes (`0` pass, `1` blocked).</a:t>
+              <a:t>• Emits ANSI colored summaries and exit codes (0 pass, 1 blocked).</a:t>
             </a:r>
           </a:p>
           <a:p>
@@ -5402,7 +6327,7 @@
           <a:noFill/>
         </p:spPr>
         <p:txBody>
-          <a:bodyPr wrap="none">
+          <a:bodyPr wrap="square" lIns="0" rIns="0" tIns="0" bIns="0">
             <a:spAutoFit/>
           </a:bodyPr>
           <a:lstStyle/>
@@ -5429,7 +6354,7 @@
         <p:spPr>
           <a:xfrm>
             <a:off x="731520" y="777240"/>
-            <a:ext cx="10698480" cy="640080"/>
+            <a:ext cx="10698480" cy="731520"/>
           </a:xfrm>
           <a:prstGeom prst="rect">
             <a:avLst/>
@@ -5437,14 +6362,14 @@
           <a:noFill/>
         </p:spPr>
         <p:txBody>
-          <a:bodyPr wrap="square" lIns="0" tIns="0" rIns="0" bIns="0">
+          <a:bodyPr wrap="square" lIns="0" rIns="0" tIns="0" bIns="0">
             <a:spAutoFit/>
           </a:bodyPr>
           <a:lstStyle/>
           <a:p>
             <a:pPr algn="l">
               <a:spcAft>
-                <a:spcPts val="200"/>
+                <a:spcPts val="300"/>
               </a:spcAft>
             </a:pPr>
             <a:r>
@@ -5484,7 +6409,7 @@
         <p:spPr>
           <a:xfrm>
             <a:off x="731520" y="1783080"/>
-            <a:ext cx="5212080" cy="4389120"/>
+            <a:ext cx="5212080" cy="4480560"/>
           </a:xfrm>
           <a:prstGeom prst="roundRect">
             <a:avLst/>
@@ -5528,8 +6453,8 @@
         </p:nvSpPr>
         <p:spPr>
           <a:xfrm>
-            <a:off x="914400" y="2011680"/>
-            <a:ext cx="4846320" cy="3931920"/>
+            <a:off x="960120" y="1965960"/>
+            <a:ext cx="4754880" cy="4114800"/>
           </a:xfrm>
           <a:prstGeom prst="rect">
             <a:avLst/>
@@ -5537,14 +6462,14 @@
           <a:noFill/>
         </p:spPr>
         <p:txBody>
-          <a:bodyPr wrap="none">
+          <a:bodyPr wrap="square" lIns="0" rIns="0" tIns="0" bIns="0">
             <a:spAutoFit/>
           </a:bodyPr>
           <a:lstStyle/>
           <a:p>
             <a:pPr algn="l">
               <a:spcAft>
-                <a:spcPts val="1200"/>
+                <a:spcPts val="1000"/>
               </a:spcAft>
             </a:pPr>
             <a:r>
@@ -5560,11 +6485,11 @@
           <a:p>
             <a:pPr algn="l">
               <a:spcAft>
-                <a:spcPts val="1000"/>
-              </a:spcAft>
-            </a:pPr>
-            <a:r>
-              <a:rPr sz="1200" b="0">
+                <a:spcPts val="800"/>
+              </a:spcAft>
+            </a:pPr>
+            <a:r>
+              <a:rPr sz="1100" b="0">
                 <a:solidFill>
                   <a:srgbClr val="475569"/>
                 </a:solidFill>
@@ -5576,11 +6501,11 @@
           <a:p>
             <a:pPr algn="l">
               <a:spcAft>
-                <a:spcPts val="1000"/>
-              </a:spcAft>
-            </a:pPr>
-            <a:r>
-              <a:rPr sz="1200" b="0">
+                <a:spcPts val="800"/>
+              </a:spcAft>
+            </a:pPr>
+            <a:r>
+              <a:rPr sz="1100" b="0">
                 <a:solidFill>
                   <a:srgbClr val="475569"/>
                 </a:solidFill>
@@ -5592,11 +6517,11 @@
           <a:p>
             <a:pPr algn="l">
               <a:spcAft>
-                <a:spcPts val="1000"/>
-              </a:spcAft>
-            </a:pPr>
-            <a:r>
-              <a:rPr sz="1200" b="0">
+                <a:spcPts val="800"/>
+              </a:spcAft>
+            </a:pPr>
+            <a:r>
+              <a:rPr sz="1100" b="0">
                 <a:solidFill>
                   <a:srgbClr val="475569"/>
                 </a:solidFill>
@@ -5612,13 +6537,13 @@
               </a:spcAft>
             </a:pPr>
             <a:r>
-              <a:rPr sz="1200" b="0">
+              <a:rPr sz="1100" b="0">
                 <a:solidFill>
                   <a:srgbClr val="475569"/>
                 </a:solidFill>
                 <a:latin typeface="Segoe UI"/>
               </a:rPr>
-              <a:t>4. V2 Enterprise Capabilities: Added repo governance (`deploysafe.yml`), deterministic blast radius (8.4ms), and human-approved patch diffs.</a:t>
+              <a:t>4. V2 Enterprise Capabilities: Added repo governance (deploysafe.yml), deterministic blast radius (8.4ms), and human-approved patch diffs.</a:t>
             </a:r>
           </a:p>
         </p:txBody>
@@ -5632,7 +6557,7 @@
         <p:spPr>
           <a:xfrm>
             <a:off x="6217920" y="1783080"/>
-            <a:ext cx="5242255" cy="4389120"/>
+            <a:ext cx="5242255" cy="4480560"/>
           </a:xfrm>
           <a:prstGeom prst="roundRect">
             <a:avLst/>
@@ -5670,132 +6595,13 @@
       </p:sp>
       <p:sp>
         <p:nvSpPr>
-          <p:cNvPr id="9" name="TextBox 8"/>
-          <p:cNvSpPr txBox="1"/>
-          <p:nvPr/>
-        </p:nvSpPr>
-        <p:spPr>
-          <a:xfrm>
-            <a:off x="6492240" y="2423160"/>
-            <a:ext cx="4663440" cy="3931920"/>
-          </a:xfrm>
-          <a:prstGeom prst="rect">
-            <a:avLst/>
-          </a:prstGeom>
-          <a:noFill/>
-        </p:spPr>
-        <p:txBody>
-          <a:bodyPr wrap="none">
-            <a:spAutoFit/>
-          </a:bodyPr>
-          <a:lstStyle/>
-          <a:p>
-            <a:pPr algn="l">
-              <a:spcAft>
-                <a:spcPts val="1200"/>
-              </a:spcAft>
-            </a:pPr>
-            <a:r>
-              <a:rPr sz="1600" b="1">
-                <a:solidFill>
-                  <a:srgbClr val="0F172A"/>
-                </a:solidFill>
-                <a:latin typeface="Segoe UI"/>
-              </a:rPr>
-              <a:t>Project Completion Summary</a:t>
-            </a:r>
-          </a:p>
-          <a:p>
-            <a:pPr algn="l">
-              <a:spcAft>
-                <a:spcPts val="1000"/>
-              </a:spcAft>
-            </a:pPr>
-            <a:r>
-              <a:rPr sz="1200" b="0">
-                <a:solidFill>
-                  <a:srgbClr val="0F172A"/>
-                </a:solidFill>
-                <a:latin typeface="Segoe UI"/>
-              </a:rPr>
-              <a:t>• Mentors: Sincere gratitude to Mr. Naveen Singla &amp; Dr. Kiran Khatter for architectural direction and guidance.</a:t>
-            </a:r>
-          </a:p>
-          <a:p>
-            <a:pPr algn="l">
-              <a:spcAft>
-                <a:spcPts val="800"/>
-              </a:spcAft>
-            </a:pPr>
-            <a:r>
-              <a:rPr sz="1200" b="0">
-                <a:solidFill>
-                  <a:srgbClr val="475569"/>
-                </a:solidFill>
-                <a:latin typeface="Segoe UI"/>
-              </a:rPr>
-              <a:t>• Versioning: v1.0.0 Final Academic Release preserved under Git Tag `v1.0.0-final-submission` (`commit 42222be`).</a:t>
-            </a:r>
-          </a:p>
-          <a:p>
-            <a:pPr algn="l">
-              <a:spcAft>
-                <a:spcPts val="800"/>
-              </a:spcAft>
-            </a:pPr>
-            <a:r>
-              <a:rPr sz="1200" b="1">
-                <a:solidFill>
-                  <a:srgbClr val="16A34A"/>
-                </a:solidFill>
-                <a:latin typeface="Segoe UI"/>
-              </a:rPr>
-              <a:t>• V2 Status: Phase 7 Completed with 98/98 tests passing.</a:t>
-            </a:r>
-          </a:p>
-          <a:p>
-            <a:pPr algn="l">
-              <a:spcAft>
-                <a:spcPts val="1600"/>
-              </a:spcAft>
-            </a:pPr>
-            <a:r>
-              <a:rPr sz="1200" b="0">
-                <a:solidFill>
-                  <a:srgbClr val="475569"/>
-                </a:solidFill>
-                <a:latin typeface="Segoe UI"/>
-              </a:rPr>
-              <a:t>• Documentation: Complete Viva Guide, Demo Scripts, Architecture Docs, and Contribution Matrix verified.</a:t>
-            </a:r>
-          </a:p>
-          <a:p>
-            <a:pPr algn="l">
-              <a:spcAft>
-                <a:spcPts val="0"/>
-              </a:spcAft>
-            </a:pPr>
-            <a:r>
-              <a:rPr sz="1400" b="1">
-                <a:solidFill>
-                  <a:srgbClr val="2563EB"/>
-                </a:solidFill>
-                <a:latin typeface="Segoe UI"/>
-              </a:rPr>
-              <a:t>Thank you. Questions &amp; Technical Demonstration Welcome.</a:t>
-            </a:r>
-          </a:p>
-        </p:txBody>
-      </p:sp>
-      <p:sp>
-        <p:nvSpPr>
-          <p:cNvPr id="10" name="Rounded Rectangle 9"/>
+          <p:cNvPr id="9" name="Rounded Rectangle 8"/>
           <p:cNvSpPr/>
           <p:nvPr/>
         </p:nvSpPr>
         <p:spPr>
           <a:xfrm>
-            <a:off x="6492240" y="2011680"/>
+            <a:off x="6446520" y="2011680"/>
             <a:ext cx="2286000" cy="274320"/>
           </a:xfrm>
           <a:prstGeom prst="roundRect">
@@ -5828,13 +6634,132 @@
           <a:p>
             <a:pPr algn="ctr"/>
             <a:r>
-              <a:rPr sz="1000" b="1">
+              <a:rPr sz="900" b="1">
                 <a:solidFill>
                   <a:srgbClr val="2563EB"/>
                 </a:solidFill>
                 <a:latin typeface="Segoe UI"/>
               </a:rPr>
               <a:t>PROJECT DELIVERABLES</a:t>
+            </a:r>
+          </a:p>
+        </p:txBody>
+      </p:sp>
+      <p:sp>
+        <p:nvSpPr>
+          <p:cNvPr id="10" name="TextBox 9"/>
+          <p:cNvSpPr txBox="1"/>
+          <p:nvPr/>
+        </p:nvSpPr>
+        <p:spPr>
+          <a:xfrm>
+            <a:off x="6446520" y="2423160"/>
+            <a:ext cx="4785055" cy="3657600"/>
+          </a:xfrm>
+          <a:prstGeom prst="rect">
+            <a:avLst/>
+          </a:prstGeom>
+          <a:noFill/>
+        </p:spPr>
+        <p:txBody>
+          <a:bodyPr wrap="square" lIns="0" rIns="0" tIns="0" bIns="0">
+            <a:spAutoFit/>
+          </a:bodyPr>
+          <a:lstStyle/>
+          <a:p>
+            <a:pPr algn="l">
+              <a:spcAft>
+                <a:spcPts val="1000"/>
+              </a:spcAft>
+            </a:pPr>
+            <a:r>
+              <a:rPr sz="1600" b="1">
+                <a:solidFill>
+                  <a:srgbClr val="0F172A"/>
+                </a:solidFill>
+                <a:latin typeface="Segoe UI"/>
+              </a:rPr>
+              <a:t>Project Completion Summary</a:t>
+            </a:r>
+          </a:p>
+          <a:p>
+            <a:pPr algn="l">
+              <a:spcAft>
+                <a:spcPts val="800"/>
+              </a:spcAft>
+            </a:pPr>
+            <a:r>
+              <a:rPr sz="1100" b="0">
+                <a:solidFill>
+                  <a:srgbClr val="0F172A"/>
+                </a:solidFill>
+                <a:latin typeface="Segoe UI"/>
+              </a:rPr>
+              <a:t>• Mentors: Sincere gratitude to Mr. Naveen Singla &amp; Dr. Kiran Khatter for architectural direction and guidance.</a:t>
+            </a:r>
+          </a:p>
+          <a:p>
+            <a:pPr algn="l">
+              <a:spcAft>
+                <a:spcPts val="800"/>
+              </a:spcAft>
+            </a:pPr>
+            <a:r>
+              <a:rPr sz="1100" b="0">
+                <a:solidFill>
+                  <a:srgbClr val="475569"/>
+                </a:solidFill>
+                <a:latin typeface="Segoe UI"/>
+              </a:rPr>
+              <a:t>• Versioning: v1.0.0 Final Academic Release preserved under Git Tag v1.0.0-final-submission.</a:t>
+            </a:r>
+          </a:p>
+          <a:p>
+            <a:pPr algn="l">
+              <a:spcAft>
+                <a:spcPts val="800"/>
+              </a:spcAft>
+            </a:pPr>
+            <a:r>
+              <a:rPr sz="1100" b="1">
+                <a:solidFill>
+                  <a:srgbClr val="16A34A"/>
+                </a:solidFill>
+                <a:latin typeface="Segoe UI"/>
+              </a:rPr>
+              <a:t>• V2 Status: Phase 7 Completed with 98/98 tests passing.</a:t>
+            </a:r>
+          </a:p>
+          <a:p>
+            <a:pPr algn="l">
+              <a:spcAft>
+                <a:spcPts val="1400"/>
+              </a:spcAft>
+            </a:pPr>
+            <a:r>
+              <a:rPr sz="1100" b="0">
+                <a:solidFill>
+                  <a:srgbClr val="475569"/>
+                </a:solidFill>
+                <a:latin typeface="Segoe UI"/>
+              </a:rPr>
+              <a:t>• Documentation: Complete Viva Guide, Demo Scripts, Architecture Docs, and Contribution Matrix verified.</a:t>
+            </a:r>
+          </a:p>
+          <a:p>
+            <a:pPr algn="l">
+              <a:spcAft>
+                <a:spcPts val="0"/>
+              </a:spcAft>
+            </a:pPr>
+            <a:r>
+              <a:rPr sz="1300" b="1">
+                <a:solidFill>
+                  <a:srgbClr val="2563EB"/>
+                </a:solidFill>
+                <a:latin typeface="Segoe UI"/>
+              </a:rPr>
+              <a:t>Thank you. Questions &amp; Technical Demonstration Welcome.</a:t>
             </a:r>
           </a:p>
         </p:txBody>
@@ -5969,7 +6894,7 @@
           <a:noFill/>
         </p:spPr>
         <p:txBody>
-          <a:bodyPr wrap="none">
+          <a:bodyPr wrap="square" lIns="0" rIns="0" tIns="0" bIns="0">
             <a:spAutoFit/>
           </a:bodyPr>
           <a:lstStyle/>
@@ -5996,7 +6921,7 @@
         <p:spPr>
           <a:xfrm>
             <a:off x="731520" y="777240"/>
-            <a:ext cx="10698480" cy="640080"/>
+            <a:ext cx="10698480" cy="731520"/>
           </a:xfrm>
           <a:prstGeom prst="rect">
             <a:avLst/>
@@ -6004,14 +6929,14 @@
           <a:noFill/>
         </p:spPr>
         <p:txBody>
-          <a:bodyPr wrap="square" lIns="0" tIns="0" rIns="0" bIns="0">
+          <a:bodyPr wrap="square" lIns="0" rIns="0" tIns="0" bIns="0">
             <a:spAutoFit/>
           </a:bodyPr>
           <a:lstStyle/>
           <a:p>
             <a:pPr algn="l">
               <a:spcAft>
-                <a:spcPts val="200"/>
+                <a:spcPts val="300"/>
               </a:spcAft>
             </a:pPr>
             <a:r>
@@ -6051,7 +6976,7 @@
         <p:spPr>
           <a:xfrm>
             <a:off x="731520" y="1783080"/>
-            <a:ext cx="3429000" cy="4389120"/>
+            <a:ext cx="3429000" cy="4480560"/>
           </a:xfrm>
           <a:prstGeom prst="roundRect">
             <a:avLst/>
@@ -6089,100 +7014,13 @@
       </p:sp>
       <p:sp>
         <p:nvSpPr>
-          <p:cNvPr id="7" name="TextBox 6"/>
-          <p:cNvSpPr txBox="1"/>
-          <p:nvPr/>
-        </p:nvSpPr>
-        <p:spPr>
-          <a:xfrm>
-            <a:off x="914400" y="2377440"/>
-            <a:ext cx="3063240" cy="3840480"/>
-          </a:xfrm>
-          <a:prstGeom prst="rect">
-            <a:avLst/>
-          </a:prstGeom>
-          <a:noFill/>
-        </p:spPr>
-        <p:txBody>
-          <a:bodyPr wrap="none">
-            <a:spAutoFit/>
-          </a:bodyPr>
-          <a:lstStyle/>
-          <a:p>
-            <a:pPr algn="l">
-              <a:spcAft>
-                <a:spcPts val="1000"/>
-              </a:spcAft>
-            </a:pPr>
-            <a:r>
-              <a:rPr sz="1500" b="1">
-                <a:solidFill>
-                  <a:srgbClr val="0F172A"/>
-                </a:solidFill>
-                <a:latin typeface="Segoe UI"/>
-              </a:rPr>
-              <a:t>Imperative Script Blindness</a:t>
-            </a:r>
-          </a:p>
-          <a:p>
-            <a:pPr algn="l">
-              <a:spcAft>
-                <a:spcPts val="800"/>
-              </a:spcAft>
-            </a:pPr>
-            <a:r>
-              <a:rPr sz="1200" b="0">
-                <a:solidFill>
-                  <a:srgbClr val="475569"/>
-                </a:solidFill>
-                <a:latin typeface="Segoe UI"/>
-              </a:rPr>
-              <a:t>• Standard CI runs tests in isolation (`pytest`, `npm test`) with zero semantic cross-artifact reasoning.</a:t>
-            </a:r>
-          </a:p>
-          <a:p>
-            <a:pPr algn="l">
-              <a:spcAft>
-                <a:spcPts val="800"/>
-              </a:spcAft>
-            </a:pPr>
-            <a:r>
-              <a:rPr sz="1200" b="0">
-                <a:solidFill>
-                  <a:srgbClr val="475569"/>
-                </a:solidFill>
-                <a:latin typeface="Segoe UI"/>
-              </a:rPr>
-              <a:t>• Static linters flag style issues but miss holistic architectural drift.</a:t>
-            </a:r>
-          </a:p>
-          <a:p>
-            <a:pPr algn="l">
-              <a:spcAft>
-                <a:spcPts val="0"/>
-              </a:spcAft>
-            </a:pPr>
-            <a:r>
-              <a:rPr sz="1200" b="0">
-                <a:solidFill>
-                  <a:srgbClr val="475569"/>
-                </a:solidFill>
-                <a:latin typeface="Segoe UI"/>
-              </a:rPr>
-              <a:t>• A PR can have 100% test pass rate while silently breaking Docker port mappings or database connections.</a:t>
-            </a:r>
-          </a:p>
-        </p:txBody>
-      </p:sp>
-      <p:sp>
-        <p:nvSpPr>
-          <p:cNvPr id="8" name="Rounded Rectangle 7"/>
+          <p:cNvPr id="7" name="Rounded Rectangle 6"/>
           <p:cNvSpPr/>
           <p:nvPr/>
         </p:nvSpPr>
         <p:spPr>
           <a:xfrm>
-            <a:off x="914400" y="2011680"/>
+            <a:off x="960120" y="2011680"/>
             <a:ext cx="1645920" cy="256032"/>
           </a:xfrm>
           <a:prstGeom prst="roundRect">
@@ -6228,6 +7066,93 @@
       </p:sp>
       <p:sp>
         <p:nvSpPr>
+          <p:cNvPr id="8" name="TextBox 7"/>
+          <p:cNvSpPr txBox="1"/>
+          <p:nvPr/>
+        </p:nvSpPr>
+        <p:spPr>
+          <a:xfrm>
+            <a:off x="960120" y="2377440"/>
+            <a:ext cx="2971800" cy="3703320"/>
+          </a:xfrm>
+          <a:prstGeom prst="rect">
+            <a:avLst/>
+          </a:prstGeom>
+          <a:noFill/>
+        </p:spPr>
+        <p:txBody>
+          <a:bodyPr wrap="square" lIns="0" rIns="0" tIns="0" bIns="0">
+            <a:spAutoFit/>
+          </a:bodyPr>
+          <a:lstStyle/>
+          <a:p>
+            <a:pPr algn="l">
+              <a:spcAft>
+                <a:spcPts val="1000"/>
+              </a:spcAft>
+            </a:pPr>
+            <a:r>
+              <a:rPr sz="1500" b="1">
+                <a:solidFill>
+                  <a:srgbClr val="0F172A"/>
+                </a:solidFill>
+                <a:latin typeface="Segoe UI"/>
+              </a:rPr>
+              <a:t>Imperative Script Blindness</a:t>
+            </a:r>
+          </a:p>
+          <a:p>
+            <a:pPr algn="l">
+              <a:spcAft>
+                <a:spcPts val="800"/>
+              </a:spcAft>
+            </a:pPr>
+            <a:r>
+              <a:rPr sz="1100" b="0">
+                <a:solidFill>
+                  <a:srgbClr val="475569"/>
+                </a:solidFill>
+                <a:latin typeface="Segoe UI"/>
+              </a:rPr>
+              <a:t>• Standard CI runs tests in isolation (pytest, npm test) with zero semantic cross-artifact reasoning.</a:t>
+            </a:r>
+          </a:p>
+          <a:p>
+            <a:pPr algn="l">
+              <a:spcAft>
+                <a:spcPts val="800"/>
+              </a:spcAft>
+            </a:pPr>
+            <a:r>
+              <a:rPr sz="1100" b="0">
+                <a:solidFill>
+                  <a:srgbClr val="475569"/>
+                </a:solidFill>
+                <a:latin typeface="Segoe UI"/>
+              </a:rPr>
+              <a:t>• Static linters flag style nits but miss holistic architectural drift.</a:t>
+            </a:r>
+          </a:p>
+          <a:p>
+            <a:pPr algn="l">
+              <a:spcAft>
+                <a:spcPts val="0"/>
+              </a:spcAft>
+            </a:pPr>
+            <a:r>
+              <a:rPr sz="1100" b="0">
+                <a:solidFill>
+                  <a:srgbClr val="475569"/>
+                </a:solidFill>
+                <a:latin typeface="Segoe UI"/>
+              </a:rPr>
+              <a:t>• A pull request can have 100% test pass rate while silently breaking Docker port mappings or database URLs.</a:t>
+            </a:r>
+          </a:p>
+        </p:txBody>
+      </p:sp>
+      <p:sp>
+        <p:nvSpPr>
           <p:cNvPr id="9" name="Rounded Rectangle 8"/>
           <p:cNvSpPr/>
           <p:nvPr/>
@@ -6235,7 +7160,7 @@
         <p:spPr>
           <a:xfrm>
             <a:off x="4379976" y="1783080"/>
-            <a:ext cx="3429000" cy="4389120"/>
+            <a:ext cx="3429000" cy="4480560"/>
           </a:xfrm>
           <a:prstGeom prst="roundRect">
             <a:avLst/>
@@ -6279,8 +7204,8 @@
         </p:nvSpPr>
         <p:spPr>
           <a:xfrm>
-            <a:off x="4562856" y="2011680"/>
-            <a:ext cx="2011680" cy="256032"/>
+            <a:off x="4608576" y="2011680"/>
+            <a:ext cx="1828800" cy="256032"/>
           </a:xfrm>
           <a:prstGeom prst="roundRect">
             <a:avLst/>
@@ -6331,8 +7256,8 @@
         </p:nvSpPr>
         <p:spPr>
           <a:xfrm>
-            <a:off x="4562856" y="2377440"/>
-            <a:ext cx="3063240" cy="3840480"/>
+            <a:off x="4608576" y="2377440"/>
+            <a:ext cx="2971800" cy="3703320"/>
           </a:xfrm>
           <a:prstGeom prst="rect">
             <a:avLst/>
@@ -6340,7 +7265,7 @@
           <a:noFill/>
         </p:spPr>
         <p:txBody>
-          <a:bodyPr wrap="none">
+          <a:bodyPr wrap="square" lIns="0" rIns="0" tIns="0" bIns="0">
             <a:spAutoFit/>
           </a:bodyPr>
           <a:lstStyle/>
@@ -6367,13 +7292,13 @@
               </a:spcAft>
             </a:pPr>
             <a:r>
-              <a:rPr sz="1200" b="0">
+              <a:rPr sz="1100" b="0">
                 <a:solidFill>
                   <a:srgbClr val="475569"/>
                 </a:solidFill>
                 <a:latin typeface="Segoe UI"/>
               </a:rPr>
-              <a:t>• Env Var Mismatches: Code consumes `DATABASE_URL` but Docker Compose defines `DB_URL`.</a:t>
+              <a:t>• Environment Drift: Code consumes DATABASE_URL but Docker Compose defines DB_URL.</a:t>
             </a:r>
           </a:p>
           <a:p>
@@ -6383,13 +7308,13 @@
               </a:spcAft>
             </a:pPr>
             <a:r>
-              <a:rPr sz="1200" b="0">
+              <a:rPr sz="1100" b="0">
                 <a:solidFill>
                   <a:srgbClr val="475569"/>
                 </a:solidFill>
                 <a:latin typeface="Segoe UI"/>
               </a:rPr>
-              <a:t>• Security Drift: Hardcoded secrets, unpinned container tags (`:latest`), or containers running as root.</a:t>
+              <a:t>• Security Drift: Hardcoded credentials, unpinned container tags (:latest), or containers running as root.</a:t>
             </a:r>
           </a:p>
           <a:p>
@@ -6399,13 +7324,13 @@
               </a:spcAft>
             </a:pPr>
             <a:r>
-              <a:rPr sz="1200" b="0">
+              <a:rPr sz="1100" b="0">
                 <a:solidFill>
                   <a:srgbClr val="475569"/>
                 </a:solidFill>
                 <a:latin typeface="Segoe UI"/>
               </a:rPr>
-              <a:t>• Dependency Vulnerabilities: Direct or transitive packages affected by published CVEs.</a:t>
+              <a:t>• Dependency Vulns: Direct or transitive packages affected by published CVEs.</a:t>
             </a:r>
           </a:p>
         </p:txBody>
@@ -6419,7 +7344,7 @@
         <p:spPr>
           <a:xfrm>
             <a:off x="8028431" y="1783080"/>
-            <a:ext cx="3429000" cy="4389120"/>
+            <a:ext cx="3429000" cy="4480560"/>
           </a:xfrm>
           <a:prstGeom prst="roundRect">
             <a:avLst/>
@@ -6463,8 +7388,8 @@
         </p:nvSpPr>
         <p:spPr>
           <a:xfrm>
-            <a:off x="8211311" y="2011680"/>
-            <a:ext cx="2011680" cy="256032"/>
+            <a:off x="8257031" y="2011680"/>
+            <a:ext cx="1828800" cy="256032"/>
           </a:xfrm>
           <a:prstGeom prst="roundRect">
             <a:avLst/>
@@ -6515,8 +7440,8 @@
         </p:nvSpPr>
         <p:spPr>
           <a:xfrm>
-            <a:off x="8211311" y="2377440"/>
-            <a:ext cx="3063240" cy="3840480"/>
+            <a:off x="8257031" y="2377440"/>
+            <a:ext cx="2971800" cy="3703320"/>
           </a:xfrm>
           <a:prstGeom prst="rect">
             <a:avLst/>
@@ -6524,7 +7449,7 @@
           <a:noFill/>
         </p:spPr>
         <p:txBody>
-          <a:bodyPr wrap="none">
+          <a:bodyPr wrap="square" lIns="0" rIns="0" tIns="0" bIns="0">
             <a:spAutoFit/>
           </a:bodyPr>
           <a:lstStyle/>
@@ -6551,7 +7476,7 @@
               </a:spcAft>
             </a:pPr>
             <a:r>
-              <a:rPr sz="1200" b="0">
+              <a:rPr sz="1100" b="0">
                 <a:solidFill>
                   <a:srgbClr val="475569"/>
                 </a:solidFill>
@@ -6567,7 +7492,7 @@
               </a:spcAft>
             </a:pPr>
             <a:r>
-              <a:rPr sz="1200" b="0">
+              <a:rPr sz="1100" b="0">
                 <a:solidFill>
                   <a:srgbClr val="475569"/>
                 </a:solidFill>
@@ -6583,7 +7508,7 @@
               </a:spcAft>
             </a:pPr>
             <a:r>
-              <a:rPr sz="1200" b="0">
+              <a:rPr sz="1100" b="0">
                 <a:solidFill>
                   <a:srgbClr val="475569"/>
                 </a:solidFill>
@@ -6724,7 +7649,7 @@
           <a:noFill/>
         </p:spPr>
         <p:txBody>
-          <a:bodyPr wrap="none">
+          <a:bodyPr wrap="square" lIns="0" rIns="0" tIns="0" bIns="0">
             <a:spAutoFit/>
           </a:bodyPr>
           <a:lstStyle/>
@@ -6751,7 +7676,7 @@
         <p:spPr>
           <a:xfrm>
             <a:off x="731520" y="777240"/>
-            <a:ext cx="10698480" cy="640080"/>
+            <a:ext cx="10698480" cy="731520"/>
           </a:xfrm>
           <a:prstGeom prst="rect">
             <a:avLst/>
@@ -6759,14 +7684,14 @@
           <a:noFill/>
         </p:spPr>
         <p:txBody>
-          <a:bodyPr wrap="square" lIns="0" tIns="0" rIns="0" bIns="0">
+          <a:bodyPr wrap="square" lIns="0" rIns="0" tIns="0" bIns="0">
             <a:spAutoFit/>
           </a:bodyPr>
           <a:lstStyle/>
           <a:p>
             <a:pPr algn="l">
               <a:spcAft>
-                <a:spcPts val="200"/>
+                <a:spcPts val="300"/>
               </a:spcAft>
             </a:pPr>
             <a:r>
@@ -6806,7 +7731,7 @@
         <p:spPr>
           <a:xfrm>
             <a:off x="731520" y="1783080"/>
-            <a:ext cx="2523744" cy="4389120"/>
+            <a:ext cx="2523744" cy="4480560"/>
           </a:xfrm>
           <a:prstGeom prst="roundRect">
             <a:avLst/>
@@ -6883,7 +7808,7 @@
           <a:p>
             <a:pPr algn="ctr"/>
             <a:r>
-              <a:rPr sz="1000" b="1">
+              <a:rPr sz="900" b="1">
                 <a:solidFill>
                   <a:srgbClr val="2563EB"/>
                 </a:solidFill>
@@ -6903,7 +7828,7 @@
         <p:spPr>
           <a:xfrm>
             <a:off x="914400" y="2377440"/>
-            <a:ext cx="2157984" cy="3840480"/>
+            <a:ext cx="2157984" cy="3703320"/>
           </a:xfrm>
           <a:prstGeom prst="rect">
             <a:avLst/>
@@ -6911,7 +7836,7 @@
           <a:noFill/>
         </p:spPr>
         <p:txBody>
-          <a:bodyPr wrap="none">
+          <a:bodyPr wrap="square" lIns="0" rIns="0" tIns="0" bIns="0">
             <a:spAutoFit/>
           </a:bodyPr>
           <a:lstStyle/>
@@ -6960,7 +7885,7 @@
                 </a:solidFill>
                 <a:latin typeface="Segoe UI"/>
               </a:rPr>
-              <a:t>• Secret Redaction pre-scrubbing regex.</a:t>
+              <a:t>• Pre-ingestion regex secret scrubbing.</a:t>
             </a:r>
           </a:p>
           <a:p>
@@ -6976,7 +7901,7 @@
                 </a:solidFill>
                 <a:latin typeface="Segoe UI"/>
               </a:rPr>
-              <a:t>• Planning Agent dynamically activates domain agents based on touched file types.</a:t>
+              <a:t>• Planner dynamically activates domain agents based on touched file types.</a:t>
             </a:r>
           </a:p>
           <a:p>
@@ -6992,7 +7917,7 @@
                 </a:solidFill>
                 <a:latin typeface="Segoe UI"/>
               </a:rPr>
-              <a:t>• Ingestion limits: 2,000 files / 200MB.</a:t>
+              <a:t>• Safe limits: 2,000 files &amp; 200MB.</a:t>
             </a:r>
           </a:p>
         </p:txBody>
@@ -7006,7 +7931,7 @@
         <p:spPr>
           <a:xfrm>
             <a:off x="3465575" y="1783080"/>
-            <a:ext cx="2523744" cy="4389120"/>
+            <a:ext cx="2523744" cy="4480560"/>
           </a:xfrm>
           <a:prstGeom prst="roundRect">
             <a:avLst/>
@@ -7083,7 +8008,7 @@
           <a:p>
             <a:pPr algn="ctr"/>
             <a:r>
-              <a:rPr sz="1000" b="1">
+              <a:rPr sz="900" b="1">
                 <a:solidFill>
                   <a:srgbClr val="2563EB"/>
                 </a:solidFill>
@@ -7103,7 +8028,7 @@
         <p:spPr>
           <a:xfrm>
             <a:off x="3648456" y="2377440"/>
-            <a:ext cx="2157984" cy="3840480"/>
+            <a:ext cx="2157984" cy="3703320"/>
           </a:xfrm>
           <a:prstGeom prst="rect">
             <a:avLst/>
@@ -7111,7 +8036,7 @@
           <a:noFill/>
         </p:spPr>
         <p:txBody>
-          <a:bodyPr wrap="none">
+          <a:bodyPr wrap="square" lIns="0" rIns="0" tIns="0" bIns="0">
             <a:spAutoFit/>
           </a:bodyPr>
           <a:lstStyle/>
@@ -7238,7 +8163,7 @@
         <p:spPr>
           <a:xfrm>
             <a:off x="6199631" y="1783080"/>
-            <a:ext cx="2523744" cy="4389120"/>
+            <a:ext cx="2523744" cy="4480560"/>
           </a:xfrm>
           <a:prstGeom prst="roundRect">
             <a:avLst/>
@@ -7315,7 +8240,7 @@
           <a:p>
             <a:pPr algn="ctr"/>
             <a:r>
-              <a:rPr sz="1000" b="1">
+              <a:rPr sz="900" b="1">
                 <a:solidFill>
                   <a:srgbClr val="7E22CE"/>
                 </a:solidFill>
@@ -7335,7 +8260,7 @@
         <p:spPr>
           <a:xfrm>
             <a:off x="6382512" y="2377440"/>
-            <a:ext cx="2157984" cy="3840480"/>
+            <a:ext cx="2157984" cy="3703320"/>
           </a:xfrm>
           <a:prstGeom prst="rect">
             <a:avLst/>
@@ -7343,7 +8268,7 @@
           <a:noFill/>
         </p:spPr>
         <p:txBody>
-          <a:bodyPr wrap="none">
+          <a:bodyPr wrap="square" lIns="0" rIns="0" tIns="0" bIns="0">
             <a:spAutoFit/>
           </a:bodyPr>
           <a:lstStyle/>
@@ -7454,7 +8379,7 @@
         <p:spPr>
           <a:xfrm>
             <a:off x="8933688" y="1783080"/>
-            <a:ext cx="2523744" cy="4389120"/>
+            <a:ext cx="2523744" cy="4480560"/>
           </a:xfrm>
           <a:prstGeom prst="roundRect">
             <a:avLst/>
@@ -7531,7 +8456,7 @@
           <a:p>
             <a:pPr algn="ctr"/>
             <a:r>
-              <a:rPr sz="1000" b="1">
+              <a:rPr sz="900" b="1">
                 <a:solidFill>
                   <a:srgbClr val="2563EB"/>
                 </a:solidFill>
@@ -7551,7 +8476,7 @@
         <p:spPr>
           <a:xfrm>
             <a:off x="9116567" y="2377440"/>
-            <a:ext cx="2157984" cy="3840480"/>
+            <a:ext cx="2157984" cy="3703320"/>
           </a:xfrm>
           <a:prstGeom prst="rect">
             <a:avLst/>
@@ -7559,7 +8484,7 @@
           <a:noFill/>
         </p:spPr>
         <p:txBody>
-          <a:bodyPr wrap="none">
+          <a:bodyPr wrap="square" lIns="0" rIns="0" tIns="0" bIns="0">
             <a:spAutoFit/>
           </a:bodyPr>
           <a:lstStyle/>
@@ -7775,7 +8700,7 @@
           <a:noFill/>
         </p:spPr>
         <p:txBody>
-          <a:bodyPr wrap="none">
+          <a:bodyPr wrap="square" lIns="0" rIns="0" tIns="0" bIns="0">
             <a:spAutoFit/>
           </a:bodyPr>
           <a:lstStyle/>
@@ -7802,7 +8727,7 @@
         <p:spPr>
           <a:xfrm>
             <a:off x="731520" y="777240"/>
-            <a:ext cx="10698480" cy="640080"/>
+            <a:ext cx="10698480" cy="731520"/>
           </a:xfrm>
           <a:prstGeom prst="rect">
             <a:avLst/>
@@ -7810,14 +8735,14 @@
           <a:noFill/>
         </p:spPr>
         <p:txBody>
-          <a:bodyPr wrap="square" lIns="0" tIns="0" rIns="0" bIns="0">
+          <a:bodyPr wrap="square" lIns="0" rIns="0" tIns="0" bIns="0">
             <a:spAutoFit/>
           </a:bodyPr>
           <a:lstStyle/>
           <a:p>
             <a:pPr algn="l">
               <a:spcAft>
-                <a:spcPts val="200"/>
+                <a:spcPts val="300"/>
               </a:spcAft>
             </a:pPr>
             <a:r>
@@ -7910,7 +8835,7 @@
           <a:noFill/>
         </p:spPr>
         <p:txBody>
-          <a:bodyPr wrap="none">
+          <a:bodyPr wrap="square" lIns="0" rIns="0" tIns="0" bIns="0">
             <a:spAutoFit/>
           </a:bodyPr>
           <a:lstStyle/>
@@ -8026,7 +8951,7 @@
           <a:noFill/>
         </p:spPr>
         <p:txBody>
-          <a:bodyPr wrap="none">
+          <a:bodyPr wrap="square" lIns="0" rIns="0" tIns="0" bIns="0">
             <a:spAutoFit/>
           </a:bodyPr>
           <a:lstStyle/>
@@ -8142,7 +9067,7 @@
           <a:noFill/>
         </p:spPr>
         <p:txBody>
-          <a:bodyPr wrap="none">
+          <a:bodyPr wrap="square" lIns="0" rIns="0" tIns="0" bIns="0">
             <a:spAutoFit/>
           </a:bodyPr>
           <a:lstStyle/>
@@ -8258,7 +9183,7 @@
           <a:noFill/>
         </p:spPr>
         <p:txBody>
-          <a:bodyPr wrap="none">
+          <a:bodyPr wrap="square" lIns="0" rIns="0" tIns="0" bIns="0">
             <a:spAutoFit/>
           </a:bodyPr>
           <a:lstStyle/>
@@ -8291,7 +9216,7 @@
                 </a:solidFill>
                 <a:latin typeface="Segoe UI"/>
               </a:rPr>
-              <a:t>• Identifies untested critical execution paths touched in diffs (e.g. auth, billing, payment tokens).</a:t>
+              <a:t>• Identifies untested critical execution paths touched in diffs (auth, billing, payment tokens).</a:t>
             </a:r>
           </a:p>
           <a:p>
@@ -8374,7 +9299,7 @@
           <a:noFill/>
         </p:spPr>
         <p:txBody>
-          <a:bodyPr wrap="none">
+          <a:bodyPr wrap="square" lIns="0" rIns="0" tIns="0" bIns="0">
             <a:spAutoFit/>
           </a:bodyPr>
           <a:lstStyle/>
@@ -8558,7 +9483,7 @@
           <a:noFill/>
         </p:spPr>
         <p:txBody>
-          <a:bodyPr wrap="none">
+          <a:bodyPr wrap="square" lIns="0" rIns="0" tIns="0" bIns="0">
             <a:spAutoFit/>
           </a:bodyPr>
           <a:lstStyle/>
@@ -8585,7 +9510,7 @@
         <p:spPr>
           <a:xfrm>
             <a:off x="731520" y="777240"/>
-            <a:ext cx="10698480" cy="640080"/>
+            <a:ext cx="10698480" cy="731520"/>
           </a:xfrm>
           <a:prstGeom prst="rect">
             <a:avLst/>
@@ -8593,14 +9518,14 @@
           <a:noFill/>
         </p:spPr>
         <p:txBody>
-          <a:bodyPr wrap="square" lIns="0" tIns="0" rIns="0" bIns="0">
+          <a:bodyPr wrap="square" lIns="0" rIns="0" tIns="0" bIns="0">
             <a:spAutoFit/>
           </a:bodyPr>
           <a:lstStyle/>
           <a:p>
             <a:pPr algn="l">
               <a:spcAft>
-                <a:spcPts val="200"/>
+                <a:spcPts val="300"/>
               </a:spcAft>
             </a:pPr>
             <a:r>
@@ -8640,7 +9565,7 @@
         <p:spPr>
           <a:xfrm>
             <a:off x="731520" y="1783080"/>
-            <a:ext cx="5212080" cy="4389120"/>
+            <a:ext cx="5212080" cy="4480560"/>
           </a:xfrm>
           <a:prstGeom prst="roundRect">
             <a:avLst/>
@@ -8684,8 +9609,8 @@
         </p:nvSpPr>
         <p:spPr>
           <a:xfrm>
-            <a:off x="914400" y="2011680"/>
-            <a:ext cx="4846320" cy="3931920"/>
+            <a:off x="960120" y="1965960"/>
+            <a:ext cx="4754880" cy="4114800"/>
           </a:xfrm>
           <a:prstGeom prst="rect">
             <a:avLst/>
@@ -8693,14 +9618,14 @@
           <a:noFill/>
         </p:spPr>
         <p:txBody>
-          <a:bodyPr wrap="none">
+          <a:bodyPr wrap="square" lIns="0" rIns="0" tIns="0" bIns="0">
             <a:spAutoFit/>
           </a:bodyPr>
           <a:lstStyle/>
           <a:p>
             <a:pPr algn="l">
               <a:spcAft>
-                <a:spcPts val="1200"/>
+                <a:spcPts val="1000"/>
               </a:spcAft>
             </a:pPr>
             <a:r>
@@ -8720,13 +9645,13 @@
               </a:spcAft>
             </a:pPr>
             <a:r>
-              <a:rPr sz="1200" b="0">
+              <a:rPr sz="1100" b="0">
                 <a:solidFill>
                   <a:srgbClr val="475569"/>
                 </a:solidFill>
                 <a:latin typeface="Segoe UI"/>
               </a:rPr>
-              <a:t>Every finding emitted by an agent must survive strict physical inspection by the Critic Agent (`critic_agent.py`):</a:t>
+              <a:t>Every finding emitted by an agent must survive strict physical inspection by the Critic Agent (critic_agent.py):</a:t>
             </a:r>
           </a:p>
           <a:p>
@@ -8736,7 +9661,7 @@
               </a:spcAft>
             </a:pPr>
             <a:r>
-              <a:rPr sz="1200" b="1">
+              <a:rPr sz="1100" b="1">
                 <a:solidFill>
                   <a:srgbClr val="0F172A"/>
                 </a:solidFill>
@@ -8752,7 +9677,7 @@
               </a:spcAft>
             </a:pPr>
             <a:r>
-              <a:rPr sz="1200" b="1">
+              <a:rPr sz="1100" b="1">
                 <a:solidFill>
                   <a:srgbClr val="0F172A"/>
                 </a:solidFill>
@@ -8768,7 +9693,7 @@
               </a:spcAft>
             </a:pPr>
             <a:r>
-              <a:rPr sz="1200" b="1">
+              <a:rPr sz="1100" b="1">
                 <a:solidFill>
                   <a:srgbClr val="0F172A"/>
                 </a:solidFill>
@@ -8784,7 +9709,7 @@
               </a:spcAft>
             </a:pPr>
             <a:r>
-              <a:rPr sz="1200" b="1">
+              <a:rPr sz="1100" b="1">
                 <a:solidFill>
                   <a:srgbClr val="0F172A"/>
                 </a:solidFill>
@@ -8804,7 +9729,7 @@
         <p:spPr>
           <a:xfrm>
             <a:off x="6217920" y="1783080"/>
-            <a:ext cx="5242255" cy="4389120"/>
+            <a:ext cx="5242255" cy="4480560"/>
           </a:xfrm>
           <a:prstGeom prst="roundRect">
             <a:avLst/>
@@ -8842,126 +9767,7 @@
       </p:sp>
       <p:sp>
         <p:nvSpPr>
-          <p:cNvPr id="9" name="TextBox 8"/>
-          <p:cNvSpPr txBox="1"/>
-          <p:nvPr/>
-        </p:nvSpPr>
-        <p:spPr>
-          <a:xfrm>
-            <a:off x="6492240" y="2423160"/>
-            <a:ext cx="4663440" cy="3931920"/>
-          </a:xfrm>
-          <a:prstGeom prst="rect">
-            <a:avLst/>
-          </a:prstGeom>
-          <a:noFill/>
-        </p:spPr>
-        <p:txBody>
-          <a:bodyPr wrap="none">
-            <a:spAutoFit/>
-          </a:bodyPr>
-          <a:lstStyle/>
-          <a:p>
-            <a:pPr algn="l">
-              <a:spcAft>
-                <a:spcPts val="1200"/>
-              </a:spcAft>
-            </a:pPr>
-            <a:r>
-              <a:rPr sz="1600" b="1">
-                <a:solidFill>
-                  <a:srgbClr val="0F172A"/>
-                </a:solidFill>
-                <a:latin typeface="Segoe UI"/>
-              </a:rPr>
-              <a:t>Benchmark Results on Clean Repo</a:t>
-            </a:r>
-          </a:p>
-          <a:p>
-            <a:pPr algn="l">
-              <a:spcAft>
-                <a:spcPts val="800"/>
-              </a:spcAft>
-            </a:pPr>
-            <a:r>
-              <a:rPr sz="1200" b="0">
-                <a:solidFill>
-                  <a:srgbClr val="475569"/>
-                </a:solidFill>
-                <a:latin typeface="Segoe UI"/>
-              </a:rPr>
-              <a:t>• Unvalidated Candidate Findings: 3 findings generated by raw LLM prompts.</a:t>
-            </a:r>
-          </a:p>
-          <a:p>
-            <a:pPr algn="l">
-              <a:spcAft>
-                <a:spcPts val="1200"/>
-              </a:spcAft>
-            </a:pPr>
-            <a:r>
-              <a:rPr sz="1200" b="0">
-                <a:solidFill>
-                  <a:srgbClr val="DC2626"/>
-                </a:solidFill>
-                <a:latin typeface="Segoe UI"/>
-              </a:rPr>
-              <a:t>• Critic Filter Verdict: All 3 ungrounded findings dropped due to snippet mismatch.</a:t>
-            </a:r>
-          </a:p>
-          <a:p>
-            <a:pPr algn="l">
-              <a:spcAft>
-                <a:spcPts val="800"/>
-              </a:spcAft>
-            </a:pPr>
-            <a:r>
-              <a:rPr sz="1400" b="1">
-                <a:solidFill>
-                  <a:srgbClr val="16A34A"/>
-                </a:solidFill>
-                <a:latin typeface="Segoe UI"/>
-              </a:rPr>
-              <a:t>• Final Verified Findings on Clean Baseline: 0</a:t>
-            </a:r>
-          </a:p>
-          <a:p>
-            <a:pPr algn="l">
-              <a:spcAft>
-                <a:spcPts val="1600"/>
-              </a:spcAft>
-            </a:pPr>
-            <a:r>
-              <a:rPr sz="1400" b="1">
-                <a:solidFill>
-                  <a:srgbClr val="16A34A"/>
-                </a:solidFill>
-                <a:latin typeface="Segoe UI"/>
-              </a:rPr>
-              <a:t>• Final False Positive Rate: 0.0%</a:t>
-            </a:r>
-          </a:p>
-          <a:p>
-            <a:pPr algn="l">
-              <a:spcAft>
-                <a:spcPts val="0"/>
-              </a:spcAft>
-            </a:pPr>
-            <a:r>
-              <a:rPr sz="1200" b="0">
-                <a:solidFill>
-                  <a:srgbClr val="0F172A"/>
-                </a:solidFill>
-                <a:latin typeface="Segoe UI"/>
-              </a:rPr>
-              <a:t>Key Takeaway: The Critic reflection step is what transforms DeploySafe from an untrusted toy into a robust production-grade safety gate.</a:t>
-            </a:r>
-          </a:p>
-        </p:txBody>
-      </p:sp>
-      <p:sp>
-        <p:nvSpPr>
-          <p:cNvPr id="10" name="Rounded Rectangle 9"/>
+          <p:cNvPr id="9" name="Rounded Rectangle 8"/>
           <p:cNvSpPr/>
           <p:nvPr/>
         </p:nvSpPr>
@@ -9000,13 +9806,132 @@
           <a:p>
             <a:pPr algn="ctr"/>
             <a:r>
-              <a:rPr sz="1000" b="1">
+              <a:rPr sz="900" b="1">
                 <a:solidFill>
                   <a:srgbClr val="16A34A"/>
                 </a:solidFill>
                 <a:latin typeface="Segoe UI"/>
               </a:rPr>
               <a:t>EMPIRICAL BENCHMARK</a:t>
+            </a:r>
+          </a:p>
+        </p:txBody>
+      </p:sp>
+      <p:sp>
+        <p:nvSpPr>
+          <p:cNvPr id="10" name="TextBox 9"/>
+          <p:cNvSpPr txBox="1"/>
+          <p:nvPr/>
+        </p:nvSpPr>
+        <p:spPr>
+          <a:xfrm>
+            <a:off x="6492240" y="2423160"/>
+            <a:ext cx="4693615" cy="3657600"/>
+          </a:xfrm>
+          <a:prstGeom prst="rect">
+            <a:avLst/>
+          </a:prstGeom>
+          <a:noFill/>
+        </p:spPr>
+        <p:txBody>
+          <a:bodyPr wrap="square" lIns="0" rIns="0" tIns="0" bIns="0">
+            <a:spAutoFit/>
+          </a:bodyPr>
+          <a:lstStyle/>
+          <a:p>
+            <a:pPr algn="l">
+              <a:spcAft>
+                <a:spcPts val="1000"/>
+              </a:spcAft>
+            </a:pPr>
+            <a:r>
+              <a:rPr sz="1600" b="1">
+                <a:solidFill>
+                  <a:srgbClr val="0F172A"/>
+                </a:solidFill>
+                <a:latin typeface="Segoe UI"/>
+              </a:rPr>
+              <a:t>Benchmark Results on Clean Baseline</a:t>
+            </a:r>
+          </a:p>
+          <a:p>
+            <a:pPr algn="l">
+              <a:spcAft>
+                <a:spcPts val="800"/>
+              </a:spcAft>
+            </a:pPr>
+            <a:r>
+              <a:rPr sz="1100" b="0">
+                <a:solidFill>
+                  <a:srgbClr val="475569"/>
+                </a:solidFill>
+                <a:latin typeface="Segoe UI"/>
+              </a:rPr>
+              <a:t>• Unvalidated Candidate Findings: 3 findings generated by raw LLM prompts.</a:t>
+            </a:r>
+          </a:p>
+          <a:p>
+            <a:pPr algn="l">
+              <a:spcAft>
+                <a:spcPts val="1200"/>
+              </a:spcAft>
+            </a:pPr>
+            <a:r>
+              <a:rPr sz="1100" b="0">
+                <a:solidFill>
+                  <a:srgbClr val="DC2626"/>
+                </a:solidFill>
+                <a:latin typeface="Segoe UI"/>
+              </a:rPr>
+              <a:t>• Critic Filter Verdict: All 3 ungrounded findings dropped due to snippet mismatch.</a:t>
+            </a:r>
+          </a:p>
+          <a:p>
+            <a:pPr algn="l">
+              <a:spcAft>
+                <a:spcPts val="600"/>
+              </a:spcAft>
+            </a:pPr>
+            <a:r>
+              <a:rPr sz="1300" b="1">
+                <a:solidFill>
+                  <a:srgbClr val="16A34A"/>
+                </a:solidFill>
+                <a:latin typeface="Segoe UI"/>
+              </a:rPr>
+              <a:t>• Final Verified Findings on Clean Baseline: 0</a:t>
+            </a:r>
+          </a:p>
+          <a:p>
+            <a:pPr algn="l">
+              <a:spcAft>
+                <a:spcPts val="1400"/>
+              </a:spcAft>
+            </a:pPr>
+            <a:r>
+              <a:rPr sz="1400" b="1">
+                <a:solidFill>
+                  <a:srgbClr val="16A34A"/>
+                </a:solidFill>
+                <a:latin typeface="Segoe UI"/>
+              </a:rPr>
+              <a:t>• Final False Positive Rate: 0.0%</a:t>
+            </a:r>
+          </a:p>
+          <a:p>
+            <a:pPr algn="l">
+              <a:spcAft>
+                <a:spcPts val="0"/>
+              </a:spcAft>
+            </a:pPr>
+            <a:r>
+              <a:rPr sz="1100" b="0">
+                <a:solidFill>
+                  <a:srgbClr val="0F172A"/>
+                </a:solidFill>
+                <a:latin typeface="Segoe UI"/>
+              </a:rPr>
+              <a:t>Key Takeaway: The Critic reflection step is what transforms DeploySafe from an untrusted toy into a robust production-grade safety gate.</a:t>
             </a:r>
           </a:p>
         </p:txBody>
@@ -9141,7 +10066,7 @@
           <a:noFill/>
         </p:spPr>
         <p:txBody>
-          <a:bodyPr wrap="none">
+          <a:bodyPr wrap="square" lIns="0" rIns="0" tIns="0" bIns="0">
             <a:spAutoFit/>
           </a:bodyPr>
           <a:lstStyle/>
@@ -9168,7 +10093,7 @@
         <p:spPr>
           <a:xfrm>
             <a:off x="731520" y="777240"/>
-            <a:ext cx="10698480" cy="640080"/>
+            <a:ext cx="10698480" cy="731520"/>
           </a:xfrm>
           <a:prstGeom prst="rect">
             <a:avLst/>
@@ -9176,14 +10101,14 @@
           <a:noFill/>
         </p:spPr>
         <p:txBody>
-          <a:bodyPr wrap="square" lIns="0" tIns="0" rIns="0" bIns="0">
+          <a:bodyPr wrap="square" lIns="0" rIns="0" tIns="0" bIns="0">
             <a:spAutoFit/>
           </a:bodyPr>
           <a:lstStyle/>
           <a:p>
             <a:pPr algn="l">
               <a:spcAft>
-                <a:spcPts val="200"/>
+                <a:spcPts val="300"/>
               </a:spcAft>
             </a:pPr>
             <a:r>
@@ -9223,7 +10148,7 @@
         <p:spPr>
           <a:xfrm>
             <a:off x="731520" y="1783080"/>
-            <a:ext cx="3429000" cy="4389120"/>
+            <a:ext cx="3429000" cy="4480560"/>
           </a:xfrm>
           <a:prstGeom prst="roundRect">
             <a:avLst/>
@@ -9261,100 +10186,13 @@
       </p:sp>
       <p:sp>
         <p:nvSpPr>
-          <p:cNvPr id="7" name="TextBox 6"/>
-          <p:cNvSpPr txBox="1"/>
-          <p:nvPr/>
-        </p:nvSpPr>
-        <p:spPr>
-          <a:xfrm>
-            <a:off x="914400" y="2377440"/>
-            <a:ext cx="3063240" cy="3840480"/>
-          </a:xfrm>
-          <a:prstGeom prst="rect">
-            <a:avLst/>
-          </a:prstGeom>
-          <a:noFill/>
-        </p:spPr>
-        <p:txBody>
-          <a:bodyPr wrap="none">
-            <a:spAutoFit/>
-          </a:bodyPr>
-          <a:lstStyle/>
-          <a:p>
-            <a:pPr algn="l">
-              <a:spcAft>
-                <a:spcPts val="1000"/>
-              </a:spcAft>
-            </a:pPr>
-            <a:r>
-              <a:rPr sz="1500" b="1">
-                <a:solidFill>
-                  <a:srgbClr val="0F172A"/>
-                </a:solidFill>
-                <a:latin typeface="Segoe UI"/>
-              </a:rPr>
-              <a:t>Document Chunking</a:t>
-            </a:r>
-          </a:p>
-          <a:p>
-            <a:pPr algn="l">
-              <a:spcAft>
-                <a:spcPts val="800"/>
-              </a:spcAft>
-            </a:pPr>
-            <a:r>
-              <a:rPr sz="1200" b="0">
-                <a:solidFill>
-                  <a:srgbClr val="475569"/>
-                </a:solidFill>
-                <a:latin typeface="Segoe UI"/>
-              </a:rPr>
-              <a:t>• Chunks READMEs, architecture guides, runbooks, and API specs.</a:t>
-            </a:r>
-          </a:p>
-          <a:p>
-            <a:pPr algn="l">
-              <a:spcAft>
-                <a:spcPts val="800"/>
-              </a:spcAft>
-            </a:pPr>
-            <a:r>
-              <a:rPr sz="1200" b="0">
-                <a:solidFill>
-                  <a:srgbClr val="475569"/>
-                </a:solidFill>
-                <a:latin typeface="Segoe UI"/>
-              </a:rPr>
-              <a:t>• Primary Embedding: Google `text-embedding-004` (768 dimensions).</a:t>
-            </a:r>
-          </a:p>
-          <a:p>
-            <a:pPr algn="l">
-              <a:spcAft>
-                <a:spcPts val="0"/>
-              </a:spcAft>
-            </a:pPr>
-            <a:r>
-              <a:rPr sz="1200" b="0">
-                <a:solidFill>
-                  <a:srgbClr val="475569"/>
-                </a:solidFill>
-                <a:latin typeface="Segoe UI"/>
-              </a:rPr>
-              <a:t>• Fallback: Local deterministic hashing embedding when API is offline.</a:t>
-            </a:r>
-          </a:p>
-        </p:txBody>
-      </p:sp>
-      <p:sp>
-        <p:nvSpPr>
-          <p:cNvPr id="8" name="Rounded Rectangle 7"/>
+          <p:cNvPr id="7" name="Rounded Rectangle 6"/>
           <p:cNvSpPr/>
           <p:nvPr/>
         </p:nvSpPr>
         <p:spPr>
           <a:xfrm>
-            <a:off x="914400" y="2011680"/>
+            <a:off x="960120" y="2011680"/>
             <a:ext cx="1645920" cy="256032"/>
           </a:xfrm>
           <a:prstGeom prst="roundRect">
@@ -9387,13 +10225,100 @@
           <a:p>
             <a:pPr algn="ctr"/>
             <a:r>
-              <a:rPr sz="1000" b="1">
+              <a:rPr sz="900" b="1">
                 <a:solidFill>
                   <a:srgbClr val="2563EB"/>
                 </a:solidFill>
                 <a:latin typeface="Segoe UI"/>
               </a:rPr>
               <a:t>INGESTION &amp; EMBED</a:t>
+            </a:r>
+          </a:p>
+        </p:txBody>
+      </p:sp>
+      <p:sp>
+        <p:nvSpPr>
+          <p:cNvPr id="8" name="TextBox 7"/>
+          <p:cNvSpPr txBox="1"/>
+          <p:nvPr/>
+        </p:nvSpPr>
+        <p:spPr>
+          <a:xfrm>
+            <a:off x="960120" y="2377440"/>
+            <a:ext cx="2971800" cy="3703320"/>
+          </a:xfrm>
+          <a:prstGeom prst="rect">
+            <a:avLst/>
+          </a:prstGeom>
+          <a:noFill/>
+        </p:spPr>
+        <p:txBody>
+          <a:bodyPr wrap="square" lIns="0" rIns="0" tIns="0" bIns="0">
+            <a:spAutoFit/>
+          </a:bodyPr>
+          <a:lstStyle/>
+          <a:p>
+            <a:pPr algn="l">
+              <a:spcAft>
+                <a:spcPts val="1000"/>
+              </a:spcAft>
+            </a:pPr>
+            <a:r>
+              <a:rPr sz="1500" b="1">
+                <a:solidFill>
+                  <a:srgbClr val="0F172A"/>
+                </a:solidFill>
+                <a:latin typeface="Segoe UI"/>
+              </a:rPr>
+              <a:t>Document Chunking</a:t>
+            </a:r>
+          </a:p>
+          <a:p>
+            <a:pPr algn="l">
+              <a:spcAft>
+                <a:spcPts val="800"/>
+              </a:spcAft>
+            </a:pPr>
+            <a:r>
+              <a:rPr sz="1100" b="0">
+                <a:solidFill>
+                  <a:srgbClr val="475569"/>
+                </a:solidFill>
+                <a:latin typeface="Segoe UI"/>
+              </a:rPr>
+              <a:t>• Chunks READMEs, architecture guides, runbooks, and API specs.</a:t>
+            </a:r>
+          </a:p>
+          <a:p>
+            <a:pPr algn="l">
+              <a:spcAft>
+                <a:spcPts val="800"/>
+              </a:spcAft>
+            </a:pPr>
+            <a:r>
+              <a:rPr sz="1100" b="0">
+                <a:solidFill>
+                  <a:srgbClr val="475569"/>
+                </a:solidFill>
+                <a:latin typeface="Segoe UI"/>
+              </a:rPr>
+              <a:t>• Primary Embedding: Google text-embedding-004 (768 dimensions).</a:t>
+            </a:r>
+          </a:p>
+          <a:p>
+            <a:pPr algn="l">
+              <a:spcAft>
+                <a:spcPts val="0"/>
+              </a:spcAft>
+            </a:pPr>
+            <a:r>
+              <a:rPr sz="1100" b="0">
+                <a:solidFill>
+                  <a:srgbClr val="475569"/>
+                </a:solidFill>
+                <a:latin typeface="Segoe UI"/>
+              </a:rPr>
+              <a:t>• Fallback: Local deterministic hashing embedding when API is offline.</a:t>
             </a:r>
           </a:p>
         </p:txBody>
@@ -9407,7 +10332,7 @@
         <p:spPr>
           <a:xfrm>
             <a:off x="4379976" y="1783080"/>
-            <a:ext cx="3429000" cy="4389120"/>
+            <a:ext cx="3429000" cy="4480560"/>
           </a:xfrm>
           <a:prstGeom prst="roundRect">
             <a:avLst/>
@@ -9451,7 +10376,7 @@
         </p:nvSpPr>
         <p:spPr>
           <a:xfrm>
-            <a:off x="4562856" y="2011680"/>
+            <a:off x="4608576" y="2011680"/>
             <a:ext cx="1645920" cy="256032"/>
           </a:xfrm>
           <a:prstGeom prst="roundRect">
@@ -9484,7 +10409,7 @@
           <a:p>
             <a:pPr algn="ctr"/>
             <a:r>
-              <a:rPr sz="1000" b="1">
+              <a:rPr sz="900" b="1">
                 <a:solidFill>
                   <a:srgbClr val="2563EB"/>
                 </a:solidFill>
@@ -9503,8 +10428,8 @@
         </p:nvSpPr>
         <p:spPr>
           <a:xfrm>
-            <a:off x="4562856" y="2377440"/>
-            <a:ext cx="3063240" cy="3840480"/>
+            <a:off x="4608576" y="2377440"/>
+            <a:ext cx="2971800" cy="3703320"/>
           </a:xfrm>
           <a:prstGeom prst="rect">
             <a:avLst/>
@@ -9512,7 +10437,7 @@
           <a:noFill/>
         </p:spPr>
         <p:txBody>
-          <a:bodyPr wrap="none">
+          <a:bodyPr wrap="square" lIns="0" rIns="0" tIns="0" bIns="0">
             <a:spAutoFit/>
           </a:bodyPr>
           <a:lstStyle/>
@@ -9539,7 +10464,7 @@
               </a:spcAft>
             </a:pPr>
             <a:r>
-              <a:rPr sz="1200" b="0">
+              <a:rPr sz="1100" b="0">
                 <a:solidFill>
                   <a:srgbClr val="475569"/>
                 </a:solidFill>
@@ -9555,13 +10480,13 @@
               </a:spcAft>
             </a:pPr>
             <a:r>
-              <a:rPr sz="1200" b="0">
+              <a:rPr sz="1100" b="0">
                 <a:solidFill>
                   <a:srgbClr val="475569"/>
                 </a:solidFill>
                 <a:latin typeface="Segoe UI"/>
               </a:rPr>
-              <a:t>• Cosine similarity search with metadata filtering (`file_path`, `type`).</a:t>
+              <a:t>• Cosine similarity search with metadata filtering (file_path, type).</a:t>
             </a:r>
           </a:p>
           <a:p>
@@ -9571,7 +10496,7 @@
               </a:spcAft>
             </a:pPr>
             <a:r>
-              <a:rPr sz="1200" b="0">
+              <a:rPr sz="1100" b="0">
                 <a:solidFill>
                   <a:srgbClr val="475569"/>
                 </a:solidFill>
@@ -9591,7 +10516,7 @@
         <p:spPr>
           <a:xfrm>
             <a:off x="8028431" y="1783080"/>
-            <a:ext cx="3429000" cy="4389120"/>
+            <a:ext cx="3429000" cy="4480560"/>
           </a:xfrm>
           <a:prstGeom prst="roundRect">
             <a:avLst/>
@@ -9635,7 +10560,7 @@
         </p:nvSpPr>
         <p:spPr>
           <a:xfrm>
-            <a:off x="8211311" y="2011680"/>
+            <a:off x="8257031" y="2011680"/>
             <a:ext cx="1645920" cy="256032"/>
           </a:xfrm>
           <a:prstGeom prst="roundRect">
@@ -9668,7 +10593,7 @@
           <a:p>
             <a:pPr algn="ctr"/>
             <a:r>
-              <a:rPr sz="1000" b="1">
+              <a:rPr sz="900" b="1">
                 <a:solidFill>
                   <a:srgbClr val="2563EB"/>
                 </a:solidFill>
@@ -9687,8 +10612,8 @@
         </p:nvSpPr>
         <p:spPr>
           <a:xfrm>
-            <a:off x="8211311" y="2377440"/>
-            <a:ext cx="3063240" cy="3840480"/>
+            <a:off x="8257031" y="2377440"/>
+            <a:ext cx="2971800" cy="3703320"/>
           </a:xfrm>
           <a:prstGeom prst="rect">
             <a:avLst/>
@@ -9696,7 +10621,7 @@
           <a:noFill/>
         </p:spPr>
         <p:txBody>
-          <a:bodyPr wrap="none">
+          <a:bodyPr wrap="square" lIns="0" rIns="0" tIns="0" bIns="0">
             <a:spAutoFit/>
           </a:bodyPr>
           <a:lstStyle/>
@@ -9723,7 +10648,7 @@
               </a:spcAft>
             </a:pPr>
             <a:r>
-              <a:rPr sz="1200" b="0">
+              <a:rPr sz="1100" b="0">
                 <a:solidFill>
                   <a:srgbClr val="475569"/>
                 </a:solidFill>
@@ -9739,13 +10664,13 @@
               </a:spcAft>
             </a:pPr>
             <a:r>
-              <a:rPr sz="1200" b="0">
+              <a:rPr sz="1100" b="0">
                 <a:solidFill>
                   <a:srgbClr val="475569"/>
                 </a:solidFill>
                 <a:latin typeface="Segoe UI"/>
               </a:rPr>
-              <a:t>• Example: Knowing that `auth_service` requires strict JWT validation according to `docs/architecture.md`.</a:t>
+              <a:t>• Example: Knowing that auth_service requires strict JWT validation according to docs/architecture.md.</a:t>
             </a:r>
           </a:p>
           <a:p>
@@ -9755,7 +10680,7 @@
               </a:spcAft>
             </a:pPr>
             <a:r>
-              <a:rPr sz="1200" b="0">
+              <a:rPr sz="1100" b="0">
                 <a:solidFill>
                   <a:srgbClr val="475569"/>
                 </a:solidFill>
@@ -9896,7 +10821,7 @@
           <a:noFill/>
         </p:spPr>
         <p:txBody>
-          <a:bodyPr wrap="none">
+          <a:bodyPr wrap="square" lIns="0" rIns="0" tIns="0" bIns="0">
             <a:spAutoFit/>
           </a:bodyPr>
           <a:lstStyle/>
@@ -9923,7 +10848,7 @@
         <p:spPr>
           <a:xfrm>
             <a:off x="731520" y="777240"/>
-            <a:ext cx="10698480" cy="640080"/>
+            <a:ext cx="10698480" cy="731520"/>
           </a:xfrm>
           <a:prstGeom prst="rect">
             <a:avLst/>
@@ -9931,14 +10856,14 @@
           <a:noFill/>
         </p:spPr>
         <p:txBody>
-          <a:bodyPr wrap="square" lIns="0" tIns="0" rIns="0" bIns="0">
+          <a:bodyPr wrap="square" lIns="0" rIns="0" tIns="0" bIns="0">
             <a:spAutoFit/>
           </a:bodyPr>
           <a:lstStyle/>
           <a:p>
             <a:pPr algn="l">
               <a:spcAft>
-                <a:spcPts val="200"/>
+                <a:spcPts val="300"/>
               </a:spcAft>
             </a:pPr>
             <a:r>
@@ -9978,7 +10903,7 @@
         <p:spPr>
           <a:xfrm>
             <a:off x="731520" y="1783080"/>
-            <a:ext cx="5212080" cy="4389120"/>
+            <a:ext cx="5212080" cy="4480560"/>
           </a:xfrm>
           <a:prstGeom prst="roundRect">
             <a:avLst/>
@@ -10022,8 +10947,8 @@
         </p:nvSpPr>
         <p:spPr>
           <a:xfrm>
-            <a:off x="914400" y="4480560"/>
-            <a:ext cx="4846320" cy="3931920"/>
+            <a:off x="960120" y="1965960"/>
+            <a:ext cx="4754880" cy="914400"/>
           </a:xfrm>
           <a:prstGeom prst="rect">
             <a:avLst/>
@@ -10031,14 +10956,14 @@
           <a:noFill/>
         </p:spPr>
         <p:txBody>
-          <a:bodyPr wrap="none">
+          <a:bodyPr wrap="square" lIns="0" rIns="0" tIns="0" bIns="0">
             <a:spAutoFit/>
           </a:bodyPr>
           <a:lstStyle/>
           <a:p>
             <a:pPr algn="l">
               <a:spcAft>
-                <a:spcPts val="1000"/>
+                <a:spcPts val="400"/>
               </a:spcAft>
             </a:pPr>
             <a:r>
@@ -10048,39 +10973,23 @@
                 </a:solidFill>
                 <a:latin typeface="Segoe UI"/>
               </a:rPr>
-              <a:t>Deterministic Scoring Formulation</a:t>
-            </a:r>
-          </a:p>
-          <a:p>
-            <a:pPr algn="l">
-              <a:spcAft>
-                <a:spcPts val="1200"/>
-              </a:spcAft>
-            </a:pPr>
-            <a:r>
-              <a:rPr sz="1200" b="0">
+              <a:t>Deterministic Scoring Formula</a:t>
+            </a:r>
+          </a:p>
+          <a:p>
+            <a:pPr algn="l">
+              <a:spcAft>
+                <a:spcPts val="0"/>
+              </a:spcAft>
+            </a:pPr>
+            <a:r>
+              <a:rPr sz="1100" b="0">
                 <a:solidFill>
                   <a:srgbClr val="475569"/>
                 </a:solidFill>
                 <a:latin typeface="Segoe UI"/>
               </a:rPr>
-              <a:t>Risk score is calculated as a calibrated sum of validated findings capped at 100:</a:t>
-            </a:r>
-          </a:p>
-          <a:p>
-            <a:pPr algn="l">
-              <a:spcAft>
-                <a:spcPts val="0"/>
-              </a:spcAft>
-            </a:pPr>
-            <a:r>
-              <a:rPr sz="1100" b="0">
-                <a:solidFill>
-                  <a:srgbClr val="475569"/>
-                </a:solidFill>
-                <a:latin typeface="Segoe UI"/>
-              </a:rPr>
-              <a:t>Zero Black-Box Guesswork: The exact same findings always yield the exact same score across runs.</a:t>
+              <a:t>Mathematical score calculated strictly from critic-validated findings:</a:t>
             </a:r>
           </a:p>
         </p:txBody>
@@ -10093,8 +11002,8 @@
         </p:nvSpPr>
         <p:spPr>
           <a:xfrm>
-            <a:off x="914400" y="2926080"/>
-            <a:ext cx="4846320" cy="1463040"/>
+            <a:off x="960120" y="2880360"/>
+            <a:ext cx="4754880" cy="1920240"/>
           </a:xfrm>
           <a:prstGeom prst="roundRect">
             <a:avLst/>
@@ -10138,8 +11047,8 @@
         </p:nvSpPr>
         <p:spPr>
           <a:xfrm>
-            <a:off x="1051560" y="3017520"/>
-            <a:ext cx="4572000" cy="1280160"/>
+            <a:off x="1143000" y="3017520"/>
+            <a:ext cx="4389120" cy="1645920"/>
           </a:xfrm>
           <a:prstGeom prst="rect">
             <a:avLst/>
@@ -10147,7 +11056,7 @@
           <a:noFill/>
         </p:spPr>
         <p:txBody>
-          <a:bodyPr wrap="none">
+          <a:bodyPr wrap="square" lIns="0" rIns="0" tIns="0" bIns="0">
             <a:spAutoFit/>
           </a:bodyPr>
           <a:lstStyle/>
@@ -10158,19 +11067,19 @@
               </a:spcAft>
             </a:pPr>
             <a:r>
-              <a:rPr sz="1200" b="1">
+              <a:rPr sz="1100" b="1">
                 <a:solidFill>
                   <a:srgbClr val="1E3A8A"/>
                 </a:solidFill>
                 <a:latin typeface="Consolas"/>
               </a:rPr>
-              <a:t>Risk Score = Min(100, Σ (Weight_i * Count_i))</a:t>
-            </a:r>
-          </a:p>
-          <a:p>
-            <a:pPr algn="l">
-              <a:spcAft>
-                <a:spcPts val="200"/>
+              <a:t>Risk Score = Min(100, Σ (Weight_i * Multiplier_i))</a:t>
+            </a:r>
+          </a:p>
+          <a:p>
+            <a:pPr algn="l">
+              <a:spcAft>
+                <a:spcPts val="300"/>
               </a:spcAft>
             </a:pPr>
             <a:r>
@@ -10186,7 +11095,7 @@
           <a:p>
             <a:pPr algn="l">
               <a:spcAft>
-                <a:spcPts val="200"/>
+                <a:spcPts val="300"/>
               </a:spcAft>
             </a:pPr>
             <a:r>
@@ -10202,7 +11111,7 @@
           <a:p>
             <a:pPr algn="l">
               <a:spcAft>
-                <a:spcPts val="200"/>
+                <a:spcPts val="300"/>
               </a:spcAft>
             </a:pPr>
             <a:r>
@@ -10235,14 +11144,53 @@
       </p:sp>
       <p:sp>
         <p:nvSpPr>
-          <p:cNvPr id="10" name="Rounded Rectangle 9"/>
+          <p:cNvPr id="10" name="TextBox 9"/>
+          <p:cNvSpPr txBox="1"/>
+          <p:nvPr/>
+        </p:nvSpPr>
+        <p:spPr>
+          <a:xfrm>
+            <a:off x="960120" y="4983480"/>
+            <a:ext cx="4754880" cy="1097280"/>
+          </a:xfrm>
+          <a:prstGeom prst="rect">
+            <a:avLst/>
+          </a:prstGeom>
+          <a:noFill/>
+        </p:spPr>
+        <p:txBody>
+          <a:bodyPr wrap="square" lIns="0" rIns="0" tIns="0" bIns="0">
+            <a:spAutoFit/>
+          </a:bodyPr>
+          <a:lstStyle/>
+          <a:p>
+            <a:pPr algn="l">
+              <a:spcAft>
+                <a:spcPts val="0"/>
+              </a:spcAft>
+            </a:pPr>
+            <a:r>
+              <a:rPr sz="1100" b="0">
+                <a:solidFill>
+                  <a:srgbClr val="475569"/>
+                </a:solidFill>
+                <a:latin typeface="Segoe UI"/>
+              </a:rPr>
+              <a:t>Zero Black-Box Guesswork: The exact same findings always yield the exact same score across runs with 100% mathematical reproducibility.</a:t>
+            </a:r>
+          </a:p>
+        </p:txBody>
+      </p:sp>
+      <p:sp>
+        <p:nvSpPr>
+          <p:cNvPr id="11" name="Rounded Rectangle 10"/>
           <p:cNvSpPr/>
           <p:nvPr/>
         </p:nvSpPr>
         <p:spPr>
           <a:xfrm>
             <a:off x="6217920" y="1783080"/>
-            <a:ext cx="5242255" cy="4389120"/>
+            <a:ext cx="5242255" cy="4480560"/>
           </a:xfrm>
           <a:prstGeom prst="roundRect">
             <a:avLst/>
@@ -10280,14 +11228,14 @@
       </p:sp>
       <p:sp>
         <p:nvSpPr>
-          <p:cNvPr id="11" name="TextBox 10"/>
+          <p:cNvPr id="12" name="TextBox 11"/>
           <p:cNvSpPr txBox="1"/>
           <p:nvPr/>
         </p:nvSpPr>
         <p:spPr>
           <a:xfrm>
-            <a:off x="6492240" y="2011680"/>
-            <a:ext cx="4663440" cy="3931920"/>
+            <a:off x="6446520" y="1965960"/>
+            <a:ext cx="4754880" cy="457200"/>
           </a:xfrm>
           <a:prstGeom prst="rect">
             <a:avLst/>
@@ -10295,14 +11243,14 @@
           <a:noFill/>
         </p:spPr>
         <p:txBody>
-          <a:bodyPr wrap="none">
+          <a:bodyPr wrap="square" lIns="0" rIns="0" tIns="0" bIns="0">
             <a:spAutoFit/>
           </a:bodyPr>
           <a:lstStyle/>
           <a:p>
             <a:pPr algn="l">
               <a:spcAft>
-                <a:spcPts val="1200"/>
+                <a:spcPts val="0"/>
               </a:spcAft>
             </a:pPr>
             <a:r>
@@ -10319,14 +11267,14 @@
       </p:sp>
       <p:sp>
         <p:nvSpPr>
-          <p:cNvPr id="12" name="Rounded Rectangle 11"/>
+          <p:cNvPr id="13" name="Rounded Rectangle 12"/>
           <p:cNvSpPr/>
           <p:nvPr/>
         </p:nvSpPr>
         <p:spPr>
           <a:xfrm>
-            <a:off x="6492240" y="2468880"/>
-            <a:ext cx="4693615" cy="1005840"/>
+            <a:off x="6446520" y="2514600"/>
+            <a:ext cx="4785055" cy="1051560"/>
           </a:xfrm>
           <a:prstGeom prst="roundRect">
             <a:avLst/>
@@ -10364,14 +11312,14 @@
       </p:sp>
       <p:sp>
         <p:nvSpPr>
-          <p:cNvPr id="13" name="TextBox 12"/>
+          <p:cNvPr id="14" name="TextBox 13"/>
           <p:cNvSpPr txBox="1"/>
           <p:nvPr/>
         </p:nvSpPr>
         <p:spPr>
           <a:xfrm>
-            <a:off x="6629400" y="2560320"/>
-            <a:ext cx="4389120" cy="822960"/>
+            <a:off x="6629400" y="2606040"/>
+            <a:ext cx="4419295" cy="868680"/>
           </a:xfrm>
           <a:prstGeom prst="rect">
             <a:avLst/>
@@ -10379,14 +11327,14 @@
           <a:noFill/>
         </p:spPr>
         <p:txBody>
-          <a:bodyPr wrap="none">
+          <a:bodyPr wrap="square" lIns="0" rIns="0" tIns="0" bIns="0">
             <a:spAutoFit/>
           </a:bodyPr>
           <a:lstStyle/>
           <a:p>
             <a:pPr algn="l">
               <a:spcAft>
-                <a:spcPts val="200"/>
+                <a:spcPts val="300"/>
               </a:spcAft>
             </a:pPr>
             <a:r>
@@ -10406,27 +11354,27 @@
               </a:spcAft>
             </a:pPr>
             <a:r>
-              <a:rPr sz="1100" b="0">
+              <a:rPr sz="1000" b="0">
                 <a:solidFill>
                   <a:srgbClr val="475569"/>
                 </a:solidFill>
                 <a:latin typeface="Segoe UI"/>
               </a:rPr>
-              <a:t>Score &lt; 40 and Critical = 0 and High = 0. Clean CI pass.</a:t>
-            </a:r>
-          </a:p>
-        </p:txBody>
-      </p:sp>
-      <p:sp>
-        <p:nvSpPr>
-          <p:cNvPr id="14" name="Rounded Rectangle 13"/>
+              <a:t>Score &lt; 40 and Critical = 0 and High = 0. Production promotion allowed.</a:t>
+            </a:r>
+          </a:p>
+        </p:txBody>
+      </p:sp>
+      <p:sp>
+        <p:nvSpPr>
+          <p:cNvPr id="15" name="Rounded Rectangle 14"/>
           <p:cNvSpPr/>
           <p:nvPr/>
         </p:nvSpPr>
         <p:spPr>
           <a:xfrm>
-            <a:off x="6492240" y="3611880"/>
-            <a:ext cx="4693615" cy="1005840"/>
+            <a:off x="6446520" y="3703320"/>
+            <a:ext cx="4785055" cy="1051560"/>
           </a:xfrm>
           <a:prstGeom prst="roundRect">
             <a:avLst/>
@@ -10464,14 +11412,14 @@
       </p:sp>
       <p:sp>
         <p:nvSpPr>
-          <p:cNvPr id="15" name="TextBox 14"/>
+          <p:cNvPr id="16" name="TextBox 15"/>
           <p:cNvSpPr txBox="1"/>
           <p:nvPr/>
         </p:nvSpPr>
         <p:spPr>
           <a:xfrm>
-            <a:off x="6629400" y="3703320"/>
-            <a:ext cx="4389120" cy="822960"/>
+            <a:off x="6629400" y="3794760"/>
+            <a:ext cx="4419295" cy="868680"/>
           </a:xfrm>
           <a:prstGeom prst="rect">
             <a:avLst/>
@@ -10479,14 +11427,14 @@
           <a:noFill/>
         </p:spPr>
         <p:txBody>
-          <a:bodyPr wrap="none">
+          <a:bodyPr wrap="square" lIns="0" rIns="0" tIns="0" bIns="0">
             <a:spAutoFit/>
           </a:bodyPr>
           <a:lstStyle/>
           <a:p>
             <a:pPr algn="l">
               <a:spcAft>
-                <a:spcPts val="200"/>
+                <a:spcPts val="300"/>
               </a:spcAft>
             </a:pPr>
             <a:r>
@@ -10506,27 +11454,27 @@
               </a:spcAft>
             </a:pPr>
             <a:r>
-              <a:rPr sz="1100" b="0">
+              <a:rPr sz="1000" b="0">
                 <a:solidFill>
                   <a:srgbClr val="475569"/>
                 </a:solidFill>
                 <a:latin typeface="Segoe UI"/>
               </a:rPr>
-              <a:t>Score between 40 and 69 or High &lt;= 2. Engineering lead signoff required.</a:t>
-            </a:r>
-          </a:p>
-        </p:txBody>
-      </p:sp>
-      <p:sp>
-        <p:nvSpPr>
-          <p:cNvPr id="16" name="Rounded Rectangle 15"/>
+              <a:t>Score 40–69 or High &lt;= 2. Engineering lead manual review required.</a:t>
+            </a:r>
+          </a:p>
+        </p:txBody>
+      </p:sp>
+      <p:sp>
+        <p:nvSpPr>
+          <p:cNvPr id="17" name="Rounded Rectangle 16"/>
           <p:cNvSpPr/>
           <p:nvPr/>
         </p:nvSpPr>
         <p:spPr>
           <a:xfrm>
-            <a:off x="6492240" y="4754880"/>
-            <a:ext cx="4693615" cy="1005840"/>
+            <a:off x="6446520" y="4892040"/>
+            <a:ext cx="4785055" cy="1051560"/>
           </a:xfrm>
           <a:prstGeom prst="roundRect">
             <a:avLst/>
@@ -10564,14 +11512,14 @@
       </p:sp>
       <p:sp>
         <p:nvSpPr>
-          <p:cNvPr id="17" name="TextBox 16"/>
+          <p:cNvPr id="18" name="TextBox 17"/>
           <p:cNvSpPr txBox="1"/>
           <p:nvPr/>
         </p:nvSpPr>
         <p:spPr>
           <a:xfrm>
-            <a:off x="6629400" y="4846320"/>
-            <a:ext cx="4389120" cy="822960"/>
+            <a:off x="6629400" y="4983480"/>
+            <a:ext cx="4419295" cy="868680"/>
           </a:xfrm>
           <a:prstGeom prst="rect">
             <a:avLst/>
@@ -10579,14 +11527,14 @@
           <a:noFill/>
         </p:spPr>
         <p:txBody>
-          <a:bodyPr wrap="none">
+          <a:bodyPr wrap="square" lIns="0" rIns="0" tIns="0" bIns="0">
             <a:spAutoFit/>
           </a:bodyPr>
           <a:lstStyle/>
           <a:p>
             <a:pPr algn="l">
               <a:spcAft>
-                <a:spcPts val="200"/>
+                <a:spcPts val="300"/>
               </a:spcAft>
             </a:pPr>
             <a:r>
@@ -10606,13 +11554,13 @@
               </a:spcAft>
             </a:pPr>
             <a:r>
-              <a:rPr sz="1100" b="0">
+              <a:rPr sz="1000" b="0">
                 <a:solidFill>
                   <a:srgbClr val="475569"/>
                 </a:solidFill>
                 <a:latin typeface="Segoe UI"/>
               </a:rPr>
-              <a:t>Score &gt;= 70 or Critical &gt;= 1. Hard stop in CI/CD pipeline.</a:t>
+              <a:t>Score &gt;= 70 or Critical &gt;= 1. Hard blocker in CI/CD pipeline.</a:t>
             </a:r>
           </a:p>
         </p:txBody>
@@ -10747,7 +11695,7 @@
           <a:noFill/>
         </p:spPr>
         <p:txBody>
-          <a:bodyPr wrap="none">
+          <a:bodyPr wrap="square" lIns="0" rIns="0" tIns="0" bIns="0">
             <a:spAutoFit/>
           </a:bodyPr>
           <a:lstStyle/>
@@ -10774,7 +11722,7 @@
         <p:spPr>
           <a:xfrm>
             <a:off x="731520" y="777240"/>
-            <a:ext cx="10698480" cy="640080"/>
+            <a:ext cx="10698480" cy="731520"/>
           </a:xfrm>
           <a:prstGeom prst="rect">
             <a:avLst/>
@@ -10782,14 +11730,14 @@
           <a:noFill/>
         </p:spPr>
         <p:txBody>
-          <a:bodyPr wrap="square" lIns="0" tIns="0" rIns="0" bIns="0">
+          <a:bodyPr wrap="square" lIns="0" rIns="0" tIns="0" bIns="0">
             <a:spAutoFit/>
           </a:bodyPr>
           <a:lstStyle/>
           <a:p>
             <a:pPr algn="l">
               <a:spcAft>
-                <a:spcPts val="200"/>
+                <a:spcPts val="300"/>
               </a:spcAft>
             </a:pPr>
             <a:r>
@@ -10829,7 +11777,7 @@
         <p:spPr>
           <a:xfrm>
             <a:off x="731520" y="1783080"/>
-            <a:ext cx="2523744" cy="4389120"/>
+            <a:ext cx="2523744" cy="4480560"/>
           </a:xfrm>
           <a:prstGeom prst="roundRect">
             <a:avLst/>
@@ -10873,7 +11821,7 @@
         </p:nvSpPr>
         <p:spPr>
           <a:xfrm>
-            <a:off x="914400" y="2011680"/>
+            <a:off x="868680" y="2011680"/>
             <a:ext cx="1645920" cy="256032"/>
           </a:xfrm>
           <a:prstGeom prst="roundRect">
@@ -10906,7 +11854,7 @@
           <a:p>
             <a:pPr algn="ctr"/>
             <a:r>
-              <a:rPr sz="1000" b="1">
+              <a:rPr sz="900" b="1">
                 <a:solidFill>
                   <a:srgbClr val="2563EB"/>
                 </a:solidFill>
@@ -10925,8 +11873,8 @@
         </p:nvSpPr>
         <p:spPr>
           <a:xfrm>
-            <a:off x="914400" y="2377440"/>
-            <a:ext cx="2157984" cy="3840480"/>
+            <a:off x="868680" y="2377440"/>
+            <a:ext cx="2249424" cy="3749040"/>
           </a:xfrm>
           <a:prstGeom prst="rect">
             <a:avLst/>
@@ -10934,7 +11882,7 @@
           <a:noFill/>
         </p:spPr>
         <p:txBody>
-          <a:bodyPr wrap="none">
+          <a:bodyPr wrap="square" lIns="0" rIns="0" tIns="0" bIns="0">
             <a:spAutoFit/>
           </a:bodyPr>
           <a:lstStyle/>
@@ -10961,13 +11909,13 @@
               </a:spcAft>
             </a:pPr>
             <a:r>
-              <a:rPr sz="1100" b="0">
+              <a:rPr sz="1000" b="0">
                 <a:solidFill>
                   <a:srgbClr val="475569"/>
                 </a:solidFill>
                 <a:latin typeface="Segoe UI"/>
               </a:rPr>
-              <a:t>• Version-controlled repo-level configuration.</a:t>
+              <a:t>• Version-controlled repository rules</a:t>
             </a:r>
           </a:p>
           <a:p>
@@ -10977,13 +11925,13 @@
               </a:spcAft>
             </a:pPr>
             <a:r>
-              <a:rPr sz="1100" b="0">
+              <a:rPr sz="1000" b="0">
                 <a:solidFill>
                   <a:srgbClr val="475569"/>
                 </a:solidFill>
                 <a:latin typeface="Segoe UI"/>
               </a:rPr>
-              <a:t>• Custom thresholds (`fail_threshold`, `critical_limit`).</a:t>
+              <a:t>• Custom risk thresholds</a:t>
             </a:r>
           </a:p>
           <a:p>
@@ -10993,13 +11941,13 @@
               </a:spcAft>
             </a:pPr>
             <a:r>
-              <a:rPr sz="1100" b="0">
+              <a:rPr sz="1000" b="0">
                 <a:solidFill>
                   <a:srgbClr val="475569"/>
                 </a:solidFill>
                 <a:latin typeface="Segoe UI"/>
               </a:rPr>
-              <a:t>• Path exclusions &amp; custom gating overrides.</a:t>
+              <a:t>• Path exclusions &amp; gate overrides</a:t>
             </a:r>
           </a:p>
           <a:p>
@@ -11009,13 +11957,13 @@
               </a:spcAft>
             </a:pPr>
             <a:r>
-              <a:rPr sz="1100" b="1">
+              <a:rPr sz="1000" b="1">
                 <a:solidFill>
                   <a:srgbClr val="16A34A"/>
                 </a:solidFill>
                 <a:latin typeface="Segoe UI"/>
               </a:rPr>
-              <a:t>• Path traversal &amp; shell injection protection.</a:t>
+              <a:t>• Traversal &amp; injection defense</a:t>
             </a:r>
           </a:p>
         </p:txBody>
@@ -11029,7 +11977,7 @@
         <p:spPr>
           <a:xfrm>
             <a:off x="3465575" y="1783080"/>
-            <a:ext cx="2523744" cy="4389120"/>
+            <a:ext cx="2523744" cy="4480560"/>
           </a:xfrm>
           <a:prstGeom prst="roundRect">
             <a:avLst/>
@@ -11073,7 +12021,7 @@
         </p:nvSpPr>
         <p:spPr>
           <a:xfrm>
-            <a:off x="3648456" y="2011680"/>
+            <a:off x="3602735" y="2011680"/>
             <a:ext cx="1645920" cy="256032"/>
           </a:xfrm>
           <a:prstGeom prst="roundRect">
@@ -11106,7 +12054,7 @@
           <a:p>
             <a:pPr algn="ctr"/>
             <a:r>
-              <a:rPr sz="1000" b="1">
+              <a:rPr sz="900" b="1">
                 <a:solidFill>
                   <a:srgbClr val="2563EB"/>
                 </a:solidFill>
@@ -11125,8 +12073,8 @@
         </p:nvSpPr>
         <p:spPr>
           <a:xfrm>
-            <a:off x="3648456" y="2377440"/>
-            <a:ext cx="2157984" cy="3840480"/>
+            <a:off x="3602735" y="2377440"/>
+            <a:ext cx="2249424" cy="3749040"/>
           </a:xfrm>
           <a:prstGeom prst="rect">
             <a:avLst/>
@@ -11134,7 +12082,7 @@
           <a:noFill/>
         </p:spPr>
         <p:txBody>
-          <a:bodyPr wrap="none">
+          <a:bodyPr wrap="square" lIns="0" rIns="0" tIns="0" bIns="0">
             <a:spAutoFit/>
           </a:bodyPr>
           <a:lstStyle/>
@@ -11161,13 +12109,13 @@
               </a:spcAft>
             </a:pPr>
             <a:r>
-              <a:rPr sz="1100" b="0">
+              <a:rPr sz="1000" b="0">
                 <a:solidFill>
                   <a:srgbClr val="475569"/>
                 </a:solidFill>
                 <a:latin typeface="Segoe UI"/>
               </a:rPr>
-              <a:t>• Maps diffs to structural blast radius (CRITICAL to LOW).</a:t>
+              <a:t>• Physical blast radius mapping</a:t>
             </a:r>
           </a:p>
           <a:p>
@@ -11177,13 +12125,13 @@
               </a:spcAft>
             </a:pPr>
             <a:r>
-              <a:rPr sz="1100" b="0">
+              <a:rPr sz="1000" b="0">
                 <a:solidFill>
                   <a:srgbClr val="475569"/>
                 </a:solidFill>
                 <a:latin typeface="Segoe UI"/>
               </a:rPr>
-              <a:t>• Flags affected architectural layers (DB, Auth, Docker).</a:t>
+              <a:t>• Affected layer classification</a:t>
             </a:r>
           </a:p>
           <a:p>
@@ -11193,13 +12141,13 @@
               </a:spcAft>
             </a:pPr>
             <a:r>
-              <a:rPr sz="1100" b="0">
+              <a:rPr sz="1000" b="0">
                 <a:solidFill>
                   <a:srgbClr val="475569"/>
                 </a:solidFill>
                 <a:latin typeface="Segoe UI"/>
               </a:rPr>
-              <a:t>• Generates mandatory verification checks.</a:t>
+              <a:t>• Mandatory verification checks</a:t>
             </a:r>
           </a:p>
           <a:p>
@@ -11209,13 +12157,13 @@
               </a:spcAft>
             </a:pPr>
             <a:r>
-              <a:rPr sz="1100" b="1">
+              <a:rPr sz="1000" b="1">
                 <a:solidFill>
                   <a:srgbClr val="16A34A"/>
                 </a:solidFill>
                 <a:latin typeface="Segoe UI"/>
               </a:rPr>
-              <a:t>• Latency: 8.4ms deterministic execution.</a:t>
+              <a:t>• Sub-10ms deterministic run</a:t>
             </a:r>
           </a:p>
         </p:txBody>
@@ -11229,7 +12177,7 @@
         <p:spPr>
           <a:xfrm>
             <a:off x="6199631" y="1783080"/>
-            <a:ext cx="2523744" cy="4389120"/>
+            <a:ext cx="2523744" cy="4480560"/>
           </a:xfrm>
           <a:prstGeom prst="roundRect">
             <a:avLst/>
@@ -11273,7 +12221,7 @@
         </p:nvSpPr>
         <p:spPr>
           <a:xfrm>
-            <a:off x="6382512" y="2011680"/>
+            <a:off x="6336792" y="2011680"/>
             <a:ext cx="1645920" cy="256032"/>
           </a:xfrm>
           <a:prstGeom prst="roundRect">
@@ -11306,7 +12254,7 @@
           <a:p>
             <a:pPr algn="ctr"/>
             <a:r>
-              <a:rPr sz="1000" b="1">
+              <a:rPr sz="900" b="1">
                 <a:solidFill>
                   <a:srgbClr val="2563EB"/>
                 </a:solidFill>
@@ -11325,8 +12273,8 @@
         </p:nvSpPr>
         <p:spPr>
           <a:xfrm>
-            <a:off x="6382512" y="2377440"/>
-            <a:ext cx="2157984" cy="3840480"/>
+            <a:off x="6336792" y="2377440"/>
+            <a:ext cx="2249424" cy="3749040"/>
           </a:xfrm>
           <a:prstGeom prst="rect">
             <a:avLst/>
@@ -11334,7 +12282,7 @@
           <a:noFill/>
         </p:spPr>
         <p:txBody>
-          <a:bodyPr wrap="none">
+          <a:bodyPr wrap="square" lIns="0" rIns="0" tIns="0" bIns="0">
             <a:spAutoFit/>
           </a:bodyPr>
           <a:lstStyle/>
@@ -11361,13 +12309,13 @@
               </a:spcAft>
             </a:pPr>
             <a:r>
-              <a:rPr sz="1100" b="0">
+              <a:rPr sz="1000" b="0">
                 <a:solidFill>
                   <a:srgbClr val="475569"/>
                 </a:solidFill>
                 <a:latin typeface="Segoe UI"/>
               </a:rPr>
-              <a:t>• Multi-run timeline analytics per repository.</a:t>
+              <a:t>• Multi-run timeline telemetry</a:t>
             </a:r>
           </a:p>
           <a:p>
@@ -11377,13 +12325,13 @@
               </a:spcAft>
             </a:pPr>
             <a:r>
-              <a:rPr sz="1100" b="0">
+              <a:rPr sz="1000" b="0">
                 <a:solidFill>
                   <a:srgbClr val="475569"/>
                 </a:solidFill>
                 <a:latin typeface="Segoe UI"/>
               </a:rPr>
-              <a:t>• Recurring issue detection across commits.</a:t>
+              <a:t>• Recurring issue detection</a:t>
             </a:r>
           </a:p>
           <a:p>
@@ -11393,13 +12341,13 @@
               </a:spcAft>
             </a:pPr>
             <a:r>
-              <a:rPr sz="1100" b="0">
+              <a:rPr sz="1000" b="0">
                 <a:solidFill>
                   <a:srgbClr val="475569"/>
                 </a:solidFill>
                 <a:latin typeface="Segoe UI"/>
               </a:rPr>
-              <a:t>• Gate pass/fail block rates.</a:t>
+              <a:t>• Gate pass/fail block rates</a:t>
             </a:r>
           </a:p>
           <a:p>
@@ -11409,13 +12357,13 @@
               </a:spcAft>
             </a:pPr>
             <a:r>
-              <a:rPr sz="1100" b="0">
+              <a:rPr sz="1000" b="0">
                 <a:solidFill>
                   <a:srgbClr val="475569"/>
                 </a:solidFill>
                 <a:latin typeface="Segoe UI"/>
               </a:rPr>
-              <a:t>• Resolution velocity tracking.</a:t>
+              <a:t>• Resolution velocity tracking</a:t>
             </a:r>
           </a:p>
         </p:txBody>
@@ -11429,7 +12377,7 @@
         <p:spPr>
           <a:xfrm>
             <a:off x="8933688" y="1783080"/>
-            <a:ext cx="2523744" cy="4389120"/>
+            <a:ext cx="2523744" cy="4480560"/>
           </a:xfrm>
           <a:prstGeom prst="roundRect">
             <a:avLst/>
@@ -11473,7 +12421,7 @@
         </p:nvSpPr>
         <p:spPr>
           <a:xfrm>
-            <a:off x="9116567" y="2011680"/>
+            <a:off x="9070848" y="2011680"/>
             <a:ext cx="1645920" cy="256032"/>
           </a:xfrm>
           <a:prstGeom prst="roundRect">
@@ -11506,7 +12454,7 @@
           <a:p>
             <a:pPr algn="ctr"/>
             <a:r>
-              <a:rPr sz="1000" b="1">
+              <a:rPr sz="900" b="1">
                 <a:solidFill>
                   <a:srgbClr val="2563EB"/>
                 </a:solidFill>
@@ -11525,8 +12473,8 @@
         </p:nvSpPr>
         <p:spPr>
           <a:xfrm>
-            <a:off x="9116567" y="2377440"/>
-            <a:ext cx="2157984" cy="3840480"/>
+            <a:off x="9070848" y="2377440"/>
+            <a:ext cx="2249424" cy="3749040"/>
           </a:xfrm>
           <a:prstGeom prst="rect">
             <a:avLst/>
@@ -11534,7 +12482,7 @@
           <a:noFill/>
         </p:spPr>
         <p:txBody>
-          <a:bodyPr wrap="none">
+          <a:bodyPr wrap="square" lIns="0" rIns="0" tIns="0" bIns="0">
             <a:spAutoFit/>
           </a:bodyPr>
           <a:lstStyle/>
@@ -11561,13 +12509,13 @@
               </a:spcAft>
             </a:pPr>
             <a:r>
-              <a:rPr sz="1100" b="0">
+              <a:rPr sz="1000" b="0">
                 <a:solidFill>
                   <a:srgbClr val="475569"/>
                 </a:solidFill>
                 <a:latin typeface="Segoe UI"/>
               </a:rPr>
-              <a:t>• Standard unified diff (`diff -u`) generation.</a:t>
+              <a:t>• Standard unified diff format</a:t>
             </a:r>
           </a:p>
           <a:p>
@@ -11577,13 +12525,13 @@
               </a:spcAft>
             </a:pPr>
             <a:r>
-              <a:rPr sz="1100" b="0">
+              <a:rPr sz="1000" b="0">
                 <a:solidFill>
                   <a:srgbClr val="475569"/>
                 </a:solidFill>
                 <a:latin typeface="Segoe UI"/>
               </a:rPr>
-              <a:t>• Non-destructive read-only proposals.</a:t>
+              <a:t>• Non-destructive read-only</a:t>
             </a:r>
           </a:p>
           <a:p>
@@ -11593,13 +12541,13 @@
               </a:spcAft>
             </a:pPr>
             <a:r>
-              <a:rPr sz="1100" b="1">
+              <a:rPr sz="1000" b="1">
                 <a:solidFill>
                   <a:srgbClr val="DC2626"/>
                 </a:solidFill>
                 <a:latin typeface="Segoe UI"/>
               </a:rPr>
-              <a:t>• Mandatory human approval banner.</a:t>
+              <a:t>• Human approval mandatory</a:t>
             </a:r>
           </a:p>
           <a:p>
@@ -11609,13 +12557,13 @@
               </a:spcAft>
             </a:pPr>
             <a:r>
-              <a:rPr sz="1100" b="0">
+              <a:rPr sz="1000" b="0">
                 <a:solidFill>
                   <a:srgbClr val="475569"/>
                 </a:solidFill>
                 <a:latin typeface="Segoe UI"/>
               </a:rPr>
-              <a:t>• Zero automated commits without signoff.</a:t>
+              <a:t>• Zero autonomous commits</a:t>
             </a:r>
           </a:p>
         </p:txBody>
@@ -11750,7 +12698,7 @@
           <a:noFill/>
         </p:spPr>
         <p:txBody>
-          <a:bodyPr wrap="none">
+          <a:bodyPr wrap="square" lIns="0" rIns="0" tIns="0" bIns="0">
             <a:spAutoFit/>
           </a:bodyPr>
           <a:lstStyle/>
@@ -11777,7 +12725,7 @@
         <p:spPr>
           <a:xfrm>
             <a:off x="731520" y="777240"/>
-            <a:ext cx="10698480" cy="640080"/>
+            <a:ext cx="10698480" cy="731520"/>
           </a:xfrm>
           <a:prstGeom prst="rect">
             <a:avLst/>
@@ -11785,14 +12733,14 @@
           <a:noFill/>
         </p:spPr>
         <p:txBody>
-          <a:bodyPr wrap="square" lIns="0" tIns="0" rIns="0" bIns="0">
+          <a:bodyPr wrap="square" lIns="0" rIns="0" tIns="0" bIns="0">
             <a:spAutoFit/>
           </a:bodyPr>
           <a:lstStyle/>
           <a:p>
             <a:pPr algn="l">
               <a:spcAft>
-                <a:spcPts val="200"/>
+                <a:spcPts val="300"/>
               </a:spcAft>
             </a:pPr>
             <a:r>
@@ -11832,7 +12780,7 @@
         <p:spPr>
           <a:xfrm>
             <a:off x="731520" y="1783080"/>
-            <a:ext cx="5212080" cy="4389120"/>
+            <a:ext cx="5212080" cy="4480560"/>
           </a:xfrm>
           <a:prstGeom prst="roundRect">
             <a:avLst/>
@@ -11876,8 +12824,8 @@
         </p:nvSpPr>
         <p:spPr>
           <a:xfrm>
-            <a:off x="914400" y="2011680"/>
-            <a:ext cx="4846320" cy="3931920"/>
+            <a:off x="960120" y="1965960"/>
+            <a:ext cx="4754880" cy="4114800"/>
           </a:xfrm>
           <a:prstGeom prst="rect">
             <a:avLst/>
@@ -11885,7 +12833,7 @@
           <a:noFill/>
         </p:spPr>
         <p:txBody>
-          <a:bodyPr wrap="none">
+          <a:bodyPr wrap="square" lIns="0" rIns="0" tIns="0" bIns="0">
             <a:spAutoFit/>
           </a:bodyPr>
           <a:lstStyle/>
@@ -11912,7 +12860,7 @@
               </a:spcAft>
             </a:pPr>
             <a:r>
-              <a:rPr sz="1200" b="0">
+              <a:rPr sz="1100" b="0">
                 <a:solidFill>
                   <a:srgbClr val="475569"/>
                 </a:solidFill>
@@ -11928,7 +12876,7 @@
               </a:spcAft>
             </a:pPr>
             <a:r>
-              <a:rPr sz="1200" b="0">
+              <a:rPr sz="1100" b="0">
                 <a:solidFill>
                   <a:srgbClr val="DC2626"/>
                 </a:solidFill>
@@ -11944,7 +12892,7 @@
               </a:spcAft>
             </a:pPr>
             <a:r>
-              <a:rPr sz="1200" b="0">
+              <a:rPr sz="1100" b="0">
                 <a:solidFill>
                   <a:srgbClr val="475569"/>
                 </a:solidFill>
@@ -11960,7 +12908,7 @@
               </a:spcAft>
             </a:pPr>
             <a:r>
-              <a:rPr sz="1200" b="0">
+              <a:rPr sz="1100" b="0">
                 <a:solidFill>
                   <a:srgbClr val="475569"/>
                 </a:solidFill>
@@ -11980,7 +12928,7 @@
         <p:spPr>
           <a:xfrm>
             <a:off x="6217920" y="1783080"/>
-            <a:ext cx="5242255" cy="4389120"/>
+            <a:ext cx="5242255" cy="4480560"/>
           </a:xfrm>
           <a:prstGeom prst="roundRect">
             <a:avLst/>
@@ -12018,116 +12966,13 @@
       </p:sp>
       <p:sp>
         <p:nvSpPr>
-          <p:cNvPr id="9" name="TextBox 8"/>
-          <p:cNvSpPr txBox="1"/>
-          <p:nvPr/>
-        </p:nvSpPr>
-        <p:spPr>
-          <a:xfrm>
-            <a:off x="6492240" y="2423160"/>
-            <a:ext cx="4663440" cy="3931920"/>
-          </a:xfrm>
-          <a:prstGeom prst="rect">
-            <a:avLst/>
-          </a:prstGeom>
-          <a:noFill/>
-        </p:spPr>
-        <p:txBody>
-          <a:bodyPr wrap="none">
-            <a:spAutoFit/>
-          </a:bodyPr>
-          <a:lstStyle/>
-          <a:p>
-            <a:pPr algn="l">
-              <a:spcAft>
-                <a:spcPts val="1000"/>
-              </a:spcAft>
-            </a:pPr>
-            <a:r>
-              <a:rPr sz="1600" b="1">
-                <a:solidFill>
-                  <a:srgbClr val="0F172A"/>
-                </a:solidFill>
-                <a:latin typeface="Segoe UI"/>
-              </a:rPr>
-              <a:t>Actionable Unified Diff Previews</a:t>
-            </a:r>
-          </a:p>
-          <a:p>
-            <a:pPr algn="l">
-              <a:spcAft>
-                <a:spcPts val="800"/>
-              </a:spcAft>
-            </a:pPr>
-            <a:r>
-              <a:rPr sz="1200" b="0">
-                <a:solidFill>
-                  <a:srgbClr val="475569"/>
-                </a:solidFill>
-                <a:latin typeface="Segoe UI"/>
-              </a:rPr>
-              <a:t>1. Standard Unified Diff Output: Formatted exactly like `git diff` with line offsets (`@@ -x,y +a,b @@`).</a:t>
-            </a:r>
-          </a:p>
-          <a:p>
-            <a:pPr algn="l">
-              <a:spcAft>
-                <a:spcPts val="800"/>
-              </a:spcAft>
-            </a:pPr>
-            <a:r>
-              <a:rPr sz="1200" b="0">
-                <a:solidFill>
-                  <a:srgbClr val="475569"/>
-                </a:solidFill>
-                <a:latin typeface="Segoe UI"/>
-              </a:rPr>
-              <a:t>2. Syntax Colored UI: Additions rendered in green, removals in red, right inside the web findings modal.</a:t>
-            </a:r>
-          </a:p>
-          <a:p>
-            <a:pPr algn="l">
-              <a:spcAft>
-                <a:spcPts val="800"/>
-              </a:spcAft>
-            </a:pPr>
-            <a:r>
-              <a:rPr sz="1200" b="1">
-                <a:solidFill>
-                  <a:srgbClr val="0F172A"/>
-                </a:solidFill>
-                <a:latin typeface="Segoe UI"/>
-              </a:rPr>
-              <a:t>3. Explicit Safety Disclaimer: Clearly labeled with amber banner requiring developer testing prior to merge.</a:t>
-            </a:r>
-          </a:p>
-          <a:p>
-            <a:pPr algn="l">
-              <a:spcAft>
-                <a:spcPts val="0"/>
-              </a:spcAft>
-            </a:pPr>
-            <a:r>
-              <a:rPr sz="1200" b="0">
-                <a:solidFill>
-                  <a:srgbClr val="16A34A"/>
-                </a:solidFill>
-                <a:latin typeface="Segoe UI"/>
-              </a:rPr>
-              <a:t>4. One-Click Copy: Engineers copy the patch, test locally, and commit with human provenance.</a:t>
-            </a:r>
-          </a:p>
-        </p:txBody>
-      </p:sp>
-      <p:sp>
-        <p:nvSpPr>
-          <p:cNvPr id="10" name="Rounded Rectangle 9"/>
+          <p:cNvPr id="9" name="Rounded Rectangle 8"/>
           <p:cNvSpPr/>
           <p:nvPr/>
         </p:nvSpPr>
         <p:spPr>
           <a:xfrm>
-            <a:off x="6492240" y="2011680"/>
+            <a:off x="6446520" y="2011680"/>
             <a:ext cx="2286000" cy="274320"/>
           </a:xfrm>
           <a:prstGeom prst="roundRect">
@@ -12160,13 +13005,116 @@
           <a:p>
             <a:pPr algn="ctr"/>
             <a:r>
-              <a:rPr sz="1000" b="1">
+              <a:rPr sz="900" b="1">
                 <a:solidFill>
                   <a:srgbClr val="2563EB"/>
                 </a:solidFill>
                 <a:latin typeface="Segoe UI"/>
               </a:rPr>
               <a:t>DEPLOYSAFE PROTOCOL</a:t>
+            </a:r>
+          </a:p>
+        </p:txBody>
+      </p:sp>
+      <p:sp>
+        <p:nvSpPr>
+          <p:cNvPr id="10" name="TextBox 9"/>
+          <p:cNvSpPr txBox="1"/>
+          <p:nvPr/>
+        </p:nvSpPr>
+        <p:spPr>
+          <a:xfrm>
+            <a:off x="6446520" y="2423160"/>
+            <a:ext cx="4785055" cy="3657600"/>
+          </a:xfrm>
+          <a:prstGeom prst="rect">
+            <a:avLst/>
+          </a:prstGeom>
+          <a:noFill/>
+        </p:spPr>
+        <p:txBody>
+          <a:bodyPr wrap="square" lIns="0" rIns="0" tIns="0" bIns="0">
+            <a:spAutoFit/>
+          </a:bodyPr>
+          <a:lstStyle/>
+          <a:p>
+            <a:pPr algn="l">
+              <a:spcAft>
+                <a:spcPts val="1000"/>
+              </a:spcAft>
+            </a:pPr>
+            <a:r>
+              <a:rPr sz="1600" b="1">
+                <a:solidFill>
+                  <a:srgbClr val="0F172A"/>
+                </a:solidFill>
+                <a:latin typeface="Segoe UI"/>
+              </a:rPr>
+              <a:t>Actionable Unified Diff Previews</a:t>
+            </a:r>
+          </a:p>
+          <a:p>
+            <a:pPr algn="l">
+              <a:spcAft>
+                <a:spcPts val="800"/>
+              </a:spcAft>
+            </a:pPr>
+            <a:r>
+              <a:rPr sz="1100" b="0">
+                <a:solidFill>
+                  <a:srgbClr val="475569"/>
+                </a:solidFill>
+                <a:latin typeface="Segoe UI"/>
+              </a:rPr>
+              <a:t>1. Standard Unified Diff Output: Formatted exactly like git diff with line offsets (@@ -x,y +a,b @@).</a:t>
+            </a:r>
+          </a:p>
+          <a:p>
+            <a:pPr algn="l">
+              <a:spcAft>
+                <a:spcPts val="800"/>
+              </a:spcAft>
+            </a:pPr>
+            <a:r>
+              <a:rPr sz="1100" b="0">
+                <a:solidFill>
+                  <a:srgbClr val="475569"/>
+                </a:solidFill>
+                <a:latin typeface="Segoe UI"/>
+              </a:rPr>
+              <a:t>2. Syntax Colored UI: Additions rendered in green, removals in red, right inside the web findings modal.</a:t>
+            </a:r>
+          </a:p>
+          <a:p>
+            <a:pPr algn="l">
+              <a:spcAft>
+                <a:spcPts val="800"/>
+              </a:spcAft>
+            </a:pPr>
+            <a:r>
+              <a:rPr sz="1100" b="1">
+                <a:solidFill>
+                  <a:srgbClr val="0F172A"/>
+                </a:solidFill>
+                <a:latin typeface="Segoe UI"/>
+              </a:rPr>
+              <a:t>3. Explicit Safety Disclaimer: Clearly labeled with amber banner requiring developer testing prior to merge.</a:t>
+            </a:r>
+          </a:p>
+          <a:p>
+            <a:pPr algn="l">
+              <a:spcAft>
+                <a:spcPts val="0"/>
+              </a:spcAft>
+            </a:pPr>
+            <a:r>
+              <a:rPr sz="1100" b="0">
+                <a:solidFill>
+                  <a:srgbClr val="16A34A"/>
+                </a:solidFill>
+                <a:latin typeface="Segoe UI"/>
+              </a:rPr>
+              <a:t>4. One-Click Copy: Engineers copy the patch, test locally, and commit with human provenance.</a:t>
             </a:r>
           </a:p>
         </p:txBody>

</xml_diff>

<commit_message>
docs: finalize intuitive PPT knowledge copy and polished card typography
</commit_message>
<xml_diff>
--- a/DeploySafe_Final_Presentation_V2.pptx
+++ b/DeploySafe_Final_Presentation_V2.pptx
@@ -3114,7 +3114,7 @@
             <a:avLst/>
           </a:prstGeom>
           <a:solidFill>
-            <a:srgbClr val="F8F9FA"/>
+            <a:srgbClr val="F8FAFC"/>
           </a:solidFill>
           <a:ln>
             <a:noFill/>
@@ -3249,11 +3249,11 @@
             <a:r>
               <a:rPr sz="1400" b="0">
                 <a:solidFill>
-                  <a:srgbClr val="475569"/>
-                </a:solidFill>
-                <a:latin typeface="Segoe UI"/>
-              </a:rPr>
-              <a:t>Cross-Boundary Architectural Hazard Detection, Adversarial Reflection &amp; Deterministic Safety Gating</a:t>
+                  <a:srgbClr val="334155"/>
+                </a:solidFill>
+                <a:latin typeface="Segoe UI"/>
+              </a:rPr>
+              <a:t>An intelligent safety shield that catches hidden production outages before you deploy.</a:t>
             </a:r>
           </a:p>
           <a:p>
@@ -3265,11 +3265,11 @@
             <a:r>
               <a:rPr sz="1200" b="0">
                 <a:solidFill>
-                  <a:srgbClr val="475569"/>
-                </a:solidFill>
-                <a:latin typeface="Segoe UI"/>
-              </a:rPr>
-              <a:t>Automating pre-release safety validation across Code, Infrastructure, Configuration, Dependencies, and Test Deficits before shipping to production.</a:t>
+                  <a:srgbClr val="334155"/>
+                </a:solidFill>
+                <a:latin typeface="Segoe UI"/>
+              </a:rPr>
+              <a:t>Eliminates deployment blind spots between Code, Docker, Cloud Configurations, and Dependencies using grounded, zero-hallucination multi-agent AI.</a:t>
             </a:r>
           </a:p>
         </p:txBody>
@@ -3349,7 +3349,7 @@
             <a:r>
               <a:rPr sz="1000" b="1">
                 <a:solidFill>
-                  <a:srgbClr val="94A3B8"/>
+                  <a:srgbClr val="64748B"/>
                 </a:solidFill>
                 <a:latin typeface="Segoe UI"/>
               </a:rPr>
@@ -3381,7 +3381,7 @@
             <a:r>
               <a:rPr sz="1300" b="1">
                 <a:solidFill>
-                  <a:srgbClr val="475569"/>
+                  <a:srgbClr val="334155"/>
                 </a:solidFill>
                 <a:latin typeface="Segoe UI"/>
               </a:rPr>
@@ -3465,7 +3465,7 @@
             <a:r>
               <a:rPr sz="1000" b="1">
                 <a:solidFill>
-                  <a:srgbClr val="94A3B8"/>
+                  <a:srgbClr val="64748B"/>
                 </a:solidFill>
                 <a:latin typeface="Segoe UI"/>
               </a:rPr>
@@ -3497,7 +3497,7 @@
             <a:r>
               <a:rPr sz="1200" b="0">
                 <a:solidFill>
-                  <a:srgbClr val="475569"/>
+                  <a:srgbClr val="334155"/>
                 </a:solidFill>
                 <a:latin typeface="Segoe UI"/>
               </a:rPr>
@@ -3601,7 +3601,7 @@
                 </a:solidFill>
                 <a:latin typeface="Segoe UI"/>
               </a:rPr>
-              <a:t>V2.0 Final Release: PASS</a:t>
+              <a:t>V2.0 Final Release: READY</a:t>
             </a:r>
           </a:p>
           <a:p>
@@ -3613,11 +3613,11 @@
             <a:r>
               <a:rPr sz="1200" b="0">
                 <a:solidFill>
-                  <a:srgbClr val="475569"/>
-                </a:solidFill>
-                <a:latin typeface="Segoe UI"/>
-              </a:rPr>
-              <a:t>98/98 Tests Passing • 0 Failures</a:t>
+                  <a:srgbClr val="334155"/>
+                </a:solidFill>
+                <a:latin typeface="Segoe UI"/>
+              </a:rPr>
+              <a:t>98/98 Tests Passing • 0 Regressions</a:t>
             </a:r>
           </a:p>
         </p:txBody>
@@ -3655,7 +3655,7 @@
             <a:avLst/>
           </a:prstGeom>
           <a:solidFill>
-            <a:srgbClr val="F8F9FA"/>
+            <a:srgbClr val="F8FAFC"/>
           </a:solidFill>
           <a:ln>
             <a:noFill/>
@@ -3692,7 +3692,7 @@
         <p:spPr>
           <a:xfrm>
             <a:off x="731520" y="411480"/>
-            <a:ext cx="3840480" cy="292608"/>
+            <a:ext cx="4023360" cy="292608"/>
           </a:xfrm>
           <a:prstGeom prst="roundRect">
             <a:avLst/>
@@ -3761,7 +3761,7 @@
             <a:r>
               <a:rPr sz="1100" b="1">
                 <a:solidFill>
-                  <a:srgbClr val="94A3B8"/>
+                  <a:srgbClr val="64748B"/>
                 </a:solidFill>
                 <a:latin typeface="Segoe UI"/>
               </a:rPr>
@@ -3816,7 +3816,7 @@
             <a:r>
               <a:rPr sz="1200" b="0">
                 <a:solidFill>
-                  <a:srgbClr val="475569"/>
+                  <a:srgbClr val="334155"/>
                 </a:solidFill>
                 <a:latin typeface="Segoe UI"/>
               </a:rPr>
@@ -3932,7 +3932,7 @@
             <a:r>
               <a:rPr sz="1000" b="0">
                 <a:solidFill>
-                  <a:srgbClr val="475569"/>
+                  <a:srgbClr val="334155"/>
                 </a:solidFill>
                 <a:latin typeface="Segoe UI"/>
               </a:rPr>
@@ -4048,7 +4048,7 @@
             <a:r>
               <a:rPr sz="1000" b="0">
                 <a:solidFill>
-                  <a:srgbClr val="475569"/>
+                  <a:srgbClr val="334155"/>
                 </a:solidFill>
                 <a:latin typeface="Segoe UI"/>
               </a:rPr>
@@ -4164,7 +4164,7 @@
             <a:r>
               <a:rPr sz="1000" b="0">
                 <a:solidFill>
-                  <a:srgbClr val="475569"/>
+                  <a:srgbClr val="334155"/>
                 </a:solidFill>
                 <a:latin typeface="Segoe UI"/>
               </a:rPr>
@@ -4280,7 +4280,7 @@
             <a:r>
               <a:rPr sz="1000" b="0">
                 <a:solidFill>
-                  <a:srgbClr val="475569"/>
+                  <a:srgbClr val="334155"/>
                 </a:solidFill>
                 <a:latin typeface="Segoe UI"/>
               </a:rPr>
@@ -4487,7 +4487,7 @@
             <a:r>
               <a:rPr sz="1000" b="0">
                 <a:solidFill>
-                  <a:srgbClr val="475569"/>
+                  <a:srgbClr val="334155"/>
                 </a:solidFill>
                 <a:latin typeface="Segoe UI"/>
               </a:rPr>
@@ -4688,7 +4688,7 @@
             <a:r>
               <a:rPr sz="1000" b="0">
                 <a:solidFill>
-                  <a:srgbClr val="475569"/>
+                  <a:srgbClr val="334155"/>
                 </a:solidFill>
                 <a:latin typeface="Segoe UI"/>
               </a:rPr>
@@ -4889,7 +4889,7 @@
             <a:r>
               <a:rPr sz="1000" b="0">
                 <a:solidFill>
-                  <a:srgbClr val="475569"/>
+                  <a:srgbClr val="334155"/>
                 </a:solidFill>
                 <a:latin typeface="Segoe UI"/>
               </a:rPr>
@@ -5090,7 +5090,7 @@
             <a:r>
               <a:rPr sz="1000" b="0">
                 <a:solidFill>
-                  <a:srgbClr val="475569"/>
+                  <a:srgbClr val="334155"/>
                 </a:solidFill>
                 <a:latin typeface="Segoe UI"/>
               </a:rPr>
@@ -5291,7 +5291,7 @@
             <a:r>
               <a:rPr sz="1000" b="0">
                 <a:solidFill>
-                  <a:srgbClr val="475569"/>
+                  <a:srgbClr val="334155"/>
                 </a:solidFill>
                 <a:latin typeface="Segoe UI"/>
               </a:rPr>
@@ -5411,7 +5411,7 @@
             <a:avLst/>
           </a:prstGeom>
           <a:solidFill>
-            <a:srgbClr val="F8F9FA"/>
+            <a:srgbClr val="F8FAFC"/>
           </a:solidFill>
           <a:ln>
             <a:noFill/>
@@ -5448,7 +5448,7 @@
         <p:spPr>
           <a:xfrm>
             <a:off x="731520" y="411480"/>
-            <a:ext cx="3840480" cy="292608"/>
+            <a:ext cx="4023360" cy="292608"/>
           </a:xfrm>
           <a:prstGeom prst="roundRect">
             <a:avLst/>
@@ -5517,7 +5517,7 @@
             <a:r>
               <a:rPr sz="1100" b="1">
                 <a:solidFill>
-                  <a:srgbClr val="94A3B8"/>
+                  <a:srgbClr val="64748B"/>
                 </a:solidFill>
                 <a:latin typeface="Segoe UI"/>
               </a:rPr>
@@ -5572,7 +5572,7 @@
             <a:r>
               <a:rPr sz="1200" b="0">
                 <a:solidFill>
-                  <a:srgbClr val="475569"/>
+                  <a:srgbClr val="334155"/>
                 </a:solidFill>
                 <a:latin typeface="Segoe UI"/>
               </a:rPr>
@@ -5724,7 +5724,7 @@
             <a:r>
               <a:rPr sz="1100" b="0">
                 <a:solidFill>
-                  <a:srgbClr val="475569"/>
+                  <a:srgbClr val="334155"/>
                 </a:solidFill>
                 <a:latin typeface="Segoe UI"/>
               </a:rPr>
@@ -5740,7 +5740,7 @@
             <a:r>
               <a:rPr sz="1100" b="0">
                 <a:solidFill>
-                  <a:srgbClr val="475569"/>
+                  <a:srgbClr val="334155"/>
                 </a:solidFill>
                 <a:latin typeface="Segoe UI"/>
               </a:rPr>
@@ -5756,7 +5756,7 @@
             <a:r>
               <a:rPr sz="1100" b="0">
                 <a:solidFill>
-                  <a:srgbClr val="475569"/>
+                  <a:srgbClr val="334155"/>
                 </a:solidFill>
                 <a:latin typeface="Segoe UI"/>
               </a:rPr>
@@ -5772,7 +5772,7 @@
             <a:r>
               <a:rPr sz="1100" b="0">
                 <a:solidFill>
-                  <a:srgbClr val="475569"/>
+                  <a:srgbClr val="334155"/>
                 </a:solidFill>
                 <a:latin typeface="Segoe UI"/>
               </a:rPr>
@@ -5940,7 +5940,7 @@
             <a:r>
               <a:rPr sz="1100" b="0">
                 <a:solidFill>
-                  <a:srgbClr val="475569"/>
+                  <a:srgbClr val="334155"/>
                 </a:solidFill>
                 <a:latin typeface="Segoe UI"/>
               </a:rPr>
@@ -5956,7 +5956,7 @@
             <a:r>
               <a:rPr sz="1100" b="0">
                 <a:solidFill>
-                  <a:srgbClr val="475569"/>
+                  <a:srgbClr val="334155"/>
                 </a:solidFill>
                 <a:latin typeface="Segoe UI"/>
               </a:rPr>
@@ -5972,7 +5972,7 @@
             <a:r>
               <a:rPr sz="1100" b="0">
                 <a:solidFill>
-                  <a:srgbClr val="475569"/>
+                  <a:srgbClr val="334155"/>
                 </a:solidFill>
                 <a:latin typeface="Segoe UI"/>
               </a:rPr>
@@ -5988,7 +5988,7 @@
             <a:r>
               <a:rPr sz="1100" b="0">
                 <a:solidFill>
-                  <a:srgbClr val="475569"/>
+                  <a:srgbClr val="334155"/>
                 </a:solidFill>
                 <a:latin typeface="Segoe UI"/>
               </a:rPr>
@@ -6140,7 +6140,7 @@
             <a:r>
               <a:rPr sz="1100" b="0">
                 <a:solidFill>
-                  <a:srgbClr val="475569"/>
+                  <a:srgbClr val="334155"/>
                 </a:solidFill>
                 <a:latin typeface="Segoe UI"/>
               </a:rPr>
@@ -6156,7 +6156,7 @@
             <a:r>
               <a:rPr sz="1100" b="0">
                 <a:solidFill>
-                  <a:srgbClr val="475569"/>
+                  <a:srgbClr val="334155"/>
                 </a:solidFill>
                 <a:latin typeface="Segoe UI"/>
               </a:rPr>
@@ -6172,7 +6172,7 @@
             <a:r>
               <a:rPr sz="1100" b="0">
                 <a:solidFill>
-                  <a:srgbClr val="475569"/>
+                  <a:srgbClr val="334155"/>
                 </a:solidFill>
                 <a:latin typeface="Segoe UI"/>
               </a:rPr>
@@ -6230,7 +6230,7 @@
             <a:avLst/>
           </a:prstGeom>
           <a:solidFill>
-            <a:srgbClr val="F8F9FA"/>
+            <a:srgbClr val="F8FAFC"/>
           </a:solidFill>
           <a:ln>
             <a:noFill/>
@@ -6267,7 +6267,7 @@
         <p:spPr>
           <a:xfrm>
             <a:off x="731520" y="411480"/>
-            <a:ext cx="3840480" cy="292608"/>
+            <a:ext cx="4023360" cy="292608"/>
           </a:xfrm>
           <a:prstGeom prst="roundRect">
             <a:avLst/>
@@ -6336,7 +6336,7 @@
             <a:r>
               <a:rPr sz="1100" b="1">
                 <a:solidFill>
-                  <a:srgbClr val="94A3B8"/>
+                  <a:srgbClr val="64748B"/>
                 </a:solidFill>
                 <a:latin typeface="Segoe UI"/>
               </a:rPr>
@@ -6391,7 +6391,7 @@
             <a:r>
               <a:rPr sz="1200" b="0">
                 <a:solidFill>
-                  <a:srgbClr val="475569"/>
+                  <a:srgbClr val="334155"/>
                 </a:solidFill>
                 <a:latin typeface="Segoe UI"/>
               </a:rPr>
@@ -6491,7 +6491,7 @@
             <a:r>
               <a:rPr sz="1100" b="0">
                 <a:solidFill>
-                  <a:srgbClr val="475569"/>
+                  <a:srgbClr val="334155"/>
                 </a:solidFill>
                 <a:latin typeface="Segoe UI"/>
               </a:rPr>
@@ -6507,7 +6507,7 @@
             <a:r>
               <a:rPr sz="1100" b="0">
                 <a:solidFill>
-                  <a:srgbClr val="475569"/>
+                  <a:srgbClr val="334155"/>
                 </a:solidFill>
                 <a:latin typeface="Segoe UI"/>
               </a:rPr>
@@ -6523,7 +6523,7 @@
             <a:r>
               <a:rPr sz="1100" b="0">
                 <a:solidFill>
-                  <a:srgbClr val="475569"/>
+                  <a:srgbClr val="334155"/>
                 </a:solidFill>
                 <a:latin typeface="Segoe UI"/>
               </a:rPr>
@@ -6539,7 +6539,7 @@
             <a:r>
               <a:rPr sz="1100" b="0">
                 <a:solidFill>
-                  <a:srgbClr val="475569"/>
+                  <a:srgbClr val="334155"/>
                 </a:solidFill>
                 <a:latin typeface="Segoe UI"/>
               </a:rPr>
@@ -6707,7 +6707,7 @@
             <a:r>
               <a:rPr sz="1100" b="0">
                 <a:solidFill>
-                  <a:srgbClr val="475569"/>
+                  <a:srgbClr val="334155"/>
                 </a:solidFill>
                 <a:latin typeface="Segoe UI"/>
               </a:rPr>
@@ -6739,7 +6739,7 @@
             <a:r>
               <a:rPr sz="1100" b="0">
                 <a:solidFill>
-                  <a:srgbClr val="475569"/>
+                  <a:srgbClr val="334155"/>
                 </a:solidFill>
                 <a:latin typeface="Segoe UI"/>
               </a:rPr>
@@ -6797,7 +6797,7 @@
             <a:avLst/>
           </a:prstGeom>
           <a:solidFill>
-            <a:srgbClr val="F8F9FA"/>
+            <a:srgbClr val="F8FAFC"/>
           </a:solidFill>
           <a:ln>
             <a:noFill/>
@@ -6834,7 +6834,7 @@
         <p:spPr>
           <a:xfrm>
             <a:off x="731520" y="411480"/>
-            <a:ext cx="3840480" cy="292608"/>
+            <a:ext cx="4023360" cy="292608"/>
           </a:xfrm>
           <a:prstGeom prst="roundRect">
             <a:avLst/>
@@ -6903,7 +6903,7 @@
             <a:r>
               <a:rPr sz="1100" b="1">
                 <a:solidFill>
-                  <a:srgbClr val="94A3B8"/>
+                  <a:srgbClr val="64748B"/>
                 </a:solidFill>
                 <a:latin typeface="Segoe UI"/>
               </a:rPr>
@@ -6946,7 +6946,7 @@
                 </a:solidFill>
                 <a:latin typeface="Segoe UI"/>
               </a:rPr>
-              <a:t>The Pre-Deployment Blind Spot: Why CI/CD Fails</a:t>
+              <a:t>The Pre-Deployment Blind Spot: Why Good Code Breaks</a:t>
             </a:r>
           </a:p>
           <a:p>
@@ -6958,7 +6958,7 @@
             <a:r>
               <a:rPr sz="1200" b="0">
                 <a:solidFill>
-                  <a:srgbClr val="475569"/>
+                  <a:srgbClr val="334155"/>
                 </a:solidFill>
                 <a:latin typeface="Segoe UI"/>
               </a:rPr>
@@ -7098,7 +7098,7 @@
                 </a:solidFill>
                 <a:latin typeface="Segoe UI"/>
               </a:rPr>
-              <a:t>Imperative Script Blindness</a:t>
+              <a:t>Tests Run in Isolation</a:t>
             </a:r>
           </a:p>
           <a:p>
@@ -7110,11 +7110,11 @@
             <a:r>
               <a:rPr sz="1100" b="0">
                 <a:solidFill>
-                  <a:srgbClr val="475569"/>
-                </a:solidFill>
-                <a:latin typeface="Segoe UI"/>
-              </a:rPr>
-              <a:t>• Standard CI runs tests in isolation (pytest, npm test) with zero semantic cross-artifact reasoning.</a:t>
+                  <a:srgbClr val="334155"/>
+                </a:solidFill>
+                <a:latin typeface="Segoe UI"/>
+              </a:rPr>
+              <a:t>• Unit tests check small functions in isolation, but miss the big picture.</a:t>
             </a:r>
           </a:p>
           <a:p>
@@ -7126,11 +7126,11 @@
             <a:r>
               <a:rPr sz="1100" b="0">
                 <a:solidFill>
-                  <a:srgbClr val="475569"/>
-                </a:solidFill>
-                <a:latin typeface="Segoe UI"/>
-              </a:rPr>
-              <a:t>• Static linters flag style nits but miss holistic architectural drift.</a:t>
+                  <a:srgbClr val="334155"/>
+                </a:solidFill>
+                <a:latin typeface="Segoe UI"/>
+              </a:rPr>
+              <a:t>• Linters check code style and semicolons, but cannot detect architectural drift.</a:t>
             </a:r>
           </a:p>
           <a:p>
@@ -7142,11 +7142,11 @@
             <a:r>
               <a:rPr sz="1100" b="0">
                 <a:solidFill>
-                  <a:srgbClr val="475569"/>
-                </a:solidFill>
-                <a:latin typeface="Segoe UI"/>
-              </a:rPr>
-              <a:t>• A pull request can have 100% test pass rate while silently breaking Docker port mappings or database URLs.</a:t>
+                  <a:srgbClr val="334155"/>
+                </a:solidFill>
+                <a:latin typeface="Segoe UI"/>
+              </a:rPr>
+              <a:t>• A pull request can have 100% test pass rate while silently breaking Docker networking or database credentials.</a:t>
             </a:r>
           </a:p>
         </p:txBody>
@@ -7282,7 +7282,7 @@
                 </a:solidFill>
                 <a:latin typeface="Segoe UI"/>
               </a:rPr>
-              <a:t>Cross-Boundary Breakages</a:t>
+              <a:t>Breakages at the Seams</a:t>
             </a:r>
           </a:p>
           <a:p>
@@ -7294,11 +7294,11 @@
             <a:r>
               <a:rPr sz="1100" b="0">
                 <a:solidFill>
-                  <a:srgbClr val="475569"/>
-                </a:solidFill>
-                <a:latin typeface="Segoe UI"/>
-              </a:rPr>
-              <a:t>• Environment Drift: Code consumes DATABASE_URL but Docker Compose defines DB_URL.</a:t>
+                  <a:srgbClr val="334155"/>
+                </a:solidFill>
+                <a:latin typeface="Segoe UI"/>
+              </a:rPr>
+              <a:t>• Config Mismatches: Code consumes DATABASE_URL, but Docker defines DB_URL.</a:t>
             </a:r>
           </a:p>
           <a:p>
@@ -7310,11 +7310,11 @@
             <a:r>
               <a:rPr sz="1100" b="0">
                 <a:solidFill>
-                  <a:srgbClr val="475569"/>
-                </a:solidFill>
-                <a:latin typeface="Segoe UI"/>
-              </a:rPr>
-              <a:t>• Security Drift: Hardcoded credentials, unpinned container tags (:latest), or containers running as root.</a:t>
+                  <a:srgbClr val="334155"/>
+                </a:solidFill>
+                <a:latin typeface="Segoe UI"/>
+              </a:rPr>
+              <a:t>• Container Drift: Unpinned tags (:latest) update upstream and crash deployments.</a:t>
             </a:r>
           </a:p>
           <a:p>
@@ -7326,11 +7326,11 @@
             <a:r>
               <a:rPr sz="1100" b="0">
                 <a:solidFill>
-                  <a:srgbClr val="475569"/>
-                </a:solidFill>
-                <a:latin typeface="Segoe UI"/>
-              </a:rPr>
-              <a:t>• Dependency Vulns: Direct or transitive packages affected by published CVEs.</a:t>
+                  <a:srgbClr val="334155"/>
+                </a:solidFill>
+                <a:latin typeface="Segoe UI"/>
+              </a:rPr>
+              <a:t>• Security Leaks: Hardcoded API keys and unencrypted credentials slipping into git.</a:t>
             </a:r>
           </a:p>
         </p:txBody>
@@ -7466,7 +7466,7 @@
                 </a:solidFill>
                 <a:latin typeface="Segoe UI"/>
               </a:rPr>
-              <a:t>The Generic AI Trap</a:t>
+              <a:t>Why Raw AI Fails</a:t>
             </a:r>
           </a:p>
           <a:p>
@@ -7478,11 +7478,11 @@
             <a:r>
               <a:rPr sz="1100" b="0">
                 <a:solidFill>
-                  <a:srgbClr val="475569"/>
-                </a:solidFill>
-                <a:latin typeface="Segoe UI"/>
-              </a:rPr>
-              <a:t>• Standard LLMs hallucinate non-existent files, wrong line numbers, and fake security issues.</a:t>
+                  <a:srgbClr val="334155"/>
+                </a:solidFill>
+                <a:latin typeface="Segoe UI"/>
+              </a:rPr>
+              <a:t>• Generic LLMs hallucinate non-existent files and invent fake line numbers.</a:t>
             </a:r>
           </a:p>
           <a:p>
@@ -7494,11 +7494,11 @@
             <a:r>
               <a:rPr sz="1100" b="0">
                 <a:solidFill>
-                  <a:srgbClr val="475569"/>
-                </a:solidFill>
-                <a:latin typeface="Segoe UI"/>
-              </a:rPr>
-              <a:t>• Single-prompt analysis lacks grounding, verification, and deterministic scoring.</a:t>
+                  <a:srgbClr val="334155"/>
+                </a:solidFill>
+                <a:latin typeface="Segoe UI"/>
+              </a:rPr>
+              <a:t>• Single prompts lack real code grounding and mathematical scoring.</a:t>
             </a:r>
           </a:p>
           <a:p>
@@ -7510,11 +7510,11 @@
             <a:r>
               <a:rPr sz="1100" b="0">
                 <a:solidFill>
-                  <a:srgbClr val="475569"/>
-                </a:solidFill>
-                <a:latin typeface="Segoe UI"/>
-              </a:rPr>
-              <a:t>• Result: High developer alert fatigue and immediate rejection of ungrounded AI tooling.</a:t>
+                  <a:srgbClr val="334155"/>
+                </a:solidFill>
+                <a:latin typeface="Segoe UI"/>
+              </a:rPr>
+              <a:t>• Developers get alert fatigue and immediately reject untrusted AI tools.</a:t>
             </a:r>
           </a:p>
         </p:txBody>
@@ -7552,7 +7552,7 @@
             <a:avLst/>
           </a:prstGeom>
           <a:solidFill>
-            <a:srgbClr val="F8F9FA"/>
+            <a:srgbClr val="F8FAFC"/>
           </a:solidFill>
           <a:ln>
             <a:noFill/>
@@ -7589,7 +7589,7 @@
         <p:spPr>
           <a:xfrm>
             <a:off x="731520" y="411480"/>
-            <a:ext cx="3840480" cy="292608"/>
+            <a:ext cx="4023360" cy="292608"/>
           </a:xfrm>
           <a:prstGeom prst="roundRect">
             <a:avLst/>
@@ -7658,7 +7658,7 @@
             <a:r>
               <a:rPr sz="1100" b="1">
                 <a:solidFill>
-                  <a:srgbClr val="94A3B8"/>
+                  <a:srgbClr val="64748B"/>
                 </a:solidFill>
                 <a:latin typeface="Segoe UI"/>
               </a:rPr>
@@ -7701,7 +7701,7 @@
                 </a:solidFill>
                 <a:latin typeface="Segoe UI"/>
               </a:rPr>
-              <a:t>DeploySafe Core Architecture &amp; Orchestration Flow</a:t>
+              <a:t>DeploySafe Solution: The Multi-Agent Safety Flow</a:t>
             </a:r>
           </a:p>
           <a:p>
@@ -7713,11 +7713,11 @@
             <a:r>
               <a:rPr sz="1200" b="0">
                 <a:solidFill>
-                  <a:srgbClr val="475569"/>
-                </a:solidFill>
-                <a:latin typeface="Segoe UI"/>
-              </a:rPr>
-              <a:t>Dynamic planning, parallel domain agents, adversarial reflection, and deterministic scoring.</a:t>
+                  <a:srgbClr val="334155"/>
+                </a:solidFill>
+                <a:latin typeface="Segoe UI"/>
+              </a:rPr>
+              <a:t>Dynamic planning, parallel domain agents, adversarial reflection, and deterministic safety gates.</a:t>
             </a:r>
           </a:p>
         </p:txBody>
@@ -7865,11 +7865,11 @@
             <a:r>
               <a:rPr sz="1100" b="0">
                 <a:solidFill>
-                  <a:srgbClr val="475569"/>
-                </a:solidFill>
-                <a:latin typeface="Segoe UI"/>
-              </a:rPr>
-              <a:t>• Git diff extraction &amp; AST file discovery.</a:t>
+                  <a:srgbClr val="334155"/>
+                </a:solidFill>
+                <a:latin typeface="Segoe UI"/>
+              </a:rPr>
+              <a:t>• Reads git commit diffs &amp; file trees.</a:t>
             </a:r>
           </a:p>
           <a:p>
@@ -7881,11 +7881,11 @@
             <a:r>
               <a:rPr sz="1100" b="0">
                 <a:solidFill>
-                  <a:srgbClr val="475569"/>
-                </a:solidFill>
-                <a:latin typeface="Segoe UI"/>
-              </a:rPr>
-              <a:t>• Pre-ingestion regex secret scrubbing.</a:t>
+                  <a:srgbClr val="334155"/>
+                </a:solidFill>
+                <a:latin typeface="Segoe UI"/>
+              </a:rPr>
+              <a:t>• Scrubs secrets before sending to AI.</a:t>
             </a:r>
           </a:p>
           <a:p>
@@ -7897,11 +7897,11 @@
             <a:r>
               <a:rPr sz="1100" b="0">
                 <a:solidFill>
-                  <a:srgbClr val="475569"/>
-                </a:solidFill>
-                <a:latin typeface="Segoe UI"/>
-              </a:rPr>
-              <a:t>• Planner dynamically activates domain agents based on touched file types.</a:t>
+                  <a:srgbClr val="334155"/>
+                </a:solidFill>
+                <a:latin typeface="Segoe UI"/>
+              </a:rPr>
+              <a:t>• Planner activates only the agents needed for the modified files.</a:t>
             </a:r>
           </a:p>
           <a:p>
@@ -7913,7 +7913,7 @@
             <a:r>
               <a:rPr sz="1100" b="0">
                 <a:solidFill>
-                  <a:srgbClr val="475569"/>
+                  <a:srgbClr val="334155"/>
                 </a:solidFill>
                 <a:latin typeface="Segoe UI"/>
               </a:rPr>
@@ -8117,7 +8117,7 @@
                 </a:solidFill>
                 <a:latin typeface="Segoe UI"/>
               </a:rPr>
-              <a:t>• Test Path Analysis Agent</a:t>
+              <a:t>• Test Path Coverage Agent</a:t>
             </a:r>
           </a:p>
           <a:p>
@@ -8145,7 +8145,7 @@
             <a:r>
               <a:rPr sz="1100" b="0">
                 <a:solidFill>
-                  <a:srgbClr val="475569"/>
+                  <a:srgbClr val="334155"/>
                 </a:solidFill>
                 <a:latin typeface="Segoe UI"/>
               </a:rPr>
@@ -8297,11 +8297,11 @@
             <a:r>
               <a:rPr sz="1100" b="0">
                 <a:solidFill>
-                  <a:srgbClr val="475569"/>
-                </a:solidFill>
-                <a:latin typeface="Segoe UI"/>
-              </a:rPr>
-              <a:t>• Adversarial verification of all candidate findings.</a:t>
+                  <a:srgbClr val="334155"/>
+                </a:solidFill>
+                <a:latin typeface="Segoe UI"/>
+              </a:rPr>
+              <a:t>• Adversarial audit of every candidate finding.</a:t>
             </a:r>
           </a:p>
           <a:p>
@@ -8313,7 +8313,7 @@
             <a:r>
               <a:rPr sz="1100" b="0">
                 <a:solidFill>
-                  <a:srgbClr val="475569"/>
+                  <a:srgbClr val="334155"/>
                 </a:solidFill>
                 <a:latin typeface="Segoe UI"/>
               </a:rPr>
@@ -8329,11 +8329,11 @@
             <a:r>
               <a:rPr sz="1100" b="0">
                 <a:solidFill>
-                  <a:srgbClr val="475569"/>
-                </a:solidFill>
-                <a:latin typeface="Segoe UI"/>
-              </a:rPr>
-              <a:t>• Line Bounds Range validation.</a:t>
+                  <a:srgbClr val="334155"/>
+                </a:solidFill>
+                <a:latin typeface="Segoe UI"/>
+              </a:rPr>
+              <a:t>• Line Number Range check.</a:t>
             </a:r>
           </a:p>
           <a:p>
@@ -8345,11 +8345,11 @@
             <a:r>
               <a:rPr sz="1100" b="0">
                 <a:solidFill>
-                  <a:srgbClr val="475569"/>
-                </a:solidFill>
-                <a:latin typeface="Segoe UI"/>
-              </a:rPr>
-              <a:t>• Literal Code Snippet matching.</a:t>
+                  <a:srgbClr val="334155"/>
+                </a:solidFill>
+                <a:latin typeface="Segoe UI"/>
+              </a:rPr>
+              <a:t>• Literal Code Snippet match.</a:t>
             </a:r>
           </a:p>
           <a:p>
@@ -8513,11 +8513,11 @@
             <a:r>
               <a:rPr sz="1100" b="0">
                 <a:solidFill>
-                  <a:srgbClr val="475569"/>
-                </a:solidFill>
-                <a:latin typeface="Segoe UI"/>
-              </a:rPr>
-              <a:t>• Deterministic 0–100 mathematical risk scoring.</a:t>
+                  <a:srgbClr val="334155"/>
+                </a:solidFill>
+                <a:latin typeface="Segoe UI"/>
+              </a:rPr>
+              <a:t>• Deterministic 0–100 mathematical risk score.</a:t>
             </a:r>
           </a:p>
           <a:p>
@@ -8529,7 +8529,7 @@
             <a:r>
               <a:rPr sz="1100" b="0">
                 <a:solidFill>
-                  <a:srgbClr val="475569"/>
+                  <a:srgbClr val="334155"/>
                 </a:solidFill>
                 <a:latin typeface="Segoe UI"/>
               </a:rPr>
@@ -8545,7 +8545,7 @@
             <a:r>
               <a:rPr sz="1100" b="0">
                 <a:solidFill>
-                  <a:srgbClr val="475569"/>
+                  <a:srgbClr val="334155"/>
                 </a:solidFill>
                 <a:latin typeface="Segoe UI"/>
               </a:rPr>
@@ -8561,7 +8561,7 @@
             <a:r>
               <a:rPr sz="1100" b="0">
                 <a:solidFill>
-                  <a:srgbClr val="475569"/>
+                  <a:srgbClr val="334155"/>
                 </a:solidFill>
                 <a:latin typeface="Segoe UI"/>
               </a:rPr>
@@ -8603,7 +8603,7 @@
             <a:avLst/>
           </a:prstGeom>
           <a:solidFill>
-            <a:srgbClr val="F8F9FA"/>
+            <a:srgbClr val="F8FAFC"/>
           </a:solidFill>
           <a:ln>
             <a:noFill/>
@@ -8640,7 +8640,7 @@
         <p:spPr>
           <a:xfrm>
             <a:off x="731520" y="411480"/>
-            <a:ext cx="3840480" cy="292608"/>
+            <a:ext cx="4023360" cy="292608"/>
           </a:xfrm>
           <a:prstGeom prst="roundRect">
             <a:avLst/>
@@ -8709,7 +8709,7 @@
             <a:r>
               <a:rPr sz="1100" b="1">
                 <a:solidFill>
-                  <a:srgbClr val="94A3B8"/>
+                  <a:srgbClr val="64748B"/>
                 </a:solidFill>
                 <a:latin typeface="Segoe UI"/>
               </a:rPr>
@@ -8752,7 +8752,7 @@
                 </a:solidFill>
                 <a:latin typeface="Segoe UI"/>
               </a:rPr>
-              <a:t>Specialized Domain Agents: Targeted Hazard Detection</a:t>
+              <a:t>Meet the 5 Specialized Domain Agents</a:t>
             </a:r>
           </a:p>
           <a:p>
@@ -8764,11 +8764,11 @@
             <a:r>
               <a:rPr sz="1200" b="0">
                 <a:solidFill>
-                  <a:srgbClr val="475569"/>
-                </a:solidFill>
-                <a:latin typeface="Segoe UI"/>
-              </a:rPr>
-              <a:t>Each agent is bound to a strict persona, deterministic toolset, and structured output schema.</a:t>
+                  <a:srgbClr val="334155"/>
+                </a:solidFill>
+                <a:latin typeface="Segoe UI"/>
+              </a:rPr>
+              <a:t>Each agent specializes in one critical aspect of your software repository.</a:t>
             </a:r>
           </a:p>
         </p:txBody>
@@ -8852,7 +8852,7 @@
                 </a:solidFill>
                 <a:latin typeface="Segoe UI"/>
               </a:rPr>
-              <a:t>1. Code Analysis Agent</a:t>
+              <a:t>1. Code Quality Agent</a:t>
             </a:r>
           </a:p>
           <a:p>
@@ -8864,11 +8864,11 @@
             <a:r>
               <a:rPr sz="1100" b="0">
                 <a:solidFill>
-                  <a:srgbClr val="475569"/>
-                </a:solidFill>
-                <a:latin typeface="Segoe UI"/>
-              </a:rPr>
-              <a:t>• Evaluates AST, structural code smells, unhandled async exceptions, resource leaks.</a:t>
+                  <a:srgbClr val="334155"/>
+                </a:solidFill>
+                <a:latin typeface="Segoe UI"/>
+              </a:rPr>
+              <a:t>• Catches silent error swallowing, resource leaks, and unhandled async crashes.</a:t>
             </a:r>
           </a:p>
           <a:p>
@@ -8880,11 +8880,11 @@
             <a:r>
               <a:rPr sz="1100" b="0">
                 <a:solidFill>
-                  <a:srgbClr val="475569"/>
-                </a:solidFill>
-                <a:latin typeface="Segoe UI"/>
-              </a:rPr>
-              <a:t>• Analyzes commit diff additions/deletions against full file context.</a:t>
+                  <a:srgbClr val="334155"/>
+                </a:solidFill>
+                <a:latin typeface="Segoe UI"/>
+              </a:rPr>
+              <a:t>• Analyzes pull request changes against the full file context.</a:t>
             </a:r>
           </a:p>
         </p:txBody>
@@ -8968,7 +8968,7 @@
                 </a:solidFill>
                 <a:latin typeface="Segoe UI"/>
               </a:rPr>
-              <a:t>2. Config &amp; Infra Agent</a:t>
+              <a:t>2. Config &amp; Docker Agent</a:t>
             </a:r>
           </a:p>
           <a:p>
@@ -8980,11 +8980,11 @@
             <a:r>
               <a:rPr sz="1100" b="0">
                 <a:solidFill>
-                  <a:srgbClr val="475569"/>
-                </a:solidFill>
-                <a:latin typeface="Segoe UI"/>
-              </a:rPr>
-              <a:t>• Validates Dockerfile, docker-compose.yml, K8s manifests, and .env files.</a:t>
+                  <a:srgbClr val="334155"/>
+                </a:solidFill>
+                <a:latin typeface="Segoe UI"/>
+              </a:rPr>
+              <a:t>• Scans Dockerfiles, compose configs, and Kubernetes manifests.</a:t>
             </a:r>
           </a:p>
           <a:p>
@@ -8996,11 +8996,11 @@
             <a:r>
               <a:rPr sz="1100" b="0">
                 <a:solidFill>
-                  <a:srgbClr val="475569"/>
-                </a:solidFill>
-                <a:latin typeface="Segoe UI"/>
-              </a:rPr>
-              <a:t>• Detects unpinned tags, root users, debug flags enabled in production.</a:t>
+                  <a:srgbClr val="334155"/>
+                </a:solidFill>
+                <a:latin typeface="Segoe UI"/>
+              </a:rPr>
+              <a:t>• Catches unpinned container tags (:latest), root users, and debug flags.</a:t>
             </a:r>
           </a:p>
         </p:txBody>
@@ -9096,11 +9096,11 @@
             <a:r>
               <a:rPr sz="1100" b="0">
                 <a:solidFill>
-                  <a:srgbClr val="475569"/>
-                </a:solidFill>
-                <a:latin typeface="Segoe UI"/>
-              </a:rPr>
-              <a:t>• Scans requirements.txt, package.json, pyproject.toml, Pipfile.</a:t>
+                  <a:srgbClr val="334155"/>
+                </a:solidFill>
+                <a:latin typeface="Segoe UI"/>
+              </a:rPr>
+              <a:t>• Inspects package.json, requirements.txt, and lockfiles.</a:t>
             </a:r>
           </a:p>
           <a:p>
@@ -9112,11 +9112,11 @@
             <a:r>
               <a:rPr sz="1100" b="0">
                 <a:solidFill>
-                  <a:srgbClr val="475569"/>
-                </a:solidFill>
-                <a:latin typeface="Segoe UI"/>
-              </a:rPr>
-              <a:t>• Cross-references advisory databases for known CVEs and breaking deprecations.</a:t>
+                  <a:srgbClr val="334155"/>
+                </a:solidFill>
+                <a:latin typeface="Segoe UI"/>
+              </a:rPr>
+              <a:t>• Flags known CVE vulnerabilities and broken deprecated libraries.</a:t>
             </a:r>
           </a:p>
         </p:txBody>
@@ -9200,7 +9200,7 @@
                 </a:solidFill>
                 <a:latin typeface="Segoe UI"/>
               </a:rPr>
-              <a:t>4. Test Path &amp; Coverage Agent</a:t>
+              <a:t>4. Test Coverage Agent</a:t>
             </a:r>
           </a:p>
           <a:p>
@@ -9212,11 +9212,11 @@
             <a:r>
               <a:rPr sz="1100" b="0">
                 <a:solidFill>
-                  <a:srgbClr val="475569"/>
-                </a:solidFill>
-                <a:latin typeface="Segoe UI"/>
-              </a:rPr>
-              <a:t>• Identifies untested critical execution paths touched in diffs (auth, billing, payment tokens).</a:t>
+                  <a:srgbClr val="334155"/>
+                </a:solidFill>
+                <a:latin typeface="Segoe UI"/>
+              </a:rPr>
+              <a:t>• Identifies untested critical paths modified in pull requests (auth, payments, billing).</a:t>
             </a:r>
           </a:p>
           <a:p>
@@ -9228,11 +9228,11 @@
             <a:r>
               <a:rPr sz="1100" b="0">
                 <a:solidFill>
-                  <a:srgbClr val="475569"/>
-                </a:solidFill>
-                <a:latin typeface="Segoe UI"/>
-              </a:rPr>
-              <a:t>• Verifies that high-risk modified functions have corresponding test assertions.</a:t>
+                  <a:srgbClr val="334155"/>
+                </a:solidFill>
+                <a:latin typeface="Segoe UI"/>
+              </a:rPr>
+              <a:t>• Warns developers before risky modified code ships without regression tests.</a:t>
             </a:r>
           </a:p>
         </p:txBody>
@@ -9316,7 +9316,7 @@
                 </a:solidFill>
                 <a:latin typeface="Segoe UI"/>
               </a:rPr>
-              <a:t>5. Security &amp; IAM Agent</a:t>
+              <a:t>5. Security &amp; Secrets Agent</a:t>
             </a:r>
           </a:p>
           <a:p>
@@ -9328,11 +9328,11 @@
             <a:r>
               <a:rPr sz="1100" b="0">
                 <a:solidFill>
-                  <a:srgbClr val="475569"/>
-                </a:solidFill>
-                <a:latin typeface="Segoe UI"/>
-              </a:rPr>
-              <a:t>• Detects accidental cloud credentials (AWS, GCP, Azure, DB passwords, JWT secrets).</a:t>
+                  <a:srgbClr val="334155"/>
+                </a:solidFill>
+                <a:latin typeface="Segoe UI"/>
+              </a:rPr>
+              <a:t>• Detects leaked AWS/GCP tokens, private keys, database passwords, and JWT keys.</a:t>
             </a:r>
           </a:p>
           <a:p>
@@ -9344,11 +9344,11 @@
             <a:r>
               <a:rPr sz="1100" b="0">
                 <a:solidFill>
-                  <a:srgbClr val="475569"/>
-                </a:solidFill>
-                <a:latin typeface="Segoe UI"/>
-              </a:rPr>
-              <a:t>• Identifies insecure CORS wildcard origins, SQL injection risk, and missing rate limiters.</a:t>
+                  <a:srgbClr val="334155"/>
+                </a:solidFill>
+                <a:latin typeface="Segoe UI"/>
+              </a:rPr>
+              <a:t>• Identifies insecure wildcard CORS origins, SQL injection hazards, and open endpoints.</a:t>
             </a:r>
           </a:p>
         </p:txBody>
@@ -9386,7 +9386,7 @@
             <a:avLst/>
           </a:prstGeom>
           <a:solidFill>
-            <a:srgbClr val="F8F9FA"/>
+            <a:srgbClr val="F8FAFC"/>
           </a:solidFill>
           <a:ln>
             <a:noFill/>
@@ -9423,7 +9423,7 @@
         <p:spPr>
           <a:xfrm>
             <a:off x="731520" y="411480"/>
-            <a:ext cx="3840480" cy="292608"/>
+            <a:ext cx="4023360" cy="292608"/>
           </a:xfrm>
           <a:prstGeom prst="roundRect">
             <a:avLst/>
@@ -9492,7 +9492,7 @@
             <a:r>
               <a:rPr sz="1100" b="1">
                 <a:solidFill>
-                  <a:srgbClr val="94A3B8"/>
+                  <a:srgbClr val="64748B"/>
                 </a:solidFill>
                 <a:latin typeface="Segoe UI"/>
               </a:rPr>
@@ -9535,7 +9535,7 @@
                 </a:solidFill>
                 <a:latin typeface="Segoe UI"/>
               </a:rPr>
-              <a:t>Eliminating AI Hallucinations: Adversarial Critic Agent</a:t>
+              <a:t>Zero Hallucinations: The Critic Reflection Engine</a:t>
             </a:r>
           </a:p>
           <a:p>
@@ -9547,11 +9547,11 @@
             <a:r>
               <a:rPr sz="1200" b="0">
                 <a:solidFill>
-                  <a:srgbClr val="475569"/>
-                </a:solidFill>
-                <a:latin typeface="Segoe UI"/>
-              </a:rPr>
-              <a:t>How DeploySafe achieves 100% evidence validity and 0.0% false positives on clean baselines.</a:t>
+                  <a:srgbClr val="334155"/>
+                </a:solidFill>
+                <a:latin typeface="Segoe UI"/>
+              </a:rPr>
+              <a:t>How DeploySafe achieves 100% evidence validity and 0.0% false positives on clean codebases.</a:t>
             </a:r>
           </a:p>
         </p:txBody>
@@ -9647,11 +9647,11 @@
             <a:r>
               <a:rPr sz="1100" b="0">
                 <a:solidFill>
-                  <a:srgbClr val="475569"/>
-                </a:solidFill>
-                <a:latin typeface="Segoe UI"/>
-              </a:rPr>
-              <a:t>Every finding emitted by an agent must survive strict physical inspection by the Critic Agent (critic_agent.py):</a:t>
+                  <a:srgbClr val="334155"/>
+                </a:solidFill>
+                <a:latin typeface="Segoe UI"/>
+              </a:rPr>
+              <a:t>Every finding must survive strict physical inspection before reaching developers:</a:t>
             </a:r>
           </a:p>
           <a:p>
@@ -9667,7 +9667,7 @@
                 </a:solidFill>
                 <a:latin typeface="Segoe UI"/>
               </a:rPr>
-              <a:t>1. File Existence: Does the file actually exist in the repository filesystem? If not -&gt; REJECT.</a:t>
+              <a:t>1. File Existence: Does the file really exist in the repository? If not -&gt; REJECT.</a:t>
             </a:r>
           </a:p>
           <a:p>
@@ -9683,7 +9683,7 @@
                 </a:solidFill>
                 <a:latin typeface="Segoe UI"/>
               </a:rPr>
-              <a:t>2. Line Number Bounds: Is the reported line number valid within 1 to Total File Lines? If out-of-bounds -&gt; REJECT.</a:t>
+              <a:t>2. Line Number Bounds: Is the reported line number valid on disk? If out of bounds -&gt; REJECT.</a:t>
             </a:r>
           </a:p>
           <a:p>
@@ -9699,7 +9699,7 @@
                 </a:solidFill>
                 <a:latin typeface="Segoe UI"/>
               </a:rPr>
-              <a:t>3. Literal Code Match: Does the provided code snippet exist in the physical file at that location? If mismatched -&gt; REJECT.</a:t>
+              <a:t>3. Literal Code Match: Does the code snippet match the physical text? If mismatch -&gt; REJECT.</a:t>
             </a:r>
           </a:p>
           <a:p>
@@ -9715,7 +9715,7 @@
                 </a:solidFill>
                 <a:latin typeface="Segoe UI"/>
               </a:rPr>
-              <a:t>4. Evidence Grounding: Is the finding a real deployment hazard or trivial style nitpick? If nitpick -&gt; REJECT.</a:t>
+              <a:t>4. Evidence Grounding: Is this a genuine deployment hazard or trivial style nit? If nit -&gt; REJECT.</a:t>
             </a:r>
           </a:p>
         </p:txBody>
@@ -9851,7 +9851,7 @@
                 </a:solidFill>
                 <a:latin typeface="Segoe UI"/>
               </a:rPr>
-              <a:t>Benchmark Results on Clean Baseline</a:t>
+              <a:t>Proven on Clean Benchmark Repository</a:t>
             </a:r>
           </a:p>
           <a:p>
@@ -9863,11 +9863,11 @@
             <a:r>
               <a:rPr sz="1100" b="0">
                 <a:solidFill>
-                  <a:srgbClr val="475569"/>
-                </a:solidFill>
-                <a:latin typeface="Segoe UI"/>
-              </a:rPr>
-              <a:t>• Unvalidated Candidate Findings: 3 findings generated by raw LLM prompts.</a:t>
+                  <a:srgbClr val="334155"/>
+                </a:solidFill>
+                <a:latin typeface="Segoe UI"/>
+              </a:rPr>
+              <a:t>• Unvalidated AI Candidates: 3 phantom findings generated by raw LLM prompts.</a:t>
             </a:r>
           </a:p>
           <a:p>
@@ -9883,7 +9883,7 @@
                 </a:solidFill>
                 <a:latin typeface="Segoe UI"/>
               </a:rPr>
-              <a:t>• Critic Filter Verdict: All 3 ungrounded findings dropped due to snippet mismatch.</a:t>
+              <a:t>• Critic Filter Verdict: All 3 dropped due to code mismatch.</a:t>
             </a:r>
           </a:p>
           <a:p>
@@ -9931,7 +9931,7 @@
                 </a:solidFill>
                 <a:latin typeface="Segoe UI"/>
               </a:rPr>
-              <a:t>Key Takeaway: The Critic reflection step is what transforms DeploySafe from an untrusted toy into a robust production-grade safety gate.</a:t>
+              <a:t>Key Takeaway: The Critic reflection step is what transforms DeploySafe from an untrusted toy into a trusted enterprise safety gate.</a:t>
             </a:r>
           </a:p>
         </p:txBody>
@@ -9969,7 +9969,7 @@
             <a:avLst/>
           </a:prstGeom>
           <a:solidFill>
-            <a:srgbClr val="F8F9FA"/>
+            <a:srgbClr val="F8FAFC"/>
           </a:solidFill>
           <a:ln>
             <a:noFill/>
@@ -10006,7 +10006,7 @@
         <p:spPr>
           <a:xfrm>
             <a:off x="731520" y="411480"/>
-            <a:ext cx="3840480" cy="292608"/>
+            <a:ext cx="4023360" cy="292608"/>
           </a:xfrm>
           <a:prstGeom prst="roundRect">
             <a:avLst/>
@@ -10075,7 +10075,7 @@
             <a:r>
               <a:rPr sz="1100" b="1">
                 <a:solidFill>
-                  <a:srgbClr val="94A3B8"/>
+                  <a:srgbClr val="64748B"/>
                 </a:solidFill>
                 <a:latin typeface="Segoe UI"/>
               </a:rPr>
@@ -10118,7 +10118,7 @@
                 </a:solidFill>
                 <a:latin typeface="Segoe UI"/>
               </a:rPr>
-              <a:t>Retrieval-Augmented Generation (RAG) Architecture</a:t>
+              <a:t>Repository Context: Vector RAG Knowledge Base</a:t>
             </a:r>
           </a:p>
           <a:p>
@@ -10130,11 +10130,11 @@
             <a:r>
               <a:rPr sz="1200" b="0">
                 <a:solidFill>
-                  <a:srgbClr val="475569"/>
-                </a:solidFill>
-                <a:latin typeface="Segoe UI"/>
-              </a:rPr>
-              <a:t>ChromaDB vector store providing repository-level architectural context to domain agents.</a:t>
+                  <a:srgbClr val="334155"/>
+                </a:solidFill>
+                <a:latin typeface="Segoe UI"/>
+              </a:rPr>
+              <a:t>ChromaDB vector store providing architectural context so AI never misinterprets intentional code.</a:t>
             </a:r>
           </a:p>
         </p:txBody>
@@ -10231,7 +10231,7 @@
                 </a:solidFill>
                 <a:latin typeface="Segoe UI"/>
               </a:rPr>
-              <a:t>INGESTION &amp; EMBED</a:t>
+              <a:t>KNOWLEDGE BASE</a:t>
             </a:r>
           </a:p>
         </p:txBody>
@@ -10270,7 +10270,7 @@
                 </a:solidFill>
                 <a:latin typeface="Segoe UI"/>
               </a:rPr>
-              <a:t>Document Chunking</a:t>
+              <a:t>Smart Document Ingestion</a:t>
             </a:r>
           </a:p>
           <a:p>
@@ -10282,11 +10282,11 @@
             <a:r>
               <a:rPr sz="1100" b="0">
                 <a:solidFill>
-                  <a:srgbClr val="475569"/>
-                </a:solidFill>
-                <a:latin typeface="Segoe UI"/>
-              </a:rPr>
-              <a:t>• Chunks READMEs, architecture guides, runbooks, and API specs.</a:t>
+                  <a:srgbClr val="334155"/>
+                </a:solidFill>
+                <a:latin typeface="Segoe UI"/>
+              </a:rPr>
+              <a:t>• Indexes READMEs, architecture docs, runbooks, and API specs.</a:t>
             </a:r>
           </a:p>
           <a:p>
@@ -10298,7 +10298,7 @@
             <a:r>
               <a:rPr sz="1100" b="0">
                 <a:solidFill>
-                  <a:srgbClr val="475569"/>
+                  <a:srgbClr val="334155"/>
                 </a:solidFill>
                 <a:latin typeface="Segoe UI"/>
               </a:rPr>
@@ -10314,11 +10314,11 @@
             <a:r>
               <a:rPr sz="1100" b="0">
                 <a:solidFill>
-                  <a:srgbClr val="475569"/>
-                </a:solidFill>
-                <a:latin typeface="Segoe UI"/>
-              </a:rPr>
-              <a:t>• Fallback: Local deterministic hashing embedding when API is offline.</a:t>
+                  <a:srgbClr val="334155"/>
+                </a:solidFill>
+                <a:latin typeface="Segoe UI"/>
+              </a:rPr>
+              <a:t>• Fallback: Local deterministic hashing when API is offline.</a:t>
             </a:r>
           </a:p>
         </p:txBody>
@@ -10415,7 +10415,7 @@
                 </a:solidFill>
                 <a:latin typeface="Segoe UI"/>
               </a:rPr>
-              <a:t>PERSISTENCE</a:t>
+              <a:t>FAST RETRIEVAL</a:t>
             </a:r>
           </a:p>
         </p:txBody>
@@ -10454,7 +10454,7 @@
                 </a:solidFill>
                 <a:latin typeface="Segoe UI"/>
               </a:rPr>
-              <a:t>ChromaDB Store</a:t>
+              <a:t>Isolated ChromaDB Store</a:t>
             </a:r>
           </a:p>
           <a:p>
@@ -10466,7 +10466,7 @@
             <a:r>
               <a:rPr sz="1100" b="0">
                 <a:solidFill>
-                  <a:srgbClr val="475569"/>
+                  <a:srgbClr val="334155"/>
                 </a:solidFill>
                 <a:latin typeface="Segoe UI"/>
               </a:rPr>
@@ -10482,11 +10482,11 @@
             <a:r>
               <a:rPr sz="1100" b="0">
                 <a:solidFill>
-                  <a:srgbClr val="475569"/>
-                </a:solidFill>
-                <a:latin typeface="Segoe UI"/>
-              </a:rPr>
-              <a:t>• Cosine similarity search with metadata filtering (file_path, type).</a:t>
+                  <a:srgbClr val="334155"/>
+                </a:solidFill>
+                <a:latin typeface="Segoe UI"/>
+              </a:rPr>
+              <a:t>• Cosine similarity search with metadata filtering.</a:t>
             </a:r>
           </a:p>
           <a:p>
@@ -10498,11 +10498,11 @@
             <a:r>
               <a:rPr sz="1100" b="0">
                 <a:solidFill>
-                  <a:srgbClr val="475569"/>
-                </a:solidFill>
-                <a:latin typeface="Segoe UI"/>
-              </a:rPr>
-              <a:t>• Query latency: &lt; 45ms per top-k retrieval.</a:t>
+                  <a:srgbClr val="334155"/>
+                </a:solidFill>
+                <a:latin typeface="Segoe UI"/>
+              </a:rPr>
+              <a:t>• Blazing fast retrieval: &lt; 45ms per query.</a:t>
             </a:r>
           </a:p>
         </p:txBody>
@@ -10599,7 +10599,7 @@
                 </a:solidFill>
                 <a:latin typeface="Segoe UI"/>
               </a:rPr>
-              <a:t>GROUNDING</a:t>
+              <a:t>ARCHITECTURAL FIT</a:t>
             </a:r>
           </a:p>
         </p:txBody>
@@ -10638,7 +10638,7 @@
                 </a:solidFill>
                 <a:latin typeface="Segoe UI"/>
               </a:rPr>
-              <a:t>Context Injection</a:t>
+              <a:t>Context-Aware Agents</a:t>
             </a:r>
           </a:p>
           <a:p>
@@ -10650,11 +10650,11 @@
             <a:r>
               <a:rPr sz="1100" b="0">
                 <a:solidFill>
-                  <a:srgbClr val="475569"/>
-                </a:solidFill>
-                <a:latin typeface="Segoe UI"/>
-              </a:rPr>
-              <a:t>• Agents receive architectural context before analyzing diffs.</a:t>
+                  <a:srgbClr val="334155"/>
+                </a:solidFill>
+                <a:latin typeface="Segoe UI"/>
+              </a:rPr>
+              <a:t>• Agents check architectural guidelines before flagging code.</a:t>
             </a:r>
           </a:p>
           <a:p>
@@ -10666,11 +10666,11 @@
             <a:r>
               <a:rPr sz="1100" b="0">
                 <a:solidFill>
-                  <a:srgbClr val="475569"/>
-                </a:solidFill>
-                <a:latin typeface="Segoe UI"/>
-              </a:rPr>
-              <a:t>• Example: Knowing that auth_service requires strict JWT validation according to docs/architecture.md.</a:t>
+                  <a:srgbClr val="334155"/>
+                </a:solidFill>
+                <a:latin typeface="Segoe UI"/>
+              </a:rPr>
+              <a:t>• Understands custom microservice conventions and project patterns.</a:t>
             </a:r>
           </a:p>
           <a:p>
@@ -10682,11 +10682,11 @@
             <a:r>
               <a:rPr sz="1100" b="0">
                 <a:solidFill>
-                  <a:srgbClr val="475569"/>
-                </a:solidFill>
-                <a:latin typeface="Segoe UI"/>
-              </a:rPr>
-              <a:t>• Prevents false positives where unconventional code is intentional per architecture.</a:t>
+                  <a:srgbClr val="334155"/>
+                </a:solidFill>
+                <a:latin typeface="Segoe UI"/>
+              </a:rPr>
+              <a:t>• Prevents false positives where unconventional code is intentional.</a:t>
             </a:r>
           </a:p>
         </p:txBody>
@@ -10724,7 +10724,7 @@
             <a:avLst/>
           </a:prstGeom>
           <a:solidFill>
-            <a:srgbClr val="F8F9FA"/>
+            <a:srgbClr val="F8FAFC"/>
           </a:solidFill>
           <a:ln>
             <a:noFill/>
@@ -10761,7 +10761,7 @@
         <p:spPr>
           <a:xfrm>
             <a:off x="731520" y="411480"/>
-            <a:ext cx="3840480" cy="292608"/>
+            <a:ext cx="4023360" cy="292608"/>
           </a:xfrm>
           <a:prstGeom prst="roundRect">
             <a:avLst/>
@@ -10830,7 +10830,7 @@
             <a:r>
               <a:rPr sz="1100" b="1">
                 <a:solidFill>
-                  <a:srgbClr val="94A3B8"/>
+                  <a:srgbClr val="64748B"/>
                 </a:solidFill>
                 <a:latin typeface="Segoe UI"/>
               </a:rPr>
@@ -10885,7 +10885,7 @@
             <a:r>
               <a:rPr sz="1200" b="0">
                 <a:solidFill>
-                  <a:srgbClr val="475569"/>
+                  <a:srgbClr val="334155"/>
                 </a:solidFill>
                 <a:latin typeface="Segoe UI"/>
               </a:rPr>
@@ -10985,7 +10985,7 @@
             <a:r>
               <a:rPr sz="1100" b="0">
                 <a:solidFill>
-                  <a:srgbClr val="475569"/>
+                  <a:srgbClr val="334155"/>
                 </a:solidFill>
                 <a:latin typeface="Segoe UI"/>
               </a:rPr>
@@ -11009,7 +11009,7 @@
             <a:avLst/>
           </a:prstGeom>
           <a:solidFill>
-            <a:srgbClr val="F8FAFC"/>
+            <a:srgbClr val="F1F5F9"/>
           </a:solidFill>
           <a:ln w="12700">
             <a:solidFill>
@@ -11117,7 +11117,7 @@
             <a:r>
               <a:rPr sz="1100" b="0">
                 <a:solidFill>
-                  <a:srgbClr val="475569"/>
+                  <a:srgbClr val="334155"/>
                 </a:solidFill>
                 <a:latin typeface="Consolas"/>
               </a:rPr>
@@ -11133,7 +11133,7 @@
             <a:r>
               <a:rPr sz="1100" b="0">
                 <a:solidFill>
-                  <a:srgbClr val="475569"/>
+                  <a:srgbClr val="334155"/>
                 </a:solidFill>
                 <a:latin typeface="Consolas"/>
               </a:rPr>
@@ -11172,7 +11172,7 @@
             <a:r>
               <a:rPr sz="1100" b="0">
                 <a:solidFill>
-                  <a:srgbClr val="475569"/>
+                  <a:srgbClr val="334155"/>
                 </a:solidFill>
                 <a:latin typeface="Segoe UI"/>
               </a:rPr>
@@ -11356,7 +11356,7 @@
             <a:r>
               <a:rPr sz="1000" b="0">
                 <a:solidFill>
-                  <a:srgbClr val="475569"/>
+                  <a:srgbClr val="334155"/>
                 </a:solidFill>
                 <a:latin typeface="Segoe UI"/>
               </a:rPr>
@@ -11456,7 +11456,7 @@
             <a:r>
               <a:rPr sz="1000" b="0">
                 <a:solidFill>
-                  <a:srgbClr val="475569"/>
+                  <a:srgbClr val="334155"/>
                 </a:solidFill>
                 <a:latin typeface="Segoe UI"/>
               </a:rPr>
@@ -11556,7 +11556,7 @@
             <a:r>
               <a:rPr sz="1000" b="0">
                 <a:solidFill>
-                  <a:srgbClr val="475569"/>
+                  <a:srgbClr val="334155"/>
                 </a:solidFill>
                 <a:latin typeface="Segoe UI"/>
               </a:rPr>
@@ -11598,7 +11598,7 @@
             <a:avLst/>
           </a:prstGeom>
           <a:solidFill>
-            <a:srgbClr val="F8F9FA"/>
+            <a:srgbClr val="F8FAFC"/>
           </a:solidFill>
           <a:ln>
             <a:noFill/>
@@ -11635,7 +11635,7 @@
         <p:spPr>
           <a:xfrm>
             <a:off x="731520" y="411480"/>
-            <a:ext cx="3840480" cy="292608"/>
+            <a:ext cx="4023360" cy="292608"/>
           </a:xfrm>
           <a:prstGeom prst="roundRect">
             <a:avLst/>
@@ -11704,7 +11704,7 @@
             <a:r>
               <a:rPr sz="1100" b="1">
                 <a:solidFill>
-                  <a:srgbClr val="94A3B8"/>
+                  <a:srgbClr val="64748B"/>
                 </a:solidFill>
                 <a:latin typeface="Segoe UI"/>
               </a:rPr>
@@ -11759,7 +11759,7 @@
             <a:r>
               <a:rPr sz="1200" b="0">
                 <a:solidFill>
-                  <a:srgbClr val="475569"/>
+                  <a:srgbClr val="334155"/>
                 </a:solidFill>
                 <a:latin typeface="Segoe UI"/>
               </a:rPr>
@@ -11911,11 +11911,11 @@
             <a:r>
               <a:rPr sz="1000" b="0">
                 <a:solidFill>
-                  <a:srgbClr val="475569"/>
-                </a:solidFill>
-                <a:latin typeface="Segoe UI"/>
-              </a:rPr>
-              <a:t>• Version-controlled repository rules</a:t>
+                  <a:srgbClr val="334155"/>
+                </a:solidFill>
+                <a:latin typeface="Segoe UI"/>
+              </a:rPr>
+              <a:t>• Version-controlled repo rules</a:t>
             </a:r>
           </a:p>
           <a:p>
@@ -11927,7 +11927,7 @@
             <a:r>
               <a:rPr sz="1000" b="0">
                 <a:solidFill>
-                  <a:srgbClr val="475569"/>
+                  <a:srgbClr val="334155"/>
                 </a:solidFill>
                 <a:latin typeface="Segoe UI"/>
               </a:rPr>
@@ -11943,7 +11943,7 @@
             <a:r>
               <a:rPr sz="1000" b="0">
                 <a:solidFill>
-                  <a:srgbClr val="475569"/>
+                  <a:srgbClr val="334155"/>
                 </a:solidFill>
                 <a:latin typeface="Segoe UI"/>
               </a:rPr>
@@ -12111,7 +12111,7 @@
             <a:r>
               <a:rPr sz="1000" b="0">
                 <a:solidFill>
-                  <a:srgbClr val="475569"/>
+                  <a:srgbClr val="334155"/>
                 </a:solidFill>
                 <a:latin typeface="Segoe UI"/>
               </a:rPr>
@@ -12127,7 +12127,7 @@
             <a:r>
               <a:rPr sz="1000" b="0">
                 <a:solidFill>
-                  <a:srgbClr val="475569"/>
+                  <a:srgbClr val="334155"/>
                 </a:solidFill>
                 <a:latin typeface="Segoe UI"/>
               </a:rPr>
@@ -12143,7 +12143,7 @@
             <a:r>
               <a:rPr sz="1000" b="0">
                 <a:solidFill>
-                  <a:srgbClr val="475569"/>
+                  <a:srgbClr val="334155"/>
                 </a:solidFill>
                 <a:latin typeface="Segoe UI"/>
               </a:rPr>
@@ -12311,7 +12311,7 @@
             <a:r>
               <a:rPr sz="1000" b="0">
                 <a:solidFill>
-                  <a:srgbClr val="475569"/>
+                  <a:srgbClr val="334155"/>
                 </a:solidFill>
                 <a:latin typeface="Segoe UI"/>
               </a:rPr>
@@ -12327,7 +12327,7 @@
             <a:r>
               <a:rPr sz="1000" b="0">
                 <a:solidFill>
-                  <a:srgbClr val="475569"/>
+                  <a:srgbClr val="334155"/>
                 </a:solidFill>
                 <a:latin typeface="Segoe UI"/>
               </a:rPr>
@@ -12343,7 +12343,7 @@
             <a:r>
               <a:rPr sz="1000" b="0">
                 <a:solidFill>
-                  <a:srgbClr val="475569"/>
+                  <a:srgbClr val="334155"/>
                 </a:solidFill>
                 <a:latin typeface="Segoe UI"/>
               </a:rPr>
@@ -12359,7 +12359,7 @@
             <a:r>
               <a:rPr sz="1000" b="0">
                 <a:solidFill>
-                  <a:srgbClr val="475569"/>
+                  <a:srgbClr val="334155"/>
                 </a:solidFill>
                 <a:latin typeface="Segoe UI"/>
               </a:rPr>
@@ -12511,7 +12511,7 @@
             <a:r>
               <a:rPr sz="1000" b="0">
                 <a:solidFill>
-                  <a:srgbClr val="475569"/>
+                  <a:srgbClr val="334155"/>
                 </a:solidFill>
                 <a:latin typeface="Segoe UI"/>
               </a:rPr>
@@ -12527,7 +12527,7 @@
             <a:r>
               <a:rPr sz="1000" b="0">
                 <a:solidFill>
-                  <a:srgbClr val="475569"/>
+                  <a:srgbClr val="334155"/>
                 </a:solidFill>
                 <a:latin typeface="Segoe UI"/>
               </a:rPr>
@@ -12559,7 +12559,7 @@
             <a:r>
               <a:rPr sz="1000" b="0">
                 <a:solidFill>
-                  <a:srgbClr val="475569"/>
+                  <a:srgbClr val="334155"/>
                 </a:solidFill>
                 <a:latin typeface="Segoe UI"/>
               </a:rPr>
@@ -12601,7 +12601,7 @@
             <a:avLst/>
           </a:prstGeom>
           <a:solidFill>
-            <a:srgbClr val="F8F9FA"/>
+            <a:srgbClr val="F8FAFC"/>
           </a:solidFill>
           <a:ln>
             <a:noFill/>
@@ -12638,7 +12638,7 @@
         <p:spPr>
           <a:xfrm>
             <a:off x="731520" y="411480"/>
-            <a:ext cx="3840480" cy="292608"/>
+            <a:ext cx="4023360" cy="292608"/>
           </a:xfrm>
           <a:prstGeom prst="roundRect">
             <a:avLst/>
@@ -12707,7 +12707,7 @@
             <a:r>
               <a:rPr sz="1100" b="1">
                 <a:solidFill>
-                  <a:srgbClr val="94A3B8"/>
+                  <a:srgbClr val="64748B"/>
                 </a:solidFill>
                 <a:latin typeface="Segoe UI"/>
               </a:rPr>
@@ -12762,7 +12762,7 @@
             <a:r>
               <a:rPr sz="1200" b="0">
                 <a:solidFill>
-                  <a:srgbClr val="475569"/>
+                  <a:srgbClr val="334155"/>
                 </a:solidFill>
                 <a:latin typeface="Segoe UI"/>
               </a:rPr>
@@ -12862,7 +12862,7 @@
             <a:r>
               <a:rPr sz="1100" b="0">
                 <a:solidFill>
-                  <a:srgbClr val="475569"/>
+                  <a:srgbClr val="334155"/>
                 </a:solidFill>
                 <a:latin typeface="Segoe UI"/>
               </a:rPr>
@@ -12882,7 +12882,7 @@
                 </a:solidFill>
                 <a:latin typeface="Segoe UI"/>
               </a:rPr>
-              <a:t>• Supply Chain Vulnerability: Malicious pull requests or prompt injections could trick agents into injecting backdoors.</a:t>
+              <a:t>• Supply Chain Risk: Malicious pull requests or prompt injections could trick agents into injecting backdoors.</a:t>
             </a:r>
           </a:p>
           <a:p>
@@ -12894,11 +12894,11 @@
             <a:r>
               <a:rPr sz="1100" b="0">
                 <a:solidFill>
-                  <a:srgbClr val="475569"/>
-                </a:solidFill>
-                <a:latin typeface="Segoe UI"/>
-              </a:rPr>
-              <a:t>• Semantic Regressions: AI fixes may resolve a lint or type error but subtly break runtime business logic.</a:t>
+                  <a:srgbClr val="334155"/>
+                </a:solidFill>
+                <a:latin typeface="Segoe UI"/>
+              </a:rPr>
+              <a:t>• Semantic Regressions: AI fixes may resolve a lint error but subtly break runtime business logic.</a:t>
             </a:r>
           </a:p>
           <a:p>
@@ -12910,11 +12910,11 @@
             <a:r>
               <a:rPr sz="1100" b="0">
                 <a:solidFill>
-                  <a:srgbClr val="475569"/>
-                </a:solidFill>
-                <a:latin typeface="Segoe UI"/>
-              </a:rPr>
-              <a:t>• Developer Disempowerment: Engineers must retain ownership and accountability over all code pushed to production.</a:t>
+                  <a:srgbClr val="334155"/>
+                </a:solidFill>
+                <a:latin typeface="Segoe UI"/>
+              </a:rPr>
+              <a:t>• Developer Ownership: Human engineers must always retain ultimate accountability over all code pushed to production.</a:t>
             </a:r>
           </a:p>
         </p:txBody>
@@ -13062,7 +13062,7 @@
             <a:r>
               <a:rPr sz="1100" b="0">
                 <a:solidFill>
-                  <a:srgbClr val="475569"/>
+                  <a:srgbClr val="334155"/>
                 </a:solidFill>
                 <a:latin typeface="Segoe UI"/>
               </a:rPr>
@@ -13078,7 +13078,7 @@
             <a:r>
               <a:rPr sz="1100" b="0">
                 <a:solidFill>
-                  <a:srgbClr val="475569"/>
+                  <a:srgbClr val="334155"/>
                 </a:solidFill>
                 <a:latin typeface="Segoe UI"/>
               </a:rPr>

</xml_diff>